<commit_message>
Debias Case Study 1; executive decks for both case studies
Case Study 1: remove CS2 gravity — Transform (not Autonomize), vendor
consolidation as optional pack only, commercial thought-process framing,
full forms throughout. Rebuild PPTX/PDF with detailed speaker notes.

Case Study 2: executive glossary on brief, full-form titles, new 10-min
executive PPTX/PDF with glossary-rich notes for lived AO storyline.

Co-authored-by: gauravch86 <gauravch86@users.noreply.github.com>
</commit_message>
<xml_diff>
--- a/case-study-1-reposition-executive.pptx
+++ b/case-study-1-reposition-executive.pptx
@@ -6,11 +6,11 @@
   </p:sldMasterIdLst>
   <p:sldIdLst>
     <p:sldId id="256" r:id="rId7"/>
-    <p:sldId id="257" r:id="rId8"/>
-    <p:sldId id="258" r:id="rId9"/>
-    <p:sldId id="259" r:id="rId10"/>
-    <p:sldId id="260" r:id="rId11"/>
-    <p:sldId id="261" r:id="rId12"/>
+    <p:sldId id="257" r:id="rId9"/>
+    <p:sldId id="258" r:id="rId10"/>
+    <p:sldId id="259" r:id="rId11"/>
+    <p:sldId id="260" r:id="rId12"/>
+    <p:sldId id="261" r:id="rId13"/>
   </p:sldIdLst>
   <p:sldSz cx="12191695" cy="6858000" type="screen4x3"/>
   <p:notesSz cx="6858000" cy="9144000"/>
@@ -507,22 +507,62 @@
           <a:lstStyle/>
           <a:p>
             <a:r>
-              <a:t>TIMING ~1:30</a:t>
-            </a:r>
-          </a:p>
-          <a:p>
-            <a:r>
-              <a:t>Open with the paradox: strong NPS, flat sales, margin down — so this is a commercial problem, not a delivery turnaround.</a:t>
-            </a:r>
-          </a:p>
-          <a:p>
-            <a:r>
-              <a:t>State hypothesis: sold as FTEs; market buys outcomes/TCO/autonomy.</a:t>
-            </a:r>
-          </a:p>
-          <a:p>
-            <a:r>
-              <a:t>Preview the 5-step agenda. Mention H3G/TEF as proof anchors only — detail later.</a:t>
+              <a:t>TIMING: ~1 minute 30 seconds</a:t>
+            </a:r>
+          </a:p>
+          <a:p/>
+          <a:p>
+            <a:r>
+              <a:t>WHAT TO SAY:</a:t>
+            </a:r>
+          </a:p>
+          <a:p>
+            <a:r>
+              <a:t>Open with the paradox: delivery Net Promoter Score / customer satisfaction is strong, yet net sales are flat and gross margin is down four to six points. That means this is NOT a delivery crisis — it is a commercial and go-to-market failure.</a:t>
+            </a:r>
+          </a:p>
+          <a:p/>
+          <a:p>
+            <a:r>
+              <a:t>Define the offering once: Application Managed Services — application support sold today as staffing (people and hours).</a:t>
+            </a:r>
+          </a:p>
+          <a:p/>
+          <a:p>
+            <a:r>
+              <a:t>State the executive framing: buyers purchase outcomes, cost predictability, and risk reduction; we sell headcount. Leadership asked us to choose evolve, reposition, or sunset. Walk the agenda.</a:t>
+            </a:r>
+          </a:p>
+          <a:p/>
+          <a:p>
+            <a:r>
+              <a:t>GLOSSARY (if asked):</a:t>
+            </a:r>
+          </a:p>
+          <a:p>
+            <a:r>
+              <a:t>• Net sales = booked revenue after discounts, before cost</a:t>
+            </a:r>
+          </a:p>
+          <a:p>
+            <a:r>
+              <a:t>• Gross margin = net sales minus direct delivery cost (points = percentage points)</a:t>
+            </a:r>
+          </a:p>
+          <a:p>
+            <a:r>
+              <a:t>• Deal Desk = the commercial approval function that reviews discounts, terms, and exceptions</a:t>
+            </a:r>
+          </a:p>
+          <a:p>
+            <a:r>
+              <a:t>• Attach = selling additional modules or higher tiers onto an existing deal or renewal</a:t>
+            </a:r>
+          </a:p>
+          <a:p/>
+          <a:p>
+            <a:r>
+              <a:t>DO NOT: dive into technology, automation, or vendor consolidation on slide 1 — stay commercial.</a:t>
             </a:r>
           </a:p>
         </p:txBody>
@@ -592,27 +632,62 @@
           <a:lstStyle/>
           <a:p>
             <a:r>
-              <a:t>TIMING ~2:00</a:t>
-            </a:r>
-          </a:p>
-          <a:p>
-            <a:r>
-              <a:t>Five diagnostic lenses in ~4 weeks before any portfolio call.</a:t>
-            </a:r>
-          </a:p>
-          <a:p>
-            <a:r>
-              <a:t>Root causes: commoditized packaging, pricing chaos, value story gap.</a:t>
-            </a:r>
-          </a:p>
-          <a:p>
-            <a:r>
-              <a:t>Decision: Reposition — sunset destroys footprint; evolve-only won't fix sales/margin.</a:t>
-            </a:r>
-          </a:p>
-          <a:p>
-            <a:r>
-              <a:t>Outcome-Tiered Application Ops: Stabilize → Optimize → Autonomize.</a:t>
+              <a:t>TIMING: ~2 minutes</a:t>
+            </a:r>
+          </a:p>
+          <a:p/>
+          <a:p>
+            <a:r>
+              <a:t>WHAT TO SAY:</a:t>
+            </a:r>
+          </a:p>
+          <a:p>
+            <a:r>
+              <a:t>Before any portfolio decision, run a four-week diagnostic across five lenses. Decision triggers matter: if losses are “value unclear,” positioning is broken; if margin erosion is mostly discount, guardrails are broken.</a:t>
+            </a:r>
+          </a:p>
+          <a:p/>
+          <a:p>
+            <a:r>
+              <a:t>Name three root causes — packaging, pricing chaos, value story — all commercial.</a:t>
+            </a:r>
+          </a:p>
+          <a:p/>
+          <a:p>
+            <a:r>
+              <a:t>Decision matrix: Sunset destroys footprint. Evolve-only (tooling without changing the sellable unit) will not fix Sales or Deal Desk. Recommendation is REPOSITION to Outcome-Tiered Application Operations: Stabilize → Optimize → Transform.</a:t>
+            </a:r>
+          </a:p>
+          <a:p/>
+          <a:p>
+            <a:r>
+              <a:t>GLOSSARY:</a:t>
+            </a:r>
+          </a:p>
+          <a:p>
+            <a:r>
+              <a:t>• Sellable unit = what appears on the customer proposal (tier + packs), not internal staffing plan</a:t>
+            </a:r>
+          </a:p>
+          <a:p>
+            <a:r>
+              <a:t>• Knowledge transfer = paid transition from incumbent / customer teams into our operating model</a:t>
+            </a:r>
+          </a:p>
+          <a:p>
+            <a:r>
+              <a:t>• Systems integrator = competitor selling labour-led application support</a:t>
+            </a:r>
+          </a:p>
+          <a:p>
+            <a:r>
+              <a:t>• Transform tier = operating-model uplift (automation share, fewer fire drills, executive scorecard) — NOT a mandatory “autonomy product” dependency</a:t>
+            </a:r>
+          </a:p>
+          <a:p/>
+          <a:p>
+            <a:r>
+              <a:t>TRADE-OFF TO VOLUNTEER: near-term average deal size may dip; attach and renewal step-up recover value while margin quality improves.</a:t>
             </a:r>
           </a:p>
         </p:txBody>
@@ -682,22 +757,82 @@
           <a:lstStyle/>
           <a:p>
             <a:r>
-              <a:t>TIMING ~2:00</a:t>
-            </a:r>
-          </a:p>
-          <a:p>
-            <a:r>
-              <a:t>Don't walk every bullet — land the shift: tiers not towers; customer buys CPI class.</a:t>
-            </a:r>
-          </a:p>
-          <a:p>
-            <a:r>
-              <a:t>Stabilize = land; Optimize = prove TCO; Autonomize = path to AO (Case Study 2).</a:t>
-            </a:r>
-          </a:p>
-          <a:p>
-            <a:r>
-              <a:t>Attach packs are priced (esp. mandatory KT) — kills Y1 margin bleed.</a:t>
+              <a:t>TIMING: ~2 minutes</a:t>
+            </a:r>
+          </a:p>
+          <a:p/>
+          <a:p>
+            <a:r>
+              <a:t>WHAT TO SAY:</a:t>
+            </a:r>
+          </a:p>
+          <a:p>
+            <a:r>
+              <a:t>The customer-facing product is a tier, not a headcount pyramid. Staffing remains an internal delivery plan.</a:t>
+            </a:r>
+          </a:p>
+          <a:p/>
+          <a:p>
+            <a:r>
+              <a:t>Walk Stabilize → Optimize → Transform as a commercial ladder Sales can land and expand.</a:t>
+            </a:r>
+          </a:p>
+          <a:p>
+            <a:r>
+              <a:t>• Stabilize: stop the bleeding — backlog, service levels, single accountability</a:t>
+            </a:r>
+          </a:p>
+          <a:p>
+            <a:r>
+              <a:t>• Optimize: prove efficiency against contracted service levels</a:t>
+            </a:r>
+          </a:p>
+          <a:p>
+            <a:r>
+              <a:t>• Transform: operating-model uplift with milestone reviews — Finance must approve revenue recognition before proposal</a:t>
+            </a:r>
+          </a:p>
+          <a:p/>
+          <a:p>
+            <a:r>
+              <a:t>Stress: transition / knowledge-transfer is MANDATORY and priced — underpriced transition is the leading Year-1 margin killer.</a:t>
+            </a:r>
+          </a:p>
+          <a:p/>
+          <a:p>
+            <a:r>
+              <a:t>On multi-vendor consolidation: say clearly — “That is an optional pack when win/loss shows buyers consolidating suppliers. It is not required for this reposition. We do not need consolidation to justify tiers.”</a:t>
+            </a:r>
+          </a:p>
+          <a:p/>
+          <a:p>
+            <a:r>
+              <a:t>GLOSSARY:</a:t>
+            </a:r>
+          </a:p>
+          <a:p>
+            <a:r>
+              <a:t>• Platform fee = recurring base charge for the operating model / tooling baseline</a:t>
+            </a:r>
+          </a:p>
+          <a:p>
+            <a:r>
+              <a:t>• Criticality class = how business-critical the application is (drives unit price)</a:t>
+            </a:r>
+          </a:p>
+          <a:p>
+            <a:r>
+              <a:t>• Outcome-band pricing = price tied to service-level bands (availability, restore time), not hours</a:t>
+            </a:r>
+          </a:p>
+          <a:p>
+            <a:r>
+              <a:t>• Gain-share = optional commercial where we share proven customer cost reduction</a:t>
+            </a:r>
+          </a:p>
+          <a:p>
+            <a:r>
+              <a:t>• Total cost of ownership = customer’s full run cost including governance and failure cost, not only our invoice</a:t>
             </a:r>
           </a:p>
         </p:txBody>
@@ -767,22 +902,76 @@
           <a:lstStyle/>
           <a:p>
             <a:r>
-              <a:t>TIMING ~2:00</a:t>
-            </a:r>
-          </a:p>
-          <a:p>
-            <a:r>
-              <a:t>Guardrails = Deal Desk as architect, not discount gate. Hit floor GM and transition pricing hard.</a:t>
-            </a:r>
-          </a:p>
-          <a:p>
-            <a:r>
-              <a:t>Sequence: commercial assets Q1 (immediate bleed stop), delivery reuse Q2–Q4, AO merge Y2.</a:t>
-            </a:r>
-          </a:p>
-          <a:p>
-            <a:r>
-              <a:t>Name what you stop — shows product discipline.</a:t>
+              <a:t>TIMING: ~2 minutes</a:t>
+            </a:r>
+          </a:p>
+          <a:p/>
+          <a:p>
+            <a:r>
+              <a:t>WHAT TO SAY:</a:t>
+            </a:r>
+          </a:p>
+          <a:p>
+            <a:r>
+              <a:t>Guardrails turn Deal Desk into a deal architect: discounts are traded for scope, term, or tier step-up — not given away.</a:t>
+            </a:r>
+          </a:p>
+          <a:p/>
+          <a:p>
+            <a:r>
+              <a:t>Hit three hard rules interviewers will probe:</a:t>
+            </a:r>
+          </a:p>
+          <a:p>
+            <a:r>
+              <a:t>1) Floor gross margin by tier</a:t>
+            </a:r>
+          </a:p>
+          <a:p>
+            <a:r>
+              <a:t>2) Mandatory priced knowledge-transfer (minimum 8% of Year-1 annual contract value)</a:t>
+            </a:r>
+          </a:p>
+          <a:p>
+            <a:r>
+              <a:t>3) Regional variance capped at ±15% versus global rate card</a:t>
+            </a:r>
+          </a:p>
+          <a:p/>
+          <a:p>
+            <a:r>
+              <a:t>Investment sequence shows product discipline: commercial assets first (they unblock Sales this quarter), then delivery standards, then harvest. Explicit stop list proves you will not fund vanity work.</a:t>
+            </a:r>
+          </a:p>
+          <a:p/>
+          <a:p>
+            <a:r>
+              <a:t>GLOSSARY:</a:t>
+            </a:r>
+          </a:p>
+          <a:p>
+            <a:r>
+              <a:t>• Annual contract value = expected revenue for one contract year</a:t>
+            </a:r>
+          </a:p>
+          <a:p>
+            <a:r>
+              <a:t>• Soft-ramp = reduced service-credit exposure in early months while the operating model stabilizes</a:t>
+            </a:r>
+          </a:p>
+          <a:p>
+            <a:r>
+              <a:t>• Revenue recognition = Finance rules for when revenue can be booked (critical for milestone / credit elements)</a:t>
+            </a:r>
+          </a:p>
+          <a:p>
+            <a:r>
+              <a:t>• Rate card = approved global list prices and regional index bands</a:t>
+            </a:r>
+          </a:p>
+          <a:p>
+            <a:r>
+              <a:t>• Q1 / Q2 = calendar or fiscal quarters one and two of the program</a:t>
             </a:r>
           </a:p>
         </p:txBody>
@@ -852,22 +1041,71 @@
           <a:lstStyle/>
           <a:p>
             <a:r>
-              <a:t>TIMING ~1:30</a:t>
-            </a:r>
-          </a:p>
-          <a:p>
-            <a:r>
-              <a:t>Four functions, one program — SPM chairs monthly steering.</a:t>
-            </a:r>
-          </a:p>
-          <a:p>
-            <a:r>
-              <a:t>Scoreboard: +8–12% sales, +3–4 pts GM, 80% tier adoption.</a:t>
-            </a:r>
-          </a:p>
-          <a:p>
-            <a:r>
-              <a:t>Feedback: monthly field signals → quarterly pricing council → annual sunset re-test.</a:t>
+              <a:t>TIMING: ~1 minute 30 seconds</a:t>
+            </a:r>
+          </a:p>
+          <a:p/>
+          <a:p>
+            <a:r>
+              <a:t>WHAT TO SAY:</a:t>
+            </a:r>
+          </a:p>
+          <a:p>
+            <a:r>
+              <a:t>Repositioning is a portfolio program. Name owners:</a:t>
+            </a:r>
+          </a:p>
+          <a:p>
+            <a:r>
+              <a:t>• Sales / Deal Desk — adoption of the sellable unit</a:t>
+            </a:r>
+          </a:p>
+          <a:p>
+            <a:r>
+              <a:t>• Marketing — one narrative; kill staffing-tower language</a:t>
+            </a:r>
+          </a:p>
+          <a:p>
+            <a:r>
+              <a:t>• Finance — revenue recognition and gross-margin floors before any creative commercial construct</a:t>
+            </a:r>
+          </a:p>
+          <a:p>
+            <a:r>
+              <a:t>• Regions / Delivery — pilots prove the catalogue is deliverable</a:t>
+            </a:r>
+          </a:p>
+          <a:p/>
+          <a:p>
+            <a:r>
+              <a:t>Scoreboard is how leadership knows it worked: sales growth, margin recovery, tier adoption, price consistency, win reasons, renewal step-up — without trading away delivery satisfaction.</a:t>
+            </a:r>
+          </a:p>
+          <a:p/>
+          <a:p>
+            <a:r>
+              <a:t>Pricing Council is the continuous refinement mechanism the brief asks for.</a:t>
+            </a:r>
+          </a:p>
+          <a:p/>
+          <a:p>
+            <a:r>
+              <a:t>GLOSSARY:</a:t>
+            </a:r>
+          </a:p>
+          <a:p>
+            <a:r>
+              <a:t>• Pricing Council = quarterly forum (Product, Sales, Finance, regions) that adjusts rate card and packs from field evidence</a:t>
+            </a:r>
+          </a:p>
+          <a:p>
+            <a:r>
+              <a:t>• Renewal step-up = moving a live account from Stabilize to Optimize/Transform at renewal</a:t>
+            </a:r>
+          </a:p>
+          <a:p>
+            <a:r>
+              <a:t>• Change request = formal scope change; unpaid change requests are a hidden margin leak</a:t>
             </a:r>
           </a:p>
         </p:txBody>
@@ -937,17 +1175,60 @@
           <a:lstStyle/>
           <a:p>
             <a:r>
-              <a:t>TIMING ~1:00 then hand to Q&amp;A</a:t>
-            </a:r>
-          </a:p>
-          <a:p>
-            <a:r>
-              <a:t>Restate the call in one breath. Proof: H3G packaging, TEF reposition.</a:t>
-            </a:r>
-          </a:p>
-          <a:p>
-            <a:r>
-              <a:t>Four asks. Open Q&amp;A (5 min). Point to HTML case study for depth.</a:t>
+              <a:t>TIMING: ~1 minute, then hand to questions (5 minutes)</a:t>
+            </a:r>
+          </a:p>
+          <a:p/>
+          <a:p>
+            <a:r>
+              <a:t>WHAT TO SAY:</a:t>
+            </a:r>
+          </a:p>
+          <a:p>
+            <a:r>
+              <a:t>Restate the call in one breath. Emphasize thought process: evidence → separate delivery from commercial → decide with trade-offs → fund Sales motion before tooling → optional strategies only when data supports them.</a:t>
+            </a:r>
+          </a:p>
+          <a:p/>
+          <a:p>
+            <a:r>
+              <a:t>Close with four concrete asks. Then: “Happy to go deep on any lens, guardrail, or pilot design.”</a:t>
+            </a:r>
+          </a:p>
+          <a:p/>
+          <a:p>
+            <a:r>
+              <a:t>LIKELY QUESTIONS AND SHORT ANSWERS:</a:t>
+            </a:r>
+          </a:p>
+          <a:p>
+            <a:r>
+              <a:t>• Why not sunset? Delivery asset + footprint; 18-month margin path exists via reposition.</a:t>
+            </a:r>
+          </a:p>
+          <a:p>
+            <a:r>
+              <a:t>• Won’t smaller tiers cut revenue? Near term maybe; attach + renewal step-up + better margin quality.</a:t>
+            </a:r>
+          </a:p>
+          <a:p>
+            <a:r>
+              <a:t>• How fast on rate card? Quarter 1 mandate; two pilots before forced global cutover.</a:t>
+            </a:r>
+          </a:p>
+          <a:p>
+            <a:r>
+              <a:t>• Finance concern on outcome pricing? Platform fee first; milestone / credit elements only with revenue-recognition memo.</a:t>
+            </a:r>
+          </a:p>
+          <a:p>
+            <a:r>
+              <a:t>• Is vendor consolidation required? No — optional pack when win/loss shows consolidation demand.</a:t>
+            </a:r>
+          </a:p>
+          <a:p>
+            <a:r>
+              <a:t>• How is this different from your lived delivery experience? This case is a portfolio commercial problem — packaging, pricing governance, and Sales enablement — solved with product-management discipline, not an operating-model rebuild.</a:t>
             </a:r>
           </a:p>
         </p:txBody>
@@ -4013,41 +4294,77 @@
           <a:noFill/>
         </p:spPr>
         <p:txBody>
+          <a:bodyPr wrap="none">
+            <a:spAutoFit/>
+          </a:bodyPr>
+          <a:lstStyle/>
+          <a:p>
+            <a:pPr algn="l">
+              <a:spcAft>
+                <a:spcPts val="0"/>
+              </a:spcAft>
+            </a:pPr>
+            <a:r>
+              <a:rPr sz="1100" b="1">
+                <a:solidFill>
+                  <a:srgbClr val="58A6FF"/>
+                </a:solidFill>
+                <a:latin typeface="Calibri"/>
+              </a:rPr>
+              <a:t>STRATEGIC PRODUCT MANAGER  ·  CASE STUDY 1  ·  10-MINUTE COMMERCIAL BRIEF</a:t>
+            </a:r>
+          </a:p>
+        </p:txBody>
+      </p:sp>
+      <p:sp>
+        <p:nvSpPr>
+          <p:cNvPr id="4" name="TextBox 3"/>
+          <p:cNvSpPr txBox="1"/>
+          <p:nvPr/>
+        </p:nvSpPr>
+        <p:spPr>
+          <a:xfrm>
+            <a:off x="502920" y="475488"/>
+            <a:ext cx="11155680" cy="640080"/>
+          </a:xfrm>
+          <a:prstGeom prst="rect">
+            <a:avLst/>
+          </a:prstGeom>
+          <a:noFill/>
+        </p:spPr>
+        <p:txBody>
           <a:bodyPr wrap="square">
             <a:spAutoFit/>
           </a:bodyPr>
           <a:lstStyle/>
           <a:p>
             <a:pPr algn="l">
-              <a:spcBef>
+              <a:spcAft>
                 <a:spcPts val="0"/>
-              </a:spcBef>
-              <a:spcAft>
-                <a:spcPts val="0"/>
-              </a:spcAft>
-            </a:pPr>
-            <a:r>
-              <a:rPr sz="1100" b="1">
-                <a:solidFill>
-                  <a:srgbClr val="58A6FF"/>
-                </a:solidFill>
-                <a:latin typeface="Calibri"/>
-              </a:rPr>
-              <a:t>STRATEGIC PRODUCT MANAGER  ·  CASE STUDY 1  ·  10-MIN BRIEF</a:t>
-            </a:r>
-          </a:p>
-        </p:txBody>
-      </p:sp>
-      <p:sp>
-        <p:nvSpPr>
-          <p:cNvPr id="4" name="TextBox 3"/>
+              </a:spcAft>
+            </a:pPr>
+            <a:r>
+              <a:rPr sz="2600" b="1">
+                <a:solidFill>
+                  <a:srgbClr val="D4A853"/>
+                </a:solidFill>
+                <a:latin typeface="Calibri"/>
+              </a:rPr>
+              <a:t>Reposition an underperforming portfolio offering</a:t>
+            </a:r>
+          </a:p>
+        </p:txBody>
+      </p:sp>
+      <p:sp>
+        <p:nvSpPr>
+          <p:cNvPr id="5" name="TextBox 4"/>
           <p:cNvSpPr txBox="1"/>
           <p:nvPr/>
         </p:nvSpPr>
         <p:spPr>
           <a:xfrm>
-            <a:off x="502920" y="475488"/>
-            <a:ext cx="11155680" cy="640080"/>
+            <a:off x="502920" y="1097280"/>
+            <a:ext cx="11155680" cy="594360"/>
           </a:xfrm>
           <a:prstGeom prst="rect">
             <a:avLst/>
@@ -4061,63 +4378,18 @@
           <a:lstStyle/>
           <a:p>
             <a:pPr algn="l">
-              <a:spcBef>
+              <a:spcAft>
                 <a:spcPts val="0"/>
-              </a:spcBef>
-              <a:spcAft>
-                <a:spcPts val="0"/>
-              </a:spcAft>
-            </a:pPr>
-            <a:r>
-              <a:rPr sz="2800" b="1">
-                <a:solidFill>
-                  <a:srgbClr val="D4A853"/>
-                </a:solidFill>
-                <a:latin typeface="Calibri"/>
-              </a:rPr>
-              <a:t>Reposition an underperforming portfolio offering</a:t>
-            </a:r>
-          </a:p>
-        </p:txBody>
-      </p:sp>
-      <p:sp>
-        <p:nvSpPr>
-          <p:cNvPr id="5" name="TextBox 4"/>
-          <p:cNvSpPr txBox="1"/>
-          <p:nvPr/>
-        </p:nvSpPr>
-        <p:spPr>
-          <a:xfrm>
-            <a:off x="502920" y="1143000"/>
-            <a:ext cx="11155680" cy="640080"/>
-          </a:xfrm>
-          <a:prstGeom prst="rect">
-            <a:avLst/>
-          </a:prstGeom>
-          <a:noFill/>
-        </p:spPr>
-        <p:txBody>
-          <a:bodyPr wrap="square">
-            <a:spAutoFit/>
-          </a:bodyPr>
-          <a:lstStyle/>
-          <a:p>
-            <a:pPr algn="l">
-              <a:spcBef>
-                <a:spcPts val="0"/>
-              </a:spcBef>
-              <a:spcAft>
-                <a:spcPts val="0"/>
-              </a:spcAft>
-            </a:pPr>
-            <a:r>
-              <a:rPr sz="1500" b="0">
+              </a:spcAft>
+            </a:pPr>
+            <a:r>
+              <a:rPr sz="1400" b="0">
                 <a:solidFill>
                   <a:srgbClr val="8B9CB3"/>
                 </a:solidFill>
                 <a:latin typeface="Calibri"/>
               </a:rPr>
-              <a:t>Application Managed Services (AMS): strong technical delivery, but commercially stuck — flat net sales, declining margins, Sales cannot articulate value, regional pricing chaos.</a:t>
+              <a:t>Application Managed Services: strong technical delivery, but commercially stuck — flat net sales, declining gross margin, Sales cannot articulate value, inconsistent regional pricing.</a:t>
             </a:r>
           </a:p>
         </p:txBody>
@@ -4130,8 +4402,8 @@
         </p:nvSpPr>
         <p:spPr>
           <a:xfrm>
-            <a:off x="502920" y="1965960"/>
-            <a:ext cx="3566160" cy="1417320"/>
+            <a:off x="502920" y="1874519"/>
+            <a:ext cx="3566160" cy="1371600"/>
           </a:xfrm>
           <a:prstGeom prst="roundRect">
             <a:avLst>
@@ -4175,8 +4447,8 @@
         </p:nvSpPr>
         <p:spPr>
           <a:xfrm>
-            <a:off x="640080" y="2075688"/>
-            <a:ext cx="3291840" cy="1234440"/>
+            <a:off x="640080" y="1984247"/>
+            <a:ext cx="3291840" cy="1188720"/>
           </a:xfrm>
           <a:prstGeom prst="rect">
             <a:avLst/>
@@ -4190,59 +4462,50 @@
           <a:lstStyle/>
           <a:p>
             <a:pPr algn="ctr">
-              <a:spcBef>
+              <a:spcAft>
+                <a:spcPts val="200"/>
+              </a:spcAft>
+            </a:pPr>
+            <a:r>
+              <a:rPr sz="1000" b="1">
+                <a:solidFill>
+                  <a:srgbClr val="8B9CB3"/>
+                </a:solidFill>
+                <a:latin typeface="Calibri"/>
+              </a:rPr>
+              <a:t>NET SALES (2 YEARS)</a:t>
+            </a:r>
+          </a:p>
+          <a:p>
+            <a:pPr algn="ctr">
+              <a:spcAft>
+                <a:spcPts val="200"/>
+              </a:spcAft>
+            </a:pPr>
+            <a:r>
+              <a:rPr sz="2400" b="1">
+                <a:solidFill>
+                  <a:srgbClr val="8B9CB3"/>
+                </a:solidFill>
+                <a:latin typeface="Calibri"/>
+              </a:rPr>
+              <a:t>Flat</a:t>
+            </a:r>
+          </a:p>
+          <a:p>
+            <a:pPr algn="ctr">
+              <a:spcAft>
                 <a:spcPts val="0"/>
-              </a:spcBef>
-              <a:spcAft>
-                <a:spcPts val="200"/>
-              </a:spcAft>
-            </a:pPr>
-            <a:r>
-              <a:rPr sz="1000" b="1">
+              </a:spcAft>
+            </a:pPr>
+            <a:r>
+              <a:rPr sz="1100" b="0">
                 <a:solidFill>
                   <a:srgbClr val="8B9CB3"/>
                 </a:solidFill>
                 <a:latin typeface="Calibri"/>
               </a:rPr>
-              <a:t>NET SALES (2 YRS)</a:t>
-            </a:r>
-          </a:p>
-          <a:p>
-            <a:pPr algn="ctr">
-              <a:spcBef>
-                <a:spcPts val="0"/>
-              </a:spcBef>
-              <a:spcAft>
-                <a:spcPts val="200"/>
-              </a:spcAft>
-            </a:pPr>
-            <a:r>
-              <a:rPr sz="2600" b="1">
-                <a:solidFill>
-                  <a:srgbClr val="8B9CB3"/>
-                </a:solidFill>
-                <a:latin typeface="Calibri"/>
-              </a:rPr>
-              <a:t>Flat</a:t>
-            </a:r>
-          </a:p>
-          <a:p>
-            <a:pPr algn="ctr">
-              <a:spcBef>
-                <a:spcPts val="0"/>
-              </a:spcBef>
-              <a:spcAft>
-                <a:spcPts val="0"/>
-              </a:spcAft>
-            </a:pPr>
-            <a:r>
-              <a:rPr sz="1100" b="0">
-                <a:solidFill>
-                  <a:srgbClr val="8B9CB3"/>
-                </a:solidFill>
-                <a:latin typeface="Calibri"/>
-              </a:rPr>
-              <a:t>Weak conversion · no attach</a:t>
+              <a:t>Weak conversion · little attach</a:t>
             </a:r>
           </a:p>
         </p:txBody>
@@ -4255,8 +4518,8 @@
         </p:nvSpPr>
         <p:spPr>
           <a:xfrm>
-            <a:off x="4297680" y="1965960"/>
-            <a:ext cx="3566160" cy="1417320"/>
+            <a:off x="4297680" y="1874519"/>
+            <a:ext cx="3566160" cy="1371600"/>
           </a:xfrm>
           <a:prstGeom prst="roundRect">
             <a:avLst>
@@ -4300,8 +4563,8 @@
         </p:nvSpPr>
         <p:spPr>
           <a:xfrm>
-            <a:off x="4434840" y="2075688"/>
-            <a:ext cx="3291840" cy="1234440"/>
+            <a:off x="4434840" y="1984247"/>
+            <a:ext cx="3291840" cy="1188720"/>
           </a:xfrm>
           <a:prstGeom prst="rect">
             <a:avLst/>
@@ -4315,59 +4578,50 @@
           <a:lstStyle/>
           <a:p>
             <a:pPr algn="ctr">
-              <a:spcBef>
+              <a:spcAft>
+                <a:spcPts val="200"/>
+              </a:spcAft>
+            </a:pPr>
+            <a:r>
+              <a:rPr sz="1000" b="1">
+                <a:solidFill>
+                  <a:srgbClr val="8B9CB3"/>
+                </a:solidFill>
+                <a:latin typeface="Calibri"/>
+              </a:rPr>
+              <a:t>GROSS MARGIN</a:t>
+            </a:r>
+          </a:p>
+          <a:p>
+            <a:pPr algn="ctr">
+              <a:spcAft>
+                <a:spcPts val="200"/>
+              </a:spcAft>
+            </a:pPr>
+            <a:r>
+              <a:rPr sz="2400" b="1">
+                <a:solidFill>
+                  <a:srgbClr val="F87171"/>
+                </a:solidFill>
+                <a:latin typeface="Calibri"/>
+              </a:rPr>
+              <a:t>−4–6 points</a:t>
+            </a:r>
+          </a:p>
+          <a:p>
+            <a:pPr algn="ctr">
+              <a:spcAft>
                 <a:spcPts val="0"/>
-              </a:spcBef>
-              <a:spcAft>
-                <a:spcPts val="200"/>
-              </a:spcAft>
-            </a:pPr>
-            <a:r>
-              <a:rPr sz="1000" b="1">
+              </a:spcAft>
+            </a:pPr>
+            <a:r>
+              <a:rPr sz="1100" b="0">
                 <a:solidFill>
                   <a:srgbClr val="8B9CB3"/>
                 </a:solidFill>
                 <a:latin typeface="Calibri"/>
               </a:rPr>
-              <a:t>GROSS MARGIN</a:t>
-            </a:r>
-          </a:p>
-          <a:p>
-            <a:pPr algn="ctr">
-              <a:spcBef>
-                <a:spcPts val="0"/>
-              </a:spcBef>
-              <a:spcAft>
-                <a:spcPts val="200"/>
-              </a:spcAft>
-            </a:pPr>
-            <a:r>
-              <a:rPr sz="2600" b="1">
-                <a:solidFill>
-                  <a:srgbClr val="F87171"/>
-                </a:solidFill>
-                <a:latin typeface="Calibri"/>
-              </a:rPr>
-              <a:t>−4–6 pts</a:t>
-            </a:r>
-          </a:p>
-          <a:p>
-            <a:pPr algn="ctr">
-              <a:spcBef>
-                <a:spcPts val="0"/>
-              </a:spcBef>
-              <a:spcAft>
-                <a:spcPts val="0"/>
-              </a:spcAft>
-            </a:pPr>
-            <a:r>
-              <a:rPr sz="1100" b="0">
-                <a:solidFill>
-                  <a:srgbClr val="8B9CB3"/>
-                </a:solidFill>
-                <a:latin typeface="Calibri"/>
-              </a:rPr>
-              <a:t>Discount · scope creep · KT bleed</a:t>
+              <a:t>Discount · scope creep · transition overrun</a:t>
             </a:r>
           </a:p>
         </p:txBody>
@@ -4380,8 +4634,8 @@
         </p:nvSpPr>
         <p:spPr>
           <a:xfrm>
-            <a:off x="8092440" y="1965960"/>
-            <a:ext cx="3566160" cy="1417320"/>
+            <a:off x="8092440" y="1874519"/>
+            <a:ext cx="3566160" cy="1371600"/>
           </a:xfrm>
           <a:prstGeom prst="roundRect">
             <a:avLst>
@@ -4425,8 +4679,8 @@
         </p:nvSpPr>
         <p:spPr>
           <a:xfrm>
-            <a:off x="8229600" y="2075688"/>
-            <a:ext cx="3291840" cy="1234440"/>
+            <a:off x="8229600" y="1984247"/>
+            <a:ext cx="3291840" cy="1188720"/>
           </a:xfrm>
           <a:prstGeom prst="rect">
             <a:avLst/>
@@ -4440,59 +4694,50 @@
           <a:lstStyle/>
           <a:p>
             <a:pPr algn="ctr">
-              <a:spcBef>
+              <a:spcAft>
+                <a:spcPts val="200"/>
+              </a:spcAft>
+            </a:pPr>
+            <a:r>
+              <a:rPr sz="1000" b="1">
+                <a:solidFill>
+                  <a:srgbClr val="8B9CB3"/>
+                </a:solidFill>
+                <a:latin typeface="Calibri"/>
+              </a:rPr>
+              <a:t>DELIVERY SATISFACTION</a:t>
+            </a:r>
+          </a:p>
+          <a:p>
+            <a:pPr algn="ctr">
+              <a:spcAft>
+                <a:spcPts val="200"/>
+              </a:spcAft>
+            </a:pPr>
+            <a:r>
+              <a:rPr sz="2400" b="1">
+                <a:solidFill>
+                  <a:srgbClr val="3FB950"/>
+                </a:solidFill>
+                <a:latin typeface="Calibri"/>
+              </a:rPr>
+              <a:t>Strong</a:t>
+            </a:r>
+          </a:p>
+          <a:p>
+            <a:pPr algn="ctr">
+              <a:spcAft>
                 <a:spcPts val="0"/>
-              </a:spcBef>
-              <a:spcAft>
-                <a:spcPts val="200"/>
-              </a:spcAft>
-            </a:pPr>
-            <a:r>
-              <a:rPr sz="1000" b="1">
+              </a:spcAft>
+            </a:pPr>
+            <a:r>
+              <a:rPr sz="1100" b="0">
                 <a:solidFill>
                   <a:srgbClr val="8B9CB3"/>
                 </a:solidFill>
                 <a:latin typeface="Calibri"/>
               </a:rPr>
-              <a:t>DELIVERY NPS / C-SAT</a:t>
-            </a:r>
-          </a:p>
-          <a:p>
-            <a:pPr algn="ctr">
-              <a:spcBef>
-                <a:spcPts val="0"/>
-              </a:spcBef>
-              <a:spcAft>
-                <a:spcPts val="200"/>
-              </a:spcAft>
-            </a:pPr>
-            <a:r>
-              <a:rPr sz="2600" b="1">
-                <a:solidFill>
-                  <a:srgbClr val="3FB950"/>
-                </a:solidFill>
-                <a:latin typeface="Calibri"/>
-              </a:rPr>
-              <a:t>Strong</a:t>
-            </a:r>
-          </a:p>
-          <a:p>
-            <a:pPr algn="ctr">
-              <a:spcBef>
-                <a:spcPts val="0"/>
-              </a:spcBef>
-              <a:spcAft>
-                <a:spcPts val="0"/>
-              </a:spcAft>
-            </a:pPr>
-            <a:r>
-              <a:rPr sz="1100" b="0">
-                <a:solidFill>
-                  <a:srgbClr val="8B9CB3"/>
-                </a:solidFill>
-                <a:latin typeface="Calibri"/>
-              </a:rPr>
-              <a:t>Execution is not the problem</a:t>
+              <a:t>Execution is not the failure mode</a:t>
             </a:r>
           </a:p>
         </p:txBody>
@@ -4505,7 +4750,7 @@
         </p:nvSpPr>
         <p:spPr>
           <a:xfrm>
-            <a:off x="502920" y="3657600"/>
+            <a:off x="502920" y="3520440"/>
             <a:ext cx="11155680" cy="1234440"/>
           </a:xfrm>
           <a:prstGeom prst="roundRect">
@@ -4550,7 +4795,7 @@
         </p:nvSpPr>
         <p:spPr>
           <a:xfrm>
-            <a:off x="685800" y="3794760"/>
+            <a:off x="685800" y="3657600"/>
             <a:ext cx="10789920" cy="1005840"/>
           </a:xfrm>
           <a:prstGeom prst="rect">
@@ -4565,40 +4810,34 @@
           <a:lstStyle/>
           <a:p>
             <a:pPr algn="l">
-              <a:spcBef>
+              <a:spcAft>
+                <a:spcPts val="400"/>
+              </a:spcAft>
+            </a:pPr>
+            <a:r>
+              <a:rPr sz="1100" b="1">
+                <a:solidFill>
+                  <a:srgbClr val="58A6FF"/>
+                </a:solidFill>
+                <a:latin typeface="Calibri"/>
+              </a:rPr>
+              <a:t>EXECUTIVE FRAMING</a:t>
+            </a:r>
+          </a:p>
+          <a:p>
+            <a:pPr algn="l">
+              <a:spcAft>
                 <a:spcPts val="0"/>
-              </a:spcBef>
-              <a:spcAft>
-                <a:spcPts val="400"/>
-              </a:spcAft>
-            </a:pPr>
-            <a:r>
-              <a:rPr sz="1100" b="1">
-                <a:solidFill>
-                  <a:srgbClr val="58A6FF"/>
-                </a:solidFill>
-                <a:latin typeface="Calibri"/>
-              </a:rPr>
-              <a:t>WORKING HYPOTHESIS</a:t>
-            </a:r>
-          </a:p>
-          <a:p>
-            <a:pPr algn="l">
-              <a:spcBef>
-                <a:spcPts val="0"/>
-              </a:spcBef>
-              <a:spcAft>
-                <a:spcPts val="0"/>
-              </a:spcAft>
-            </a:pPr>
-            <a:r>
-              <a:rPr sz="1400" b="0">
+              </a:spcAft>
+            </a:pPr>
+            <a:r>
+              <a:rPr sz="1300" b="0">
                 <a:solidFill>
                   <a:srgbClr val="E6EDF3"/>
                 </a:solidFill>
                 <a:latin typeface="Calibri"/>
               </a:rPr>
-              <a:t>Commercially mis-positioned — sold as FTE headcount while the market buys outcomes, autonomy, and TCO reduction. Delivery excellence exists; the product story, packaging, and pricing model do not.</a:t>
+              <a:t>This is a commercial and go-to-market problem — not a delivery turnaround. The offer is sold as headcount while buyers purchase outcomes, cost predictability, and risk reduction. Decide evolve / reposition / sunset with evidence, then fix packaging, pricing discipline, and Sales enablement.</a:t>
             </a:r>
           </a:p>
         </p:txBody>
@@ -4611,8 +4850,8 @@
         </p:nvSpPr>
         <p:spPr>
           <a:xfrm>
-            <a:off x="502920" y="5074920"/>
-            <a:ext cx="11155680" cy="1097280"/>
+            <a:off x="502920" y="4983480"/>
+            <a:ext cx="11155680" cy="1188720"/>
           </a:xfrm>
           <a:prstGeom prst="rect">
             <a:avLst/>
@@ -4626,49 +4865,40 @@
           <a:lstStyle/>
           <a:p>
             <a:pPr algn="l">
-              <a:spcBef>
+              <a:spcAft>
+                <a:spcPts val="600"/>
+              </a:spcAft>
+            </a:pPr>
+            <a:r>
+              <a:rPr sz="1100" b="1">
+                <a:solidFill>
+                  <a:srgbClr val="D4A853"/>
+                </a:solidFill>
+                <a:latin typeface="Calibri"/>
+              </a:rPr>
+              <a:t>AGENDA  ·  10 MINUTES  (+ 5 MINUTES QUESTIONS)</a:t>
+            </a:r>
+          </a:p>
+          <a:p>
+            <a:pPr algn="l">
+              <a:spcAft>
+                <a:spcPts val="800"/>
+              </a:spcAft>
+            </a:pPr>
+            <a:r>
+              <a:rPr sz="1400" b="0">
+                <a:solidFill>
+                  <a:srgbClr val="E6EDF3"/>
+                </a:solidFill>
+                <a:latin typeface="Calibri"/>
+              </a:rPr>
+              <a:t>1  Diagnose   →   2  Decide   →   3  Package &amp; price   →   4  Prioritize &amp; align   →   5  Measure &amp; ask</a:t>
+            </a:r>
+          </a:p>
+          <a:p>
+            <a:pPr algn="l">
+              <a:spcAft>
                 <a:spcPts val="0"/>
-              </a:spcBef>
-              <a:spcAft>
-                <a:spcPts val="600"/>
-              </a:spcAft>
-            </a:pPr>
-            <a:r>
-              <a:rPr sz="1100" b="1">
-                <a:solidFill>
-                  <a:srgbClr val="D4A853"/>
-                </a:solidFill>
-                <a:latin typeface="Calibri"/>
-              </a:rPr>
-              <a:t>AGENDA  ·  10 minutes</a:t>
-            </a:r>
-          </a:p>
-          <a:p>
-            <a:pPr algn="l">
-              <a:spcBef>
-                <a:spcPts val="0"/>
-              </a:spcBef>
-              <a:spcAft>
-                <a:spcPts val="800"/>
-              </a:spcAft>
-            </a:pPr>
-            <a:r>
-              <a:rPr sz="1400" b="0">
-                <a:solidFill>
-                  <a:srgbClr val="E6EDF3"/>
-                </a:solidFill>
-                <a:latin typeface="Calibri"/>
-              </a:rPr>
-              <a:t>1  Diagnose   →   2  Decide (evolve / reposition / sunset)   →   3  Package &amp; price   →   4  Prioritize &amp; align   →   5  Measure &amp; close</a:t>
-            </a:r>
-          </a:p>
-          <a:p>
-            <a:pPr algn="l">
-              <a:spcBef>
-                <a:spcPts val="0"/>
-              </a:spcBef>
-              <a:spcAft>
-                <a:spcPts val="0"/>
               </a:spcAft>
             </a:pPr>
             <a:r>
@@ -4678,7 +4908,7 @@
                 </a:solidFill>
                 <a:latin typeface="Calibri"/>
               </a:rPr>
-              <a:t>Proof anchors:  H3G UK  $125m packaging &amp; economics   ·   TEF Argentina  $100m renewal reposition</a:t>
+              <a:t>Leadership question answered: evolve, reposition, or sunset — with a plan Sales, Deal Desk, Finance, and regions can run.</a:t>
             </a:r>
           </a:p>
         </p:txBody>
@@ -4706,9 +4936,6 @@
           <a:lstStyle/>
           <a:p>
             <a:pPr algn="l">
-              <a:spcBef>
-                <a:spcPts val="0"/>
-              </a:spcBef>
               <a:spcAft>
                 <a:spcPts val="0"/>
               </a:spcAft>
@@ -4748,9 +4975,6 @@
           <a:lstStyle/>
           <a:p>
             <a:pPr algn="r">
-              <a:spcBef>
-                <a:spcPts val="0"/>
-              </a:spcBef>
               <a:spcAft>
                 <a:spcPts val="0"/>
               </a:spcAft>
@@ -4845,63 +5069,57 @@
           <a:noFill/>
         </p:spPr>
         <p:txBody>
+          <a:bodyPr wrap="none">
+            <a:spAutoFit/>
+          </a:bodyPr>
+          <a:lstStyle/>
+          <a:p>
+            <a:pPr algn="l">
+              <a:spcAft>
+                <a:spcPts val="0"/>
+              </a:spcAft>
+            </a:pPr>
+            <a:r>
+              <a:rPr sz="1100" b="1">
+                <a:solidFill>
+                  <a:srgbClr val="58A6FF"/>
+                </a:solidFill>
+                <a:latin typeface="Calibri"/>
+              </a:rPr>
+              <a:t>DIAGNOSIS FRAMEWORK  ·  RECOMMENDATION</a:t>
+            </a:r>
+          </a:p>
+        </p:txBody>
+      </p:sp>
+      <p:sp>
+        <p:nvSpPr>
+          <p:cNvPr id="4" name="TextBox 3"/>
+          <p:cNvSpPr txBox="1"/>
+          <p:nvPr/>
+        </p:nvSpPr>
+        <p:spPr>
+          <a:xfrm>
+            <a:off x="502920" y="475488"/>
+            <a:ext cx="11155680" cy="640080"/>
+          </a:xfrm>
+          <a:prstGeom prst="rect">
+            <a:avLst/>
+          </a:prstGeom>
+          <a:noFill/>
+        </p:spPr>
+        <p:txBody>
           <a:bodyPr wrap="square">
             <a:spAutoFit/>
           </a:bodyPr>
           <a:lstStyle/>
           <a:p>
             <a:pPr algn="l">
-              <a:spcBef>
+              <a:spcAft>
                 <a:spcPts val="0"/>
-              </a:spcBef>
-              <a:spcAft>
-                <a:spcPts val="0"/>
-              </a:spcAft>
-            </a:pPr>
-            <a:r>
-              <a:rPr sz="1100" b="1">
-                <a:solidFill>
-                  <a:srgbClr val="58A6FF"/>
-                </a:solidFill>
-                <a:latin typeface="Calibri"/>
-              </a:rPr>
-              <a:t>DIAGNOSIS FRAMEWORK  ·  RECOMMENDATION</a:t>
-            </a:r>
-          </a:p>
-        </p:txBody>
-      </p:sp>
-      <p:sp>
-        <p:nvSpPr>
-          <p:cNvPr id="4" name="TextBox 3"/>
-          <p:cNvSpPr txBox="1"/>
-          <p:nvPr/>
-        </p:nvSpPr>
-        <p:spPr>
-          <a:xfrm>
-            <a:off x="502920" y="475488"/>
-            <a:ext cx="11155680" cy="640080"/>
-          </a:xfrm>
-          <a:prstGeom prst="rect">
-            <a:avLst/>
-          </a:prstGeom>
-          <a:noFill/>
-        </p:spPr>
-        <p:txBody>
-          <a:bodyPr wrap="square">
-            <a:spAutoFit/>
-          </a:bodyPr>
-          <a:lstStyle/>
-          <a:p>
-            <a:pPr algn="l">
-              <a:spcBef>
-                <a:spcPts val="0"/>
-              </a:spcBef>
-              <a:spcAft>
-                <a:spcPts val="0"/>
-              </a:spcAft>
-            </a:pPr>
-            <a:r>
-              <a:rPr sz="2800" b="1">
+              </a:spcAft>
+            </a:pPr>
+            <a:r>
+              <a:rPr sz="2600" b="1">
                 <a:solidFill>
                   <a:srgbClr val="D4A853"/>
                 </a:solidFill>
@@ -4920,8 +5138,8 @@
         </p:nvSpPr>
         <p:spPr>
           <a:xfrm>
-            <a:off x="502920" y="1234440"/>
-            <a:ext cx="2148840" cy="1417320"/>
+            <a:off x="502920" y="1188720"/>
+            <a:ext cx="2148840" cy="1371600"/>
           </a:xfrm>
           <a:prstGeom prst="roundRect">
             <a:avLst>
@@ -4965,8 +5183,8 @@
         </p:nvSpPr>
         <p:spPr>
           <a:xfrm>
-            <a:off x="612648" y="1325880"/>
-            <a:ext cx="1920240" cy="1234440"/>
+            <a:off x="612648" y="1280160"/>
+            <a:ext cx="1920240" cy="1188720"/>
           </a:xfrm>
           <a:prstGeom prst="rect">
             <a:avLst/>
@@ -4980,9 +5198,6 @@
           <a:lstStyle/>
           <a:p>
             <a:pPr algn="l">
-              <a:spcBef>
-                <a:spcPts val="0"/>
-              </a:spcBef>
               <a:spcAft>
                 <a:spcPts val="400"/>
               </a:spcAft>
@@ -4999,9 +5214,6 @@
           </a:p>
           <a:p>
             <a:pPr algn="l">
-              <a:spcBef>
-                <a:spcPts val="0"/>
-              </a:spcBef>
               <a:spcAft>
                 <a:spcPts val="100"/>
               </a:spcAft>
@@ -5013,14 +5225,11 @@
                 </a:solidFill>
                 <a:latin typeface="Calibri"/>
               </a:rPr>
-              <a:t>15–20 deals · tag</a:t>
-            </a:r>
-          </a:p>
-          <a:p>
-            <a:pPr algn="l">
-              <a:spcBef>
-                <a:spcPts val="0"/>
-              </a:spcBef>
+              <a:t>15–20 deals: tag losses as</a:t>
+            </a:r>
+          </a:p>
+          <a:p>
+            <a:pPr algn="l">
               <a:spcAft>
                 <a:spcPts val="100"/>
               </a:spcAft>
@@ -5032,7 +5241,7 @@
                 </a:solidFill>
                 <a:latin typeface="Calibri"/>
               </a:rPr>
-              <a:t>price vs value vs unclear</a:t>
+              <a:t>price-only vs value unclear</a:t>
             </a:r>
           </a:p>
         </p:txBody>
@@ -5045,8 +5254,8 @@
         </p:nvSpPr>
         <p:spPr>
           <a:xfrm>
-            <a:off x="2788920" y="1234440"/>
-            <a:ext cx="2148840" cy="1417320"/>
+            <a:off x="2788920" y="1188720"/>
+            <a:ext cx="2148840" cy="1371600"/>
           </a:xfrm>
           <a:prstGeom prst="roundRect">
             <a:avLst>
@@ -5090,8 +5299,8 @@
         </p:nvSpPr>
         <p:spPr>
           <a:xfrm>
-            <a:off x="2898648" y="1325880"/>
-            <a:ext cx="1920240" cy="1234440"/>
+            <a:off x="2898648" y="1280160"/>
+            <a:ext cx="1920240" cy="1188720"/>
           </a:xfrm>
           <a:prstGeom prst="rect">
             <a:avLst/>
@@ -5105,9 +5314,6 @@
           <a:lstStyle/>
           <a:p>
             <a:pPr algn="l">
-              <a:spcBef>
-                <a:spcPts val="0"/>
-              </a:spcBef>
               <a:spcAft>
                 <a:spcPts val="400"/>
               </a:spcAft>
@@ -5124,9 +5330,6 @@
           </a:p>
           <a:p>
             <a:pPr algn="l">
-              <a:spcBef>
-                <a:spcPts val="0"/>
-              </a:spcBef>
               <a:spcAft>
                 <a:spcPts val="100"/>
               </a:spcAft>
@@ -5138,14 +5341,11 @@
                 </a:solidFill>
                 <a:latin typeface="Calibri"/>
               </a:rPr>
-              <a:t>GM waterfall · discount</a:t>
-            </a:r>
-          </a:p>
-          <a:p>
-            <a:pPr algn="l">
-              <a:spcBef>
-                <a:spcPts val="0"/>
-              </a:spcBef>
+              <a:t>Gross-margin waterfall:</a:t>
+            </a:r>
+          </a:p>
+          <a:p>
+            <a:pPr algn="l">
               <a:spcAft>
                 <a:spcPts val="100"/>
               </a:spcAft>
@@ -5157,7 +5357,7 @@
                 </a:solidFill>
                 <a:latin typeface="Calibri"/>
               </a:rPr>
-              <a:t>· KT overrun · CR leak</a:t>
+              <a:t>discount · transition · unpaid scope</a:t>
             </a:r>
           </a:p>
         </p:txBody>
@@ -5170,8 +5370,8 @@
         </p:nvSpPr>
         <p:spPr>
           <a:xfrm>
-            <a:off x="5074920" y="1234440"/>
-            <a:ext cx="2148840" cy="1417320"/>
+            <a:off x="5074920" y="1188720"/>
+            <a:ext cx="2148840" cy="1371600"/>
           </a:xfrm>
           <a:prstGeom prst="roundRect">
             <a:avLst>
@@ -5215,8 +5415,8 @@
         </p:nvSpPr>
         <p:spPr>
           <a:xfrm>
-            <a:off x="5184648" y="1325880"/>
-            <a:ext cx="1920240" cy="1234440"/>
+            <a:off x="5184648" y="1280160"/>
+            <a:ext cx="1920240" cy="1188720"/>
           </a:xfrm>
           <a:prstGeom prst="rect">
             <a:avLst/>
@@ -5230,9 +5430,6 @@
           <a:lstStyle/>
           <a:p>
             <a:pPr algn="l">
-              <a:spcBef>
-                <a:spcPts val="0"/>
-              </a:spcBef>
               <a:spcAft>
                 <a:spcPts val="400"/>
               </a:spcAft>
@@ -5249,9 +5446,6 @@
           </a:p>
           <a:p>
             <a:pPr algn="l">
-              <a:spcBef>
-                <a:spcPts val="0"/>
-              </a:spcBef>
               <a:spcAft>
                 <a:spcPts val="100"/>
               </a:spcAft>
@@ -5263,14 +5457,11 @@
                 </a:solidFill>
                 <a:latin typeface="Calibri"/>
               </a:rPr>
-              <a:t>FTE SI vs outcome /</a:t>
-            </a:r>
-          </a:p>
-          <a:p>
-            <a:pPr algn="l">
-              <a:spcBef>
-                <a:spcPts val="0"/>
-              </a:spcBef>
+              <a:t>Staff augmentation vs</a:t>
+            </a:r>
+          </a:p>
+          <a:p>
+            <a:pPr algn="l">
               <a:spcAft>
                 <a:spcPts val="100"/>
               </a:spcAft>
@@ -5282,7 +5473,7 @@
                 </a:solidFill>
                 <a:latin typeface="Calibri"/>
               </a:rPr>
-              <a:t>AO product MS shift</a:t>
+              <a:t>outcome-packaged peers</a:t>
             </a:r>
           </a:p>
         </p:txBody>
@@ -5295,8 +5486,8 @@
         </p:nvSpPr>
         <p:spPr>
           <a:xfrm>
-            <a:off x="7360920" y="1234440"/>
-            <a:ext cx="2148840" cy="1417320"/>
+            <a:off x="7360920" y="1188720"/>
+            <a:ext cx="2148840" cy="1371600"/>
           </a:xfrm>
           <a:prstGeom prst="roundRect">
             <a:avLst>
@@ -5340,8 +5531,8 @@
         </p:nvSpPr>
         <p:spPr>
           <a:xfrm>
-            <a:off x="7470648" y="1325880"/>
-            <a:ext cx="1920240" cy="1234440"/>
+            <a:off x="7470648" y="1280160"/>
+            <a:ext cx="1920240" cy="1188720"/>
           </a:xfrm>
           <a:prstGeom prst="rect">
             <a:avLst/>
@@ -5355,9 +5546,6 @@
           <a:lstStyle/>
           <a:p>
             <a:pPr algn="l">
-              <a:spcBef>
-                <a:spcPts val="0"/>
-              </a:spcBef>
               <a:spcAft>
                 <a:spcPts val="400"/>
               </a:spcAft>
@@ -5369,14 +5557,11 @@
                 </a:solidFill>
                 <a:latin typeface="Calibri"/>
               </a:rPr>
-              <a:t>VOICE</a:t>
-            </a:r>
-          </a:p>
-          <a:p>
-            <a:pPr algn="l">
-              <a:spcBef>
-                <a:spcPts val="0"/>
-              </a:spcBef>
+              <a:t>CUSTOMER VOICE</a:t>
+            </a:r>
+          </a:p>
+          <a:p>
+            <a:pPr algn="l">
               <a:spcAft>
                 <a:spcPts val="100"/>
               </a:spcAft>
@@ -5388,14 +5573,11 @@
                 </a:solidFill>
                 <a:latin typeface="Calibri"/>
               </a:rPr>
-              <a:t>NPS high + willingness</a:t>
-            </a:r>
-          </a:p>
-          <a:p>
-            <a:pPr algn="l">
-              <a:spcBef>
-                <a:spcPts val="0"/>
-              </a:spcBef>
+              <a:t>High satisfaction + low</a:t>
+            </a:r>
+          </a:p>
+          <a:p>
+            <a:pPr algn="l">
               <a:spcAft>
                 <a:spcPts val="100"/>
               </a:spcAft>
@@ -5407,7 +5589,7 @@
                 </a:solidFill>
                 <a:latin typeface="Calibri"/>
               </a:rPr>
-              <a:t>to pay low = story gap</a:t>
+              <a:t>willingness to pay = story gap</a:t>
             </a:r>
           </a:p>
         </p:txBody>
@@ -5420,8 +5602,8 @@
         </p:nvSpPr>
         <p:spPr>
           <a:xfrm>
-            <a:off x="9646920" y="1234440"/>
-            <a:ext cx="2148840" cy="1417320"/>
+            <a:off x="9646920" y="1188720"/>
+            <a:ext cx="2148840" cy="1371600"/>
           </a:xfrm>
           <a:prstGeom prst="roundRect">
             <a:avLst>
@@ -5465,8 +5647,8 @@
         </p:nvSpPr>
         <p:spPr>
           <a:xfrm>
-            <a:off x="9756648" y="1325880"/>
-            <a:ext cx="1920240" cy="1234440"/>
+            <a:off x="9756648" y="1280160"/>
+            <a:ext cx="1920240" cy="1188720"/>
           </a:xfrm>
           <a:prstGeom prst="rect">
             <a:avLst/>
@@ -5480,9 +5662,6 @@
           <a:lstStyle/>
           <a:p>
             <a:pPr algn="l">
-              <a:spcBef>
-                <a:spcPts val="0"/>
-              </a:spcBef>
               <a:spcAft>
                 <a:spcPts val="400"/>
               </a:spcAft>
@@ -5494,14 +5673,11 @@
                 </a:solidFill>
                 <a:latin typeface="Calibri"/>
               </a:rPr>
-              <a:t>PORTFOLIO</a:t>
-            </a:r>
-          </a:p>
-          <a:p>
-            <a:pPr algn="l">
-              <a:spcBef>
-                <a:spcPts val="0"/>
-              </a:spcBef>
+              <a:t>PORTFOLIO FIT</a:t>
+            </a:r>
+          </a:p>
+          <a:p>
+            <a:pPr algn="l">
               <a:spcAft>
                 <a:spcPts val="100"/>
               </a:spcAft>
@@ -5513,14 +5689,11 @@
                 </a:solidFill>
                 <a:latin typeface="Calibri"/>
               </a:rPr>
-              <a:t>18-mo GM path?</a:t>
-            </a:r>
-          </a:p>
-          <a:p>
-            <a:pPr algn="l">
-              <a:spcBef>
-                <a:spcPts val="0"/>
-              </a:spcBef>
+              <a:t>18-month margin path?</a:t>
+            </a:r>
+          </a:p>
+          <a:p>
+            <a:pPr algn="l">
               <a:spcAft>
                 <a:spcPts val="100"/>
               </a:spcAft>
@@ -5532,7 +5705,7 @@
                 </a:solidFill>
                 <a:latin typeface="Calibri"/>
               </a:rPr>
-              <a:t>Attach to AO / products?</a:t>
+              <a:t>Strategic pull-through?</a:t>
             </a:r>
           </a:p>
         </p:txBody>
@@ -5545,7 +5718,7 @@
         </p:nvSpPr>
         <p:spPr>
           <a:xfrm>
-            <a:off x="502920" y="2880360"/>
+            <a:off x="502920" y="2788920"/>
             <a:ext cx="3611880" cy="1234440"/>
           </a:xfrm>
           <a:prstGeom prst="roundRect">
@@ -5590,7 +5763,7 @@
         </p:nvSpPr>
         <p:spPr>
           <a:xfrm>
-            <a:off x="502920" y="2880360"/>
+            <a:off x="502920" y="2788920"/>
             <a:ext cx="3611880" cy="54864"/>
           </a:xfrm>
           <a:prstGeom prst="rect">
@@ -5633,7 +5806,7 @@
         </p:nvSpPr>
         <p:spPr>
           <a:xfrm>
-            <a:off x="640080" y="3017520"/>
+            <a:off x="640080" y="2926080"/>
             <a:ext cx="3337560" cy="1005840"/>
           </a:xfrm>
           <a:prstGeom prst="rect">
@@ -5648,30 +5821,24 @@
           <a:lstStyle/>
           <a:p>
             <a:pPr algn="l">
-              <a:spcBef>
+              <a:spcAft>
+                <a:spcPts val="400"/>
+              </a:spcAft>
+            </a:pPr>
+            <a:r>
+              <a:rPr sz="1300" b="1">
+                <a:solidFill>
+                  <a:srgbClr val="F87171"/>
+                </a:solidFill>
+                <a:latin typeface="Calibri"/>
+              </a:rPr>
+              <a:t>Commoditized packaging</a:t>
+            </a:r>
+          </a:p>
+          <a:p>
+            <a:pPr algn="l">
+              <a:spcAft>
                 <a:spcPts val="0"/>
-              </a:spcBef>
-              <a:spcAft>
-                <a:spcPts val="400"/>
-              </a:spcAft>
-            </a:pPr>
-            <a:r>
-              <a:rPr sz="1300" b="1">
-                <a:solidFill>
-                  <a:srgbClr val="F87171"/>
-                </a:solidFill>
-                <a:latin typeface="Calibri"/>
-              </a:rPr>
-              <a:t>Commoditized packaging</a:t>
-            </a:r>
-          </a:p>
-          <a:p>
-            <a:pPr algn="l">
-              <a:spcBef>
-                <a:spcPts val="0"/>
-              </a:spcBef>
-              <a:spcAft>
-                <a:spcPts val="0"/>
               </a:spcAft>
             </a:pPr>
             <a:r>
@@ -5681,7 +5848,7 @@
                 </a:solidFill>
                 <a:latin typeface="Calibri"/>
               </a:rPr>
-              <a:t>Sold as L1/L2/L3 FTE towers — procurement benches us vs SIs</a:t>
+              <a:t>Sold as Level-1/2/3 staffing towers — procurement benches us against systems integrators</a:t>
             </a:r>
           </a:p>
         </p:txBody>
@@ -5694,7 +5861,7 @@
         </p:nvSpPr>
         <p:spPr>
           <a:xfrm>
-            <a:off x="4297680" y="2880360"/>
+            <a:off x="4297680" y="2788920"/>
             <a:ext cx="3611880" cy="1234440"/>
           </a:xfrm>
           <a:prstGeom prst="roundRect">
@@ -5739,7 +5906,7 @@
         </p:nvSpPr>
         <p:spPr>
           <a:xfrm>
-            <a:off x="4297680" y="2880360"/>
+            <a:off x="4297680" y="2788920"/>
             <a:ext cx="3611880" cy="54864"/>
           </a:xfrm>
           <a:prstGeom prst="rect">
@@ -5782,7 +5949,7 @@
         </p:nvSpPr>
         <p:spPr>
           <a:xfrm>
-            <a:off x="4434840" y="3017520"/>
+            <a:off x="4434840" y="2926080"/>
             <a:ext cx="3337560" cy="1005840"/>
           </a:xfrm>
           <a:prstGeom prst="rect">
@@ -5797,30 +5964,24 @@
           <a:lstStyle/>
           <a:p>
             <a:pPr algn="l">
-              <a:spcBef>
+              <a:spcAft>
+                <a:spcPts val="400"/>
+              </a:spcAft>
+            </a:pPr>
+            <a:r>
+              <a:rPr sz="1300" b="1">
+                <a:solidFill>
+                  <a:srgbClr val="F87171"/>
+                </a:solidFill>
+                <a:latin typeface="Calibri"/>
+              </a:rPr>
+              <a:t>Pricing chaos</a:t>
+            </a:r>
+          </a:p>
+          <a:p>
+            <a:pPr algn="l">
+              <a:spcAft>
                 <a:spcPts val="0"/>
-              </a:spcBef>
-              <a:spcAft>
-                <a:spcPts val="400"/>
-              </a:spcAft>
-            </a:pPr>
-            <a:r>
-              <a:rPr sz="1300" b="1">
-                <a:solidFill>
-                  <a:srgbClr val="F87171"/>
-                </a:solidFill>
-                <a:latin typeface="Calibri"/>
-              </a:rPr>
-              <a:t>Pricing chaos</a:t>
-            </a:r>
-          </a:p>
-          <a:p>
-            <a:pPr algn="l">
-              <a:spcBef>
-                <a:spcPts val="0"/>
-              </a:spcBef>
-              <a:spcAft>
-                <a:spcPts val="0"/>
               </a:spcAft>
             </a:pPr>
             <a:r>
@@ -5830,7 +5991,7 @@
                 </a:solidFill>
                 <a:latin typeface="Calibri"/>
               </a:rPr>
-              <a:t>Regional ad-hoc discounts · underpriced KT · unpaid scope creep</a:t>
+              <a:t>Regional ad-hoc discounts · underpriced knowledge transfer · unpaid scope creep</a:t>
             </a:r>
           </a:p>
         </p:txBody>
@@ -5843,7 +6004,7 @@
         </p:nvSpPr>
         <p:spPr>
           <a:xfrm>
-            <a:off x="8092440" y="2880360"/>
+            <a:off x="8092440" y="2788920"/>
             <a:ext cx="3611880" cy="1234440"/>
           </a:xfrm>
           <a:prstGeom prst="roundRect">
@@ -5888,7 +6049,7 @@
         </p:nvSpPr>
         <p:spPr>
           <a:xfrm>
-            <a:off x="8092440" y="2880360"/>
+            <a:off x="8092440" y="2788920"/>
             <a:ext cx="3611880" cy="54864"/>
           </a:xfrm>
           <a:prstGeom prst="rect">
@@ -5931,7 +6092,7 @@
         </p:nvSpPr>
         <p:spPr>
           <a:xfrm>
-            <a:off x="8229600" y="3017520"/>
+            <a:off x="8229600" y="2926080"/>
             <a:ext cx="3337560" cy="1005840"/>
           </a:xfrm>
           <a:prstGeom prst="rect">
@@ -5946,30 +6107,24 @@
           <a:lstStyle/>
           <a:p>
             <a:pPr algn="l">
-              <a:spcBef>
+              <a:spcAft>
+                <a:spcPts val="400"/>
+              </a:spcAft>
+            </a:pPr>
+            <a:r>
+              <a:rPr sz="1300" b="1">
+                <a:solidFill>
+                  <a:srgbClr val="F87171"/>
+                </a:solidFill>
+                <a:latin typeface="Calibri"/>
+              </a:rPr>
+              <a:t>Value story gap</a:t>
+            </a:r>
+          </a:p>
+          <a:p>
+            <a:pPr algn="l">
+              <a:spcAft>
                 <a:spcPts val="0"/>
-              </a:spcBef>
-              <a:spcAft>
-                <a:spcPts val="400"/>
-              </a:spcAft>
-            </a:pPr>
-            <a:r>
-              <a:rPr sz="1300" b="1">
-                <a:solidFill>
-                  <a:srgbClr val="F87171"/>
-                </a:solidFill>
-                <a:latin typeface="Calibri"/>
-              </a:rPr>
-              <a:t>Value story gap</a:t>
-            </a:r>
-          </a:p>
-          <a:p>
-            <a:pPr algn="l">
-              <a:spcBef>
-                <a:spcPts val="0"/>
-              </a:spcBef>
-              <a:spcAft>
-                <a:spcPts val="0"/>
               </a:spcAft>
             </a:pPr>
             <a:r>
@@ -5979,7 +6134,7 @@
                 </a:solidFill>
                 <a:latin typeface="Calibri"/>
               </a:rPr>
-              <a:t>Buyers want TCO &amp; autonomy path; we pitch headcount replacement</a:t>
+              <a:t>Buyers want outcomes and predictability; Sales pitches headcount replacement</a:t>
             </a:r>
           </a:p>
         </p:txBody>
@@ -5992,8 +6147,8 @@
         </p:nvSpPr>
         <p:spPr>
           <a:xfrm>
-            <a:off x="502920" y="4343400"/>
-            <a:ext cx="3611880" cy="1691640"/>
+            <a:off x="502920" y="4251960"/>
+            <a:ext cx="3611880" cy="1783080"/>
           </a:xfrm>
           <a:prstGeom prst="roundRect">
             <a:avLst>
@@ -6037,8 +6192,8 @@
         </p:nvSpPr>
         <p:spPr>
           <a:xfrm>
-            <a:off x="667512" y="4480560"/>
-            <a:ext cx="3291840" cy="1417320"/>
+            <a:off x="667512" y="4389120"/>
+            <a:ext cx="3291840" cy="1508760"/>
           </a:xfrm>
           <a:prstGeom prst="rect">
             <a:avLst/>
@@ -6052,9 +6207,6 @@
           <a:lstStyle/>
           <a:p>
             <a:pPr algn="l">
-              <a:spcBef>
-                <a:spcPts val="0"/>
-              </a:spcBef>
               <a:spcAft>
                 <a:spcPts val="600"/>
               </a:spcAft>
@@ -6071,9 +6223,6 @@
           </a:p>
           <a:p>
             <a:pPr algn="l">
-              <a:spcBef>
-                <a:spcPts val="0"/>
-              </a:spcBef>
               <a:spcAft>
                 <a:spcPts val="100"/>
               </a:spcAft>
@@ -6090,9 +6239,6 @@
           </a:p>
           <a:p>
             <a:pPr algn="l">
-              <a:spcBef>
-                <a:spcPts val="0"/>
-              </a:spcBef>
               <a:spcAft>
                 <a:spcPts val="100"/>
               </a:spcAft>
@@ -6104,14 +6250,11 @@
                 </a:solidFill>
                 <a:latin typeface="Calibri"/>
               </a:rPr>
-              <a:t>Ericsson footprint.</a:t>
-            </a:r>
-          </a:p>
-          <a:p>
-            <a:pPr algn="l">
-              <a:spcBef>
-                <a:spcPts val="0"/>
-              </a:spcBef>
+              <a:t>account footprint.</a:t>
+            </a:r>
+          </a:p>
+          <a:p>
+            <a:pPr algn="l">
               <a:spcAft>
                 <a:spcPts val="100"/>
               </a:spcAft>
@@ -6123,7 +6266,7 @@
                 </a:solidFill>
                 <a:latin typeface="Calibri"/>
               </a:rPr>
-              <a:t>Only if no 18-mo GM path.</a:t>
+              <a:t>Only if no 18-month margin path.</a:t>
             </a:r>
           </a:p>
         </p:txBody>
@@ -6136,8 +6279,8 @@
         </p:nvSpPr>
         <p:spPr>
           <a:xfrm>
-            <a:off x="4297680" y="4343400"/>
-            <a:ext cx="3611880" cy="1691640"/>
+            <a:off x="4297680" y="4251960"/>
+            <a:ext cx="3611880" cy="1783080"/>
           </a:xfrm>
           <a:prstGeom prst="roundRect">
             <a:avLst>
@@ -6181,8 +6324,8 @@
         </p:nvSpPr>
         <p:spPr>
           <a:xfrm>
-            <a:off x="4462272" y="4480560"/>
-            <a:ext cx="3291840" cy="1417320"/>
+            <a:off x="4462272" y="4389120"/>
+            <a:ext cx="3291840" cy="1508760"/>
           </a:xfrm>
           <a:prstGeom prst="rect">
             <a:avLst/>
@@ -6196,9 +6339,6 @@
           <a:lstStyle/>
           <a:p>
             <a:pPr algn="l">
-              <a:spcBef>
-                <a:spcPts val="0"/>
-              </a:spcBef>
               <a:spcAft>
                 <a:spcPts val="600"/>
               </a:spcAft>
@@ -6215,9 +6355,6 @@
           </a:p>
           <a:p>
             <a:pPr algn="l">
-              <a:spcBef>
-                <a:spcPts val="0"/>
-              </a:spcBef>
               <a:spcAft>
                 <a:spcPts val="100"/>
               </a:spcAft>
@@ -6229,14 +6366,11 @@
                 </a:solidFill>
                 <a:latin typeface="Calibri"/>
               </a:rPr>
-              <a:t>Tooling without SKU change</a:t>
-            </a:r>
-          </a:p>
-          <a:p>
-            <a:pPr algn="l">
-              <a:spcBef>
-                <a:spcPts val="0"/>
-              </a:spcBef>
+              <a:t>More tooling, same sellable unit.</a:t>
+            </a:r>
+          </a:p>
+          <a:p>
+            <a:pPr algn="l">
               <a:spcAft>
                 <a:spcPts val="100"/>
               </a:spcAft>
@@ -6248,14 +6382,11 @@
                 </a:solidFill>
                 <a:latin typeface="Calibri"/>
               </a:rPr>
-              <a:t>fixes neither sales narrative</a:t>
-            </a:r>
-          </a:p>
-          <a:p>
-            <a:pPr algn="l">
-              <a:spcBef>
-                <a:spcPts val="0"/>
-              </a:spcBef>
+              <a:t>Fixes neither Sales narrative</a:t>
+            </a:r>
+          </a:p>
+          <a:p>
+            <a:pPr algn="l">
               <a:spcAft>
                 <a:spcPts val="100"/>
               </a:spcAft>
@@ -6267,7 +6398,7 @@
                 </a:solidFill>
                 <a:latin typeface="Calibri"/>
               </a:rPr>
-              <a:t>nor margin guardrails.</a:t>
+              <a:t>nor pricing discipline.</a:t>
             </a:r>
           </a:p>
         </p:txBody>
@@ -6280,8 +6411,8 @@
         </p:nvSpPr>
         <p:spPr>
           <a:xfrm>
-            <a:off x="8092440" y="4343400"/>
-            <a:ext cx="3611880" cy="1691640"/>
+            <a:off x="8092440" y="4251960"/>
+            <a:ext cx="3611880" cy="1783080"/>
           </a:xfrm>
           <a:prstGeom prst="roundRect">
             <a:avLst>
@@ -6325,8 +6456,8 @@
         </p:nvSpPr>
         <p:spPr>
           <a:xfrm>
-            <a:off x="8092440" y="4343400"/>
-            <a:ext cx="3611880" cy="1691640"/>
+            <a:off x="8092440" y="4251960"/>
+            <a:ext cx="3611880" cy="1783080"/>
           </a:xfrm>
           <a:prstGeom prst="roundRect">
             <a:avLst>
@@ -6370,8 +6501,8 @@
         </p:nvSpPr>
         <p:spPr>
           <a:xfrm>
-            <a:off x="8257032" y="4480560"/>
-            <a:ext cx="3291840" cy="1417320"/>
+            <a:off x="8257032" y="4389120"/>
+            <a:ext cx="3291840" cy="1508760"/>
           </a:xfrm>
           <a:prstGeom prst="rect">
             <a:avLst/>
@@ -6385,9 +6516,6 @@
           <a:lstStyle/>
           <a:p>
             <a:pPr algn="l">
-              <a:spcBef>
-                <a:spcPts val="0"/>
-              </a:spcBef>
               <a:spcAft>
                 <a:spcPts val="600"/>
               </a:spcAft>
@@ -6404,9 +6532,6 @@
           </a:p>
           <a:p>
             <a:pPr algn="l">
-              <a:spcBef>
-                <a:spcPts val="0"/>
-              </a:spcBef>
               <a:spcAft>
                 <a:spcPts val="100"/>
               </a:spcAft>
@@ -6423,9 +6548,6 @@
           </a:p>
           <a:p>
             <a:pPr algn="l">
-              <a:spcBef>
-                <a:spcPts val="0"/>
-              </a:spcBef>
               <a:spcAft>
                 <a:spcPts val="100"/>
               </a:spcAft>
@@ -6437,14 +6559,11 @@
                 </a:solidFill>
                 <a:latin typeface="Calibri"/>
               </a:rPr>
-              <a:t>Stabilize → Optimize → Autonomize</a:t>
-            </a:r>
-          </a:p>
-          <a:p>
-            <a:pPr algn="l">
-              <a:spcBef>
-                <a:spcPts val="0"/>
-              </a:spcBef>
+              <a:t>Stabilize → Optimize → Transform</a:t>
+            </a:r>
+          </a:p>
+          <a:p>
+            <a:pPr algn="l">
               <a:spcAft>
                 <a:spcPts val="100"/>
               </a:spcAft>
@@ -6456,7 +6575,7 @@
                 </a:solidFill>
                 <a:latin typeface="Calibri"/>
               </a:rPr>
-              <a:t>Evolve modules underneath.</a:t>
+              <a:t>Evolve modules selectively.</a:t>
             </a:r>
           </a:p>
         </p:txBody>
@@ -6484,9 +6603,6 @@
           <a:lstStyle/>
           <a:p>
             <a:pPr algn="l">
-              <a:spcBef>
-                <a:spcPts val="0"/>
-              </a:spcBef>
               <a:spcAft>
                 <a:spcPts val="0"/>
               </a:spcAft>
@@ -6526,9 +6642,6 @@
           <a:lstStyle/>
           <a:p>
             <a:pPr algn="r">
-              <a:spcBef>
-                <a:spcPts val="0"/>
-              </a:spcBef>
               <a:spcAft>
                 <a:spcPts val="0"/>
               </a:spcAft>
@@ -6623,41 +6736,77 @@
           <a:noFill/>
         </p:spPr>
         <p:txBody>
+          <a:bodyPr wrap="none">
+            <a:spAutoFit/>
+          </a:bodyPr>
+          <a:lstStyle/>
+          <a:p>
+            <a:pPr algn="l">
+              <a:spcAft>
+                <a:spcPts val="0"/>
+              </a:spcAft>
+            </a:pPr>
+            <a:r>
+              <a:rPr sz="1100" b="1">
+                <a:solidFill>
+                  <a:srgbClr val="58A6FF"/>
+                </a:solidFill>
+                <a:latin typeface="Calibri"/>
+              </a:rPr>
+              <a:t>REVISED PRICING AND PACKAGING  ·  VALUE PROPOSITION</a:t>
+            </a:r>
+          </a:p>
+        </p:txBody>
+      </p:sp>
+      <p:sp>
+        <p:nvSpPr>
+          <p:cNvPr id="4" name="TextBox 3"/>
+          <p:cNvSpPr txBox="1"/>
+          <p:nvPr/>
+        </p:nvSpPr>
+        <p:spPr>
+          <a:xfrm>
+            <a:off x="502920" y="475488"/>
+            <a:ext cx="11155680" cy="640080"/>
+          </a:xfrm>
+          <a:prstGeom prst="rect">
+            <a:avLst/>
+          </a:prstGeom>
+          <a:noFill/>
+        </p:spPr>
+        <p:txBody>
           <a:bodyPr wrap="square">
             <a:spAutoFit/>
           </a:bodyPr>
           <a:lstStyle/>
           <a:p>
             <a:pPr algn="l">
-              <a:spcBef>
+              <a:spcAft>
                 <a:spcPts val="0"/>
-              </a:spcBef>
-              <a:spcAft>
-                <a:spcPts val="0"/>
-              </a:spcAft>
-            </a:pPr>
-            <a:r>
-              <a:rPr sz="1100" b="1">
-                <a:solidFill>
-                  <a:srgbClr val="58A6FF"/>
-                </a:solidFill>
-                <a:latin typeface="Calibri"/>
-              </a:rPr>
-              <a:t>REVISED PRICING &amp; PACKAGING  ·  VALUE PROPOSITION</a:t>
-            </a:r>
-          </a:p>
-        </p:txBody>
-      </p:sp>
-      <p:sp>
-        <p:nvSpPr>
-          <p:cNvPr id="4" name="TextBox 3"/>
+              </a:spcAft>
+            </a:pPr>
+            <a:r>
+              <a:rPr sz="2600" b="1">
+                <a:solidFill>
+                  <a:srgbClr val="D4A853"/>
+                </a:solidFill>
+                <a:latin typeface="Calibri"/>
+              </a:rPr>
+              <a:t>Sell tiers and outcomes — not staffing towers</a:t>
+            </a:r>
+          </a:p>
+        </p:txBody>
+      </p:sp>
+      <p:sp>
+        <p:nvSpPr>
+          <p:cNvPr id="5" name="TextBox 4"/>
           <p:cNvSpPr txBox="1"/>
           <p:nvPr/>
         </p:nvSpPr>
         <p:spPr>
           <a:xfrm>
-            <a:off x="502920" y="475488"/>
-            <a:ext cx="11155680" cy="640080"/>
+            <a:off x="502920" y="1051560"/>
+            <a:ext cx="11155680" cy="411480"/>
           </a:xfrm>
           <a:prstGeom prst="rect">
             <a:avLst/>
@@ -6671,63 +6820,18 @@
           <a:lstStyle/>
           <a:p>
             <a:pPr algn="l">
-              <a:spcBef>
+              <a:spcAft>
                 <a:spcPts val="0"/>
-              </a:spcBef>
-              <a:spcAft>
-                <a:spcPts val="0"/>
-              </a:spcAft>
-            </a:pPr>
-            <a:r>
-              <a:rPr sz="2800" b="1">
-                <a:solidFill>
-                  <a:srgbClr val="D4A853"/>
-                </a:solidFill>
-                <a:latin typeface="Calibri"/>
-              </a:rPr>
-              <a:t>Sell tiers &amp; outcomes — not FTE towers</a:t>
-            </a:r>
-          </a:p>
-        </p:txBody>
-      </p:sp>
-      <p:sp>
-        <p:nvSpPr>
-          <p:cNvPr id="5" name="TextBox 4"/>
-          <p:cNvSpPr txBox="1"/>
-          <p:nvPr/>
-        </p:nvSpPr>
-        <p:spPr>
-          <a:xfrm>
-            <a:off x="502920" y="1097280"/>
-            <a:ext cx="11155680" cy="411480"/>
-          </a:xfrm>
-          <a:prstGeom prst="rect">
-            <a:avLst/>
-          </a:prstGeom>
-          <a:noFill/>
-        </p:spPr>
-        <p:txBody>
-          <a:bodyPr wrap="square">
-            <a:spAutoFit/>
-          </a:bodyPr>
-          <a:lstStyle/>
-          <a:p>
-            <a:pPr algn="l">
-              <a:spcBef>
-                <a:spcPts val="0"/>
-              </a:spcBef>
-              <a:spcAft>
-                <a:spcPts val="0"/>
-              </a:spcAft>
-            </a:pPr>
-            <a:r>
-              <a:rPr sz="1300" b="0">
+              </a:spcAft>
+            </a:pPr>
+            <a:r>
+              <a:rPr sz="1200" b="0">
                 <a:solidFill>
                   <a:srgbClr val="8B9CB3"/>
                 </a:solidFill>
                 <a:latin typeface="Calibri"/>
               </a:rPr>
-              <a:t>Value prop:  Outcome-guaranteed Application Operations with a built-in ramp to autonomy — reducing customer TCO while protecting margin through standardized tiers &amp; global guardrails.</a:t>
+              <a:t>Value proposition: outcome-tiered managed applications — restore control, improve total cost of ownership where contracted, and give Sales a globally consistent story with Deal Desk pricing discipline.</a:t>
             </a:r>
           </a:p>
         </p:txBody>
@@ -6740,8 +6844,8 @@
         </p:nvSpPr>
         <p:spPr>
           <a:xfrm>
-            <a:off x="502920" y="1645920"/>
-            <a:ext cx="3611880" cy="3246120"/>
+            <a:off x="502920" y="1600200"/>
+            <a:ext cx="3611880" cy="3200400"/>
           </a:xfrm>
           <a:prstGeom prst="roundRect">
             <a:avLst>
@@ -6785,7 +6889,7 @@
         </p:nvSpPr>
         <p:spPr>
           <a:xfrm>
-            <a:off x="502920" y="1645920"/>
+            <a:off x="502920" y="1600200"/>
             <a:ext cx="3611880" cy="73152"/>
           </a:xfrm>
           <a:prstGeom prst="rect">
@@ -6828,8 +6932,8 @@
         </p:nvSpPr>
         <p:spPr>
           <a:xfrm>
-            <a:off x="685800" y="1828800"/>
-            <a:ext cx="3246120" cy="2926080"/>
+            <a:off x="685800" y="1783080"/>
+            <a:ext cx="3246120" cy="2880360"/>
           </a:xfrm>
           <a:prstGeom prst="rect">
             <a:avLst/>
@@ -6843,9 +6947,6 @@
           <a:lstStyle/>
           <a:p>
             <a:pPr algn="l">
-              <a:spcBef>
-                <a:spcPts val="0"/>
-              </a:spcBef>
               <a:spcAft>
                 <a:spcPts val="200"/>
               </a:spcAft>
@@ -6862,9 +6963,6 @@
           </a:p>
           <a:p>
             <a:pPr algn="l">
-              <a:spcBef>
-                <a:spcPts val="0"/>
-              </a:spcBef>
               <a:spcAft>
                 <a:spcPts val="800"/>
               </a:spcAft>
@@ -6881,9 +6979,6 @@
           </a:p>
           <a:p>
             <a:pPr algn="l">
-              <a:spcBef>
-                <a:spcPts val="0"/>
-              </a:spcBef>
               <a:spcAft>
                 <a:spcPts val="400"/>
               </a:spcAft>
@@ -6895,14 +6990,11 @@
                 </a:solidFill>
                 <a:latin typeface="Calibri"/>
               </a:rPr>
-              <a:t>•  Backlog burn · SLA baseline</a:t>
-            </a:r>
-          </a:p>
-          <a:p>
-            <a:pPr algn="l">
-              <a:spcBef>
-                <a:spcPts val="0"/>
-              </a:spcBef>
+              <a:t>•  Backlog reduction · service-level baseline</a:t>
+            </a:r>
+          </a:p>
+          <a:p>
+            <a:pPr algn="l">
               <a:spcAft>
                 <a:spcPts val="400"/>
               </a:spcAft>
@@ -6914,14 +7006,11 @@
                 </a:solidFill>
                 <a:latin typeface="Calibri"/>
               </a:rPr>
-              <a:t>•  Single accountability · CPI board</a:t>
-            </a:r>
-          </a:p>
-          <a:p>
-            <a:pPr algn="l">
-              <a:spcBef>
-                <a:spcPts val="0"/>
-              </a:spcBef>
+              <a:t>•  Single accountability · monthly board</a:t>
+            </a:r>
+          </a:p>
+          <a:p>
+            <a:pPr algn="l">
               <a:spcAft>
                 <a:spcPts val="400"/>
               </a:spcAft>
@@ -6933,14 +7022,11 @@
                 </a:solidFill>
                 <a:latin typeface="Calibri"/>
               </a:rPr>
-              <a:t>•  Top-offender program</a:t>
-            </a:r>
-          </a:p>
-          <a:p>
-            <a:pPr algn="l">
-              <a:spcBef>
-                <a:spcPts val="0"/>
-              </a:spcBef>
+              <a:t>•  Top-offender (highest-impact) program</a:t>
+            </a:r>
+          </a:p>
+          <a:p>
+            <a:pPr algn="l">
               <a:spcAft>
                 <a:spcPts val="400"/>
               </a:spcAft>
@@ -6952,14 +7038,11 @@
                 </a:solidFill>
                 <a:latin typeface="Calibri"/>
               </a:rPr>
-              <a:t>•  Price: platform + app-class</a:t>
-            </a:r>
-          </a:p>
-          <a:p>
-            <a:pPr algn="l">
-              <a:spcBef>
-                <a:spcPts val="0"/>
-              </a:spcBef>
+              <a:t>•  Price: platform fee + criticality class</a:t>
+            </a:r>
+          </a:p>
+          <a:p>
+            <a:pPr algn="l">
               <a:spcAft>
                 <a:spcPts val="400"/>
               </a:spcAft>
@@ -6971,7 +7054,7 @@
                 </a:solidFill>
                 <a:latin typeface="Calibri"/>
               </a:rPr>
-              <a:t>•  Floor GM ≥ 22%</a:t>
+              <a:t>•  Floor gross margin ≥ 22%</a:t>
             </a:r>
           </a:p>
         </p:txBody>
@@ -6984,8 +7067,8 @@
         </p:nvSpPr>
         <p:spPr>
           <a:xfrm>
-            <a:off x="4297680" y="1645920"/>
-            <a:ext cx="3611880" cy="3246120"/>
+            <a:off x="4297680" y="1600200"/>
+            <a:ext cx="3611880" cy="3200400"/>
           </a:xfrm>
           <a:prstGeom prst="roundRect">
             <a:avLst>
@@ -7029,7 +7112,7 @@
         </p:nvSpPr>
         <p:spPr>
           <a:xfrm>
-            <a:off x="4297680" y="1645920"/>
+            <a:off x="4297680" y="1600200"/>
             <a:ext cx="3611880" cy="73152"/>
           </a:xfrm>
           <a:prstGeom prst="rect">
@@ -7072,8 +7155,8 @@
         </p:nvSpPr>
         <p:spPr>
           <a:xfrm>
-            <a:off x="4480560" y="1828800"/>
-            <a:ext cx="3246120" cy="2926080"/>
+            <a:off x="4480560" y="1783080"/>
+            <a:ext cx="3246120" cy="2880360"/>
           </a:xfrm>
           <a:prstGeom prst="rect">
             <a:avLst/>
@@ -7087,9 +7170,6 @@
           <a:lstStyle/>
           <a:p>
             <a:pPr algn="l">
-              <a:spcBef>
-                <a:spcPts val="0"/>
-              </a:spcBef>
               <a:spcAft>
                 <a:spcPts val="200"/>
               </a:spcAft>
@@ -7106,9 +7186,6 @@
           </a:p>
           <a:p>
             <a:pPr algn="l">
-              <a:spcBef>
-                <a:spcPts val="0"/>
-              </a:spcBef>
               <a:spcAft>
                 <a:spcPts val="800"/>
               </a:spcAft>
@@ -7120,14 +7197,11 @@
                 </a:solidFill>
                 <a:latin typeface="Calibri"/>
               </a:rPr>
-              <a:t>TCO &amp; MTTR proof</a:t>
-            </a:r>
-          </a:p>
-          <a:p>
-            <a:pPr algn="l">
-              <a:spcBef>
-                <a:spcPts val="0"/>
-              </a:spcBef>
+              <a:t>Prove efficiency</a:t>
+            </a:r>
+          </a:p>
+          <a:p>
+            <a:pPr algn="l">
               <a:spcAft>
                 <a:spcPts val="400"/>
               </a:spcAft>
@@ -7139,14 +7213,11 @@
                 </a:solidFill>
                 <a:latin typeface="Calibri"/>
               </a:rPr>
-              <a:t>•  + Unified observability / SPOG</a:t>
-            </a:r>
-          </a:p>
-          <a:p>
-            <a:pPr algn="l">
-              <a:spcBef>
-                <a:spcPts val="0"/>
-              </a:spcBef>
+              <a:t>•  + Standard monitoring / correlation pack</a:t>
+            </a:r>
+          </a:p>
+          <a:p>
+            <a:pPr algn="l">
               <a:spcAft>
                 <a:spcPts val="400"/>
               </a:spcAft>
@@ -7158,14 +7229,11 @@
                 </a:solidFill>
                 <a:latin typeface="Calibri"/>
               </a:rPr>
-              <a:t>•  + GenAI SOP · automation factory</a:t>
-            </a:r>
-          </a:p>
-          <a:p>
-            <a:pPr algn="l">
-              <a:spcBef>
-                <a:spcPts val="0"/>
-              </a:spcBef>
+              <a:t>•  + Runbook automation · proactive problems</a:t>
+            </a:r>
+          </a:p>
+          <a:p>
+            <a:pPr algn="l">
               <a:spcAft>
                 <a:spcPts val="400"/>
               </a:spcAft>
@@ -7177,14 +7245,11 @@
                 </a:solidFill>
                 <a:latin typeface="Calibri"/>
               </a:rPr>
-              <a:t>•  Outcome-band pricing</a:t>
-            </a:r>
-          </a:p>
-          <a:p>
-            <a:pPr algn="l">
-              <a:spcBef>
-                <a:spcPts val="0"/>
-              </a:spcBef>
+              <a:t>•  Outcome-band pricing vs service levels</a:t>
+            </a:r>
+          </a:p>
+          <a:p>
+            <a:pPr algn="l">
               <a:spcAft>
                 <a:spcPts val="400"/>
               </a:spcAft>
@@ -7196,14 +7261,11 @@
                 </a:solidFill>
                 <a:latin typeface="Calibri"/>
               </a:rPr>
-              <a:t>•  Gain-share on TCO proof</a:t>
-            </a:r>
-          </a:p>
-          <a:p>
-            <a:pPr algn="l">
-              <a:spcBef>
-                <a:spcPts val="0"/>
-              </a:spcBef>
+              <a:t>•  Optional gain-share on proven savings</a:t>
+            </a:r>
+          </a:p>
+          <a:p>
+            <a:pPr algn="l">
               <a:spcAft>
                 <a:spcPts val="400"/>
               </a:spcAft>
@@ -7215,7 +7277,7 @@
                 </a:solidFill>
                 <a:latin typeface="Calibri"/>
               </a:rPr>
-              <a:t>•  Floor GM ≥ 26%</a:t>
+              <a:t>•  Floor gross margin ≥ 26%</a:t>
             </a:r>
           </a:p>
         </p:txBody>
@@ -7228,8 +7290,8 @@
         </p:nvSpPr>
         <p:spPr>
           <a:xfrm>
-            <a:off x="8092440" y="1645920"/>
-            <a:ext cx="3611880" cy="3246120"/>
+            <a:off x="8092440" y="1600200"/>
+            <a:ext cx="3611880" cy="3200400"/>
           </a:xfrm>
           <a:prstGeom prst="roundRect">
             <a:avLst>
@@ -7273,7 +7335,7 @@
         </p:nvSpPr>
         <p:spPr>
           <a:xfrm>
-            <a:off x="8092440" y="1645920"/>
+            <a:off x="8092440" y="1600200"/>
             <a:ext cx="3611880" cy="73152"/>
           </a:xfrm>
           <a:prstGeom prst="rect">
@@ -7316,8 +7378,8 @@
         </p:nvSpPr>
         <p:spPr>
           <a:xfrm>
-            <a:off x="8275320" y="1828800"/>
-            <a:ext cx="3246120" cy="2926080"/>
+            <a:off x="8275320" y="1783080"/>
+            <a:ext cx="3246120" cy="2880360"/>
           </a:xfrm>
           <a:prstGeom prst="rect">
             <a:avLst/>
@@ -7331,9 +7393,6 @@
           <a:lstStyle/>
           <a:p>
             <a:pPr algn="l">
-              <a:spcBef>
-                <a:spcPts val="0"/>
-              </a:spcBef>
               <a:spcAft>
                 <a:spcPts val="200"/>
               </a:spcAft>
@@ -7345,14 +7404,11 @@
                 </a:solidFill>
                 <a:latin typeface="Calibri"/>
               </a:rPr>
-              <a:t>AUTONOMIZE</a:t>
-            </a:r>
-          </a:p>
-          <a:p>
-            <a:pPr algn="l">
-              <a:spcBef>
-                <a:spcPts val="0"/>
-              </a:spcBef>
+              <a:t>TRANSFORM</a:t>
+            </a:r>
+          </a:p>
+          <a:p>
+            <a:pPr algn="l">
               <a:spcAft>
                 <a:spcPts val="800"/>
               </a:spcAft>
@@ -7364,14 +7420,11 @@
                 </a:solidFill>
                 <a:latin typeface="Calibri"/>
               </a:rPr>
-              <a:t>Path to L3–L4 autonomy</a:t>
-            </a:r>
-          </a:p>
-          <a:p>
-            <a:pPr algn="l">
-              <a:spcBef>
-                <a:spcPts val="0"/>
-              </a:spcBef>
+              <a:t>Operating-model uplift</a:t>
+            </a:r>
+          </a:p>
+          <a:p>
+            <a:pPr algn="l">
               <a:spcAft>
                 <a:spcPts val="400"/>
               </a:spcAft>
@@ -7383,14 +7436,11 @@
                 </a:solidFill>
                 <a:latin typeface="Calibri"/>
               </a:rPr>
-              <a:t>•  + Closed-loop · policy packs</a:t>
-            </a:r>
-          </a:p>
-          <a:p>
-            <a:pPr algn="l">
-              <a:spcBef>
-                <a:spcPts val="0"/>
-              </a:spcBef>
+              <a:t>•  + Continuous-improvement factory</a:t>
+            </a:r>
+          </a:p>
+          <a:p>
+            <a:pPr algn="l">
               <a:spcAft>
                 <a:spcPts val="400"/>
               </a:spcAft>
@@ -7402,14 +7452,11 @@
                 </a:solidFill>
                 <a:latin typeface="Calibri"/>
               </a:rPr>
-              <a:t>•  + Soft-ramp CPI contract</a:t>
-            </a:r>
-          </a:p>
-          <a:p>
-            <a:pPr algn="l">
-              <a:spcBef>
-                <a:spcPts val="0"/>
-              </a:spcBef>
+              <a:t>•  + Policy-based standard changes</a:t>
+            </a:r>
+          </a:p>
+          <a:p>
+            <a:pPr algn="l">
               <a:spcAft>
                 <a:spcPts val="400"/>
               </a:spcAft>
@@ -7421,14 +7468,11 @@
                 </a:solidFill>
                 <a:latin typeface="Calibri"/>
               </a:rPr>
-              <a:t>•  Milestone + performance</a:t>
-            </a:r>
-          </a:p>
-          <a:p>
-            <a:pPr algn="l">
-              <a:spcBef>
-                <a:spcPts val="0"/>
-              </a:spcBef>
+              <a:t>•  Milestone elements (Finance sign-off)</a:t>
+            </a:r>
+          </a:p>
+          <a:p>
+            <a:pPr algn="l">
               <a:spcAft>
                 <a:spcPts val="400"/>
               </a:spcAft>
@@ -7440,14 +7484,11 @@
                 </a:solidFill>
                 <a:latin typeface="Calibri"/>
               </a:rPr>
-              <a:t>•  On-ramp to reusable AO SKU</a:t>
-            </a:r>
-          </a:p>
-          <a:p>
-            <a:pPr algn="l">
-              <a:spcBef>
-                <a:spcPts val="0"/>
-              </a:spcBef>
+              <a:t>•  Executive scorecard · fewer fire drills</a:t>
+            </a:r>
+          </a:p>
+          <a:p>
+            <a:pPr algn="l">
               <a:spcAft>
                 <a:spcPts val="400"/>
               </a:spcAft>
@@ -7459,7 +7500,7 @@
                 </a:solidFill>
                 <a:latin typeface="Calibri"/>
               </a:rPr>
-              <a:t>•  Floor GM ≥ 30%</a:t>
+              <a:t>•  Floor gross margin ≥ 28%</a:t>
             </a:r>
           </a:p>
         </p:txBody>
@@ -7472,8 +7513,8 @@
         </p:nvSpPr>
         <p:spPr>
           <a:xfrm>
-            <a:off x="502920" y="5074920"/>
-            <a:ext cx="11155680" cy="1051560"/>
+            <a:off x="502920" y="5029200"/>
+            <a:ext cx="11155680" cy="1097280"/>
           </a:xfrm>
           <a:prstGeom prst="roundRect">
             <a:avLst>
@@ -7517,8 +7558,8 @@
         </p:nvSpPr>
         <p:spPr>
           <a:xfrm>
-            <a:off x="685800" y="5166360"/>
-            <a:ext cx="10789920" cy="868680"/>
+            <a:off x="685800" y="5120640"/>
+            <a:ext cx="10789920" cy="914400"/>
           </a:xfrm>
           <a:prstGeom prst="rect">
             <a:avLst/>
@@ -7532,40 +7573,34 @@
           <a:lstStyle/>
           <a:p>
             <a:pPr algn="l">
-              <a:spcBef>
+              <a:spcAft>
+                <a:spcPts val="400"/>
+              </a:spcAft>
+            </a:pPr>
+            <a:r>
+              <a:rPr sz="1100" b="1">
+                <a:solidFill>
+                  <a:srgbClr val="58A6FF"/>
+                </a:solidFill>
+                <a:latin typeface="Calibri"/>
+              </a:rPr>
+              <a:t>MODULAR ATTACH PACKS  ·  PRICED, NOT FREE</a:t>
+            </a:r>
+          </a:p>
+          <a:p>
+            <a:pPr algn="l">
+              <a:spcAft>
                 <a:spcPts val="0"/>
-              </a:spcBef>
-              <a:spcAft>
-                <a:spcPts val="400"/>
-              </a:spcAft>
-            </a:pPr>
-            <a:r>
-              <a:rPr sz="1100" b="1">
-                <a:solidFill>
-                  <a:srgbClr val="58A6FF"/>
-                </a:solidFill>
-                <a:latin typeface="Calibri"/>
-              </a:rPr>
-              <a:t>MODULAR ATTACH  ·  priced, not free</a:t>
-            </a:r>
-          </a:p>
-          <a:p>
-            <a:pPr algn="l">
-              <a:spcBef>
-                <a:spcPts val="0"/>
-              </a:spcBef>
-              <a:spcAft>
-                <a:spcPts val="0"/>
-              </a:spcAft>
-            </a:pPr>
-            <a:r>
-              <a:rPr sz="1300" b="0">
+              </a:spcAft>
+            </a:pPr>
+            <a:r>
+              <a:rPr sz="1200" b="0">
                 <a:solidFill>
                   <a:srgbClr val="E6EDF3"/>
                 </a:solidFill>
                 <a:latin typeface="Calibri"/>
               </a:rPr>
-              <a:t>Observability jump-start (90d)   ·   Top-offender sprint (6mo)   ·   Transition accelerator (mandatory KT)   ·   Vendor-consolidation bridge   ·   FTE sizing stays internal — customer buys service class &amp; CPI attainment</a:t>
+              <a:t>Mandatory: Transition / knowledge-transfer module on new logos.  Optional: top-offender sprint · monitoring jump-start.  Multi-vendor governance pack — ONLY when win/loss shows consolidation demand (applicable possibility, not required strategy).</a:t>
             </a:r>
           </a:p>
         </p:txBody>
@@ -7593,9 +7628,6 @@
           <a:lstStyle/>
           <a:p>
             <a:pPr algn="l">
-              <a:spcBef>
-                <a:spcPts val="0"/>
-              </a:spcBef>
               <a:spcAft>
                 <a:spcPts val="0"/>
               </a:spcAft>
@@ -7635,9 +7667,6 @@
           <a:lstStyle/>
           <a:p>
             <a:pPr algn="r">
-              <a:spcBef>
-                <a:spcPts val="0"/>
-              </a:spcBef>
               <a:spcAft>
                 <a:spcPts val="0"/>
               </a:spcAft>
@@ -7732,69 +7761,63 @@
           <a:noFill/>
         </p:spPr>
         <p:txBody>
+          <a:bodyPr wrap="none">
+            <a:spAutoFit/>
+          </a:bodyPr>
+          <a:lstStyle/>
+          <a:p>
+            <a:pPr algn="l">
+              <a:spcAft>
+                <a:spcPts val="0"/>
+              </a:spcAft>
+            </a:pPr>
+            <a:r>
+              <a:rPr sz="1100" b="1">
+                <a:solidFill>
+                  <a:srgbClr val="58A6FF"/>
+                </a:solidFill>
+                <a:latin typeface="Calibri"/>
+              </a:rPr>
+              <a:t>COMMERCIAL GUARDRAILS  ·  INVESTMENT SEQUENCING</a:t>
+            </a:r>
+          </a:p>
+        </p:txBody>
+      </p:sp>
+      <p:sp>
+        <p:nvSpPr>
+          <p:cNvPr id="4" name="TextBox 3"/>
+          <p:cNvSpPr txBox="1"/>
+          <p:nvPr/>
+        </p:nvSpPr>
+        <p:spPr>
+          <a:xfrm>
+            <a:off x="502920" y="475488"/>
+            <a:ext cx="11155680" cy="640080"/>
+          </a:xfrm>
+          <a:prstGeom prst="rect">
+            <a:avLst/>
+          </a:prstGeom>
+          <a:noFill/>
+        </p:spPr>
+        <p:txBody>
           <a:bodyPr wrap="square">
             <a:spAutoFit/>
           </a:bodyPr>
           <a:lstStyle/>
           <a:p>
             <a:pPr algn="l">
-              <a:spcBef>
+              <a:spcAft>
                 <a:spcPts val="0"/>
-              </a:spcBef>
-              <a:spcAft>
-                <a:spcPts val="0"/>
-              </a:spcAft>
-            </a:pPr>
-            <a:r>
-              <a:rPr sz="1100" b="1">
-                <a:solidFill>
-                  <a:srgbClr val="58A6FF"/>
-                </a:solidFill>
-                <a:latin typeface="Calibri"/>
-              </a:rPr>
-              <a:t>COMMERCIAL GUARDRAILS  ·  INVESTMENT SEQUENCING</a:t>
-            </a:r>
-          </a:p>
-        </p:txBody>
-      </p:sp>
-      <p:sp>
-        <p:nvSpPr>
-          <p:cNvPr id="4" name="TextBox 3"/>
-          <p:cNvSpPr txBox="1"/>
-          <p:nvPr/>
-        </p:nvSpPr>
-        <p:spPr>
-          <a:xfrm>
-            <a:off x="502920" y="475488"/>
-            <a:ext cx="11155680" cy="640080"/>
-          </a:xfrm>
-          <a:prstGeom prst="rect">
-            <a:avLst/>
-          </a:prstGeom>
-          <a:noFill/>
-        </p:spPr>
-        <p:txBody>
-          <a:bodyPr wrap="square">
-            <a:spAutoFit/>
-          </a:bodyPr>
-          <a:lstStyle/>
-          <a:p>
-            <a:pPr algn="l">
-              <a:spcBef>
-                <a:spcPts val="0"/>
-              </a:spcBef>
-              <a:spcAft>
-                <a:spcPts val="0"/>
-              </a:spcAft>
-            </a:pPr>
-            <a:r>
-              <a:rPr sz="2800" b="1">
+              </a:spcAft>
+            </a:pPr>
+            <a:r>
+              <a:rPr sz="2600" b="1">
                 <a:solidFill>
                   <a:srgbClr val="D4A853"/>
                 </a:solidFill>
                 <a:latin typeface="Calibri"/>
               </a:rPr>
-              <a:t>Deal Desk rules that stop the bleed — fund ROI first</a:t>
+              <a:t>Deal Desk rules that stop the bleed — fund return first</a:t>
             </a:r>
           </a:p>
         </p:txBody>
@@ -7807,8 +7830,8 @@
         </p:nvSpPr>
         <p:spPr>
           <a:xfrm>
-            <a:off x="502920" y="1188720"/>
-            <a:ext cx="5760720" cy="4937760"/>
+            <a:off x="502920" y="1143000"/>
+            <a:ext cx="5760720" cy="4983480"/>
           </a:xfrm>
           <a:prstGeom prst="roundRect">
             <a:avLst>
@@ -7852,8 +7875,8 @@
         </p:nvSpPr>
         <p:spPr>
           <a:xfrm>
-            <a:off x="685800" y="1325880"/>
-            <a:ext cx="5394960" cy="4663440"/>
+            <a:off x="685800" y="1280160"/>
+            <a:ext cx="5394960" cy="4709160"/>
           </a:xfrm>
           <a:prstGeom prst="rect">
             <a:avLst/>
@@ -7867,9 +7890,6 @@
           <a:lstStyle/>
           <a:p>
             <a:pPr algn="l">
-              <a:spcBef>
-                <a:spcPts val="0"/>
-              </a:spcBef>
               <a:spcAft>
                 <a:spcPts val="1000"/>
               </a:spcAft>
@@ -7886,9 +7906,6 @@
           </a:p>
           <a:p>
             <a:pPr algn="l">
-              <a:spcBef>
-                <a:spcPts val="0"/>
-              </a:spcBef>
               <a:spcAft>
                 <a:spcPts val="100"/>
               </a:spcAft>
@@ -7900,14 +7917,11 @@
                 </a:solidFill>
                 <a:latin typeface="Calibri"/>
               </a:rPr>
-              <a:t>Floor GM%</a:t>
-            </a:r>
-          </a:p>
-          <a:p>
-            <a:pPr algn="l">
-              <a:spcBef>
-                <a:spcPts val="0"/>
-              </a:spcBef>
+              <a:t>Floor gross margin</a:t>
+            </a:r>
+          </a:p>
+          <a:p>
+            <a:pPr algn="l">
               <a:spcAft>
                 <a:spcPts val="800"/>
               </a:spcAft>
@@ -7919,14 +7933,11 @@
                 </a:solidFill>
                 <a:latin typeface="Calibri"/>
               </a:rPr>
-              <a:t>Stabilize ≥22% · Optimize ≥26% · Autonomize ≥30%</a:t>
-            </a:r>
-          </a:p>
-          <a:p>
-            <a:pPr algn="l">
-              <a:spcBef>
-                <a:spcPts val="0"/>
-              </a:spcBef>
+              <a:t>Stabilize ≥22% · Optimize ≥26% · Transform ≥28%</a:t>
+            </a:r>
+          </a:p>
+          <a:p>
+            <a:pPr algn="l">
               <a:spcAft>
                 <a:spcPts val="100"/>
               </a:spcAft>
@@ -7938,14 +7949,11 @@
                 </a:solidFill>
                 <a:latin typeface="Calibri"/>
               </a:rPr>
-              <a:t>Max discount</a:t>
-            </a:r>
-          </a:p>
-          <a:p>
-            <a:pPr algn="l">
-              <a:spcBef>
-                <a:spcPts val="0"/>
-              </a:spcBef>
+              <a:t>Maximum discount</a:t>
+            </a:r>
+          </a:p>
+          <a:p>
+            <a:pPr algn="l">
               <a:spcAft>
                 <a:spcPts val="800"/>
               </a:spcAft>
@@ -7962,9 +7970,6 @@
           </a:p>
           <a:p>
             <a:pPr algn="l">
-              <a:spcBef>
-                <a:spcPts val="0"/>
-              </a:spcBef>
               <a:spcAft>
                 <a:spcPts val="100"/>
               </a:spcAft>
@@ -7976,14 +7981,11 @@
                 </a:solidFill>
                 <a:latin typeface="Calibri"/>
               </a:rPr>
-              <a:t>Transition</a:t>
-            </a:r>
-          </a:p>
-          <a:p>
-            <a:pPr algn="l">
-              <a:spcBef>
-                <a:spcPts val="0"/>
-              </a:spcBef>
+              <a:t>Transition pricing</a:t>
+            </a:r>
+          </a:p>
+          <a:p>
+            <a:pPr algn="l">
               <a:spcAft>
                 <a:spcPts val="800"/>
               </a:spcAft>
@@ -7995,14 +7997,11 @@
                 </a:solidFill>
                 <a:latin typeface="Calibri"/>
               </a:rPr>
-              <a:t>KT module mandatory on new logos · min 8% of Y1 ACV</a:t>
-            </a:r>
-          </a:p>
-          <a:p>
-            <a:pPr algn="l">
-              <a:spcBef>
-                <a:spcPts val="0"/>
-              </a:spcBef>
+              <a:t>Knowledge-transfer mandatory · min 8% of Year-1 contract value</a:t>
+            </a:r>
+          </a:p>
+          <a:p>
+            <a:pPr algn="l">
               <a:spcAft>
                 <a:spcPts val="100"/>
               </a:spcAft>
@@ -8014,14 +8013,11 @@
                 </a:solidFill>
                 <a:latin typeface="Calibri"/>
               </a:rPr>
-              <a:t>Scope CR</a:t>
-            </a:r>
-          </a:p>
-          <a:p>
-            <a:pPr algn="l">
-              <a:spcBef>
-                <a:spcPts val="0"/>
-              </a:spcBef>
+              <a:t>Scope change</a:t>
+            </a:r>
+          </a:p>
+          <a:p>
+            <a:pPr algn="l">
               <a:spcAft>
                 <a:spcPts val="800"/>
               </a:spcAft>
@@ -8033,14 +8029,11 @@
                 </a:solidFill>
                 <a:latin typeface="Calibri"/>
               </a:rPr>
-              <a:t>Unpaid work cap 2% ACV · 5-day CR cycle</a:t>
-            </a:r>
-          </a:p>
-          <a:p>
-            <a:pPr algn="l">
-              <a:spcBef>
-                <a:spcPts val="0"/>
-              </a:spcBef>
+              <a:t>Unpaid work cap 2% of annual contract value · 5-day cycle</a:t>
+            </a:r>
+          </a:p>
+          <a:p>
+            <a:pPr algn="l">
               <a:spcAft>
                 <a:spcPts val="100"/>
               </a:spcAft>
@@ -8057,9 +8050,6 @@
           </a:p>
           <a:p>
             <a:pPr algn="l">
-              <a:spcBef>
-                <a:spcPts val="0"/>
-              </a:spcBef>
               <a:spcAft>
                 <a:spcPts val="800"/>
               </a:spcAft>
@@ -8076,9 +8066,6 @@
           </a:p>
           <a:p>
             <a:pPr algn="l">
-              <a:spcBef>
-                <a:spcPts val="0"/>
-              </a:spcBef>
               <a:spcAft>
                 <a:spcPts val="100"/>
               </a:spcAft>
@@ -8090,14 +8077,11 @@
                 </a:solidFill>
                 <a:latin typeface="Calibri"/>
               </a:rPr>
-              <a:t>CPI / penalty</a:t>
-            </a:r>
-          </a:p>
-          <a:p>
-            <a:pPr algn="l">
-              <a:spcBef>
-                <a:spcPts val="0"/>
-              </a:spcBef>
+              <a:t>Credits / penalties</a:t>
+            </a:r>
+          </a:p>
+          <a:p>
+            <a:pPr algn="l">
               <a:spcAft>
                 <a:spcPts val="800"/>
               </a:spcAft>
@@ -8109,7 +8093,7 @@
                 </a:solidFill>
                 <a:latin typeface="Calibri"/>
               </a:rPr>
-              <a:t>Soft-ramp M1–6 · credit caps · Finance rev-rec sign-off</a:t>
+              <a:t>Soft-ramp months 1–6 · Finance revenue-recognition sign-off</a:t>
             </a:r>
           </a:p>
         </p:txBody>
@@ -8122,7 +8106,7 @@
         </p:nvSpPr>
         <p:spPr>
           <a:xfrm>
-            <a:off x="6446520" y="1188720"/>
+            <a:off x="6446520" y="1143000"/>
             <a:ext cx="5212080" cy="2880360"/>
           </a:xfrm>
           <a:prstGeom prst="roundRect">
@@ -8167,7 +8151,7 @@
         </p:nvSpPr>
         <p:spPr>
           <a:xfrm>
-            <a:off x="6629400" y="1325880"/>
+            <a:off x="6629400" y="1280160"/>
             <a:ext cx="4846320" cy="2651760"/>
           </a:xfrm>
           <a:prstGeom prst="rect">
@@ -8182,9 +8166,6 @@
           <a:lstStyle/>
           <a:p>
             <a:pPr algn="l">
-              <a:spcBef>
-                <a:spcPts val="0"/>
-              </a:spcBef>
               <a:spcAft>
                 <a:spcPts val="800"/>
               </a:spcAft>
@@ -8196,14 +8177,11 @@
                 </a:solidFill>
                 <a:latin typeface="Calibri"/>
               </a:rPr>
-              <a:t>FUND  ·  HIGH ROI</a:t>
-            </a:r>
-          </a:p>
-          <a:p>
-            <a:pPr algn="l">
-              <a:spcBef>
-                <a:spcPts val="0"/>
-              </a:spcBef>
+              <a:t>FUND  ·  HIGH RETURN</a:t>
+            </a:r>
+          </a:p>
+          <a:p>
+            <a:pPr algn="l">
               <a:spcAft>
                 <a:spcPts val="600"/>
               </a:spcAft>
@@ -8215,14 +8193,11 @@
                 </a:solidFill>
                 <a:latin typeface="Calibri"/>
               </a:rPr>
-              <a:t>▸  Q1: Global rate card · tier SKUs · ROI calc · Deal Desk rules</a:t>
-            </a:r>
-          </a:p>
-          <a:p>
-            <a:pPr algn="l">
-              <a:spcBef>
-                <a:spcPts val="0"/>
-              </a:spcBef>
+              <a:t>▸  Q1: Rate card · tier definitions · Deal Desk toolkit</a:t>
+            </a:r>
+          </a:p>
+          <a:p>
+            <a:pPr algn="l">
               <a:spcAft>
                 <a:spcPts val="600"/>
               </a:spcAft>
@@ -8234,14 +8209,11 @@
                 </a:solidFill>
                 <a:latin typeface="Calibri"/>
               </a:rPr>
-              <a:t>▸  Q2: CPI catalogue · transition factory · 2 regional pilots</a:t>
-            </a:r>
-          </a:p>
-          <a:p>
-            <a:pPr algn="l">
-              <a:spcBef>
-                <a:spcPts val="0"/>
-              </a:spcBef>
+              <a:t>▸  Q2: Service-level catalogue · transition factory · 2 pilots</a:t>
+            </a:r>
+          </a:p>
+          <a:p>
+            <a:pPr algn="l">
               <a:spcAft>
                 <a:spcPts val="600"/>
               </a:spcAft>
@@ -8253,14 +8225,11 @@
                 </a:solidFill>
                 <a:latin typeface="Calibri"/>
               </a:rPr>
-              <a:t>▸  Q3–4: Observability pack · SPOG · automation library · renewals</a:t>
-            </a:r>
-          </a:p>
-          <a:p>
-            <a:pPr algn="l">
-              <a:spcBef>
-                <a:spcPts val="0"/>
-              </a:spcBef>
+              <a:t>▸  Q3–4: Modular packs · renewal step-up · scale enablement</a:t>
+            </a:r>
+          </a:p>
+          <a:p>
+            <a:pPr algn="l">
               <a:spcAft>
                 <a:spcPts val="600"/>
               </a:spcAft>
@@ -8272,7 +8241,7 @@
                 </a:solidFill>
                 <a:latin typeface="Calibri"/>
               </a:rPr>
-              <a:t>▸  Y2: Autonomize scale → merge with reusable AO offering</a:t>
+              <a:t>▸  Year 2: Retire headcount-only contracts on renewal</a:t>
             </a:r>
           </a:p>
         </p:txBody>
@@ -8285,8 +8254,8 @@
         </p:nvSpPr>
         <p:spPr>
           <a:xfrm>
-            <a:off x="6446520" y="4251960"/>
-            <a:ext cx="5212080" cy="1874519"/>
+            <a:off x="6446520" y="4206240"/>
+            <a:ext cx="5212080" cy="1920240"/>
           </a:xfrm>
           <a:prstGeom prst="roundRect">
             <a:avLst>
@@ -8330,8 +8299,8 @@
         </p:nvSpPr>
         <p:spPr>
           <a:xfrm>
-            <a:off x="6629400" y="4389120"/>
-            <a:ext cx="4846320" cy="1645920"/>
+            <a:off x="6629400" y="4343400"/>
+            <a:ext cx="4846320" cy="1691640"/>
           </a:xfrm>
           <a:prstGeom prst="rect">
             <a:avLst/>
@@ -8345,9 +8314,6 @@
           <a:lstStyle/>
           <a:p>
             <a:pPr algn="l">
-              <a:spcBef>
-                <a:spcPts val="0"/>
-              </a:spcBef>
               <a:spcAft>
                 <a:spcPts val="800"/>
               </a:spcAft>
@@ -8364,9 +8330,6 @@
           </a:p>
           <a:p>
             <a:pPr algn="l">
-              <a:spcBef>
-                <a:spcPts val="0"/>
-              </a:spcBef>
               <a:spcAft>
                 <a:spcPts val="400"/>
               </a:spcAft>
@@ -8378,14 +8341,11 @@
                 </a:solidFill>
                 <a:latin typeface="Calibri"/>
               </a:rPr>
-              <a:t>×  Per-account custom observability builds</a:t>
-            </a:r>
-          </a:p>
-          <a:p>
-            <a:pPr algn="l">
-              <a:spcBef>
-                <a:spcPts val="0"/>
-              </a:spcBef>
+              <a:t>×  Per-account custom tooling builds</a:t>
+            </a:r>
+          </a:p>
+          <a:p>
+            <a:pPr algn="l">
               <a:spcAft>
                 <a:spcPts val="400"/>
               </a:spcAft>
@@ -8397,14 +8357,11 @@
                 </a:solidFill>
                 <a:latin typeface="Calibri"/>
               </a:rPr>
-              <a:t>×  Below-floor PoCs to “win logo”</a:t>
-            </a:r>
-          </a:p>
-          <a:p>
-            <a:pPr algn="l">
-              <a:spcBef>
-                <a:spcPts val="0"/>
-              </a:spcBef>
+              <a:t>×  Below-floor proofs of concept to “win logo”</a:t>
+            </a:r>
+          </a:p>
+          <a:p>
+            <a:pPr algn="l">
               <a:spcAft>
                 <a:spcPts val="400"/>
               </a:spcAft>
@@ -8421,9 +8378,6 @@
           </a:p>
           <a:p>
             <a:pPr algn="l">
-              <a:spcBef>
-                <a:spcPts val="0"/>
-              </a:spcBef>
               <a:spcAft>
                 <a:spcPts val="400"/>
               </a:spcAft>
@@ -8435,7 +8389,7 @@
                 </a:solidFill>
                 <a:latin typeface="Calibri"/>
               </a:rPr>
-              <a:t>×  Rebrand without sales / Deal Desk kit</a:t>
+              <a:t>×  Rebrand without Sales / Deal Desk kit</a:t>
             </a:r>
           </a:p>
         </p:txBody>
@@ -8463,9 +8417,6 @@
           <a:lstStyle/>
           <a:p>
             <a:pPr algn="l">
-              <a:spcBef>
-                <a:spcPts val="0"/>
-              </a:spcBef>
               <a:spcAft>
                 <a:spcPts val="0"/>
               </a:spcAft>
@@ -8505,9 +8456,6 @@
           <a:lstStyle/>
           <a:p>
             <a:pPr algn="r">
-              <a:spcBef>
-                <a:spcPts val="0"/>
-              </a:spcBef>
               <a:spcAft>
                 <a:spcPts val="0"/>
               </a:spcAft>
@@ -8602,69 +8550,63 @@
           <a:noFill/>
         </p:spPr>
         <p:txBody>
+          <a:bodyPr wrap="none">
+            <a:spAutoFit/>
+          </a:bodyPr>
+          <a:lstStyle/>
+          <a:p>
+            <a:pPr algn="l">
+              <a:spcAft>
+                <a:spcPts val="0"/>
+              </a:spcAft>
+            </a:pPr>
+            <a:r>
+              <a:rPr sz="1100" b="1">
+                <a:solidFill>
+                  <a:srgbClr val="58A6FF"/>
+                </a:solidFill>
+                <a:latin typeface="Calibri"/>
+              </a:rPr>
+              <a:t>CROSS-FUNCTIONAL ALIGNMENT  ·  SUCCESS METRICS AND FEEDBACK LOOP</a:t>
+            </a:r>
+          </a:p>
+        </p:txBody>
+      </p:sp>
+      <p:sp>
+        <p:nvSpPr>
+          <p:cNvPr id="4" name="TextBox 3"/>
+          <p:cNvSpPr txBox="1"/>
+          <p:nvPr/>
+        </p:nvSpPr>
+        <p:spPr>
+          <a:xfrm>
+            <a:off x="502920" y="475488"/>
+            <a:ext cx="11155680" cy="640080"/>
+          </a:xfrm>
+          <a:prstGeom prst="rect">
+            <a:avLst/>
+          </a:prstGeom>
+          <a:noFill/>
+        </p:spPr>
+        <p:txBody>
           <a:bodyPr wrap="square">
             <a:spAutoFit/>
           </a:bodyPr>
           <a:lstStyle/>
           <a:p>
             <a:pPr algn="l">
-              <a:spcBef>
+              <a:spcAft>
                 <a:spcPts val="0"/>
-              </a:spcBef>
-              <a:spcAft>
-                <a:spcPts val="0"/>
-              </a:spcAft>
-            </a:pPr>
-            <a:r>
-              <a:rPr sz="1100" b="1">
-                <a:solidFill>
-                  <a:srgbClr val="58A6FF"/>
-                </a:solidFill>
-                <a:latin typeface="Calibri"/>
-              </a:rPr>
-              <a:t>CROSS-FUNCTIONAL ALIGNMENT  ·  SUCCESS METRICS &amp; FEEDBACK LOOP</a:t>
-            </a:r>
-          </a:p>
-        </p:txBody>
-      </p:sp>
-      <p:sp>
-        <p:nvSpPr>
-          <p:cNvPr id="4" name="TextBox 3"/>
-          <p:cNvSpPr txBox="1"/>
-          <p:nvPr/>
-        </p:nvSpPr>
-        <p:spPr>
-          <a:xfrm>
-            <a:off x="502920" y="475488"/>
-            <a:ext cx="11155680" cy="640080"/>
-          </a:xfrm>
-          <a:prstGeom prst="rect">
-            <a:avLst/>
-          </a:prstGeom>
-          <a:noFill/>
-        </p:spPr>
-        <p:txBody>
-          <a:bodyPr wrap="square">
-            <a:spAutoFit/>
-          </a:bodyPr>
-          <a:lstStyle/>
-          <a:p>
-            <a:pPr algn="l">
-              <a:spcBef>
-                <a:spcPts val="0"/>
-              </a:spcBef>
-              <a:spcAft>
-                <a:spcPts val="0"/>
-              </a:spcAft>
-            </a:pPr>
-            <a:r>
-              <a:rPr sz="2800" b="1">
+              </a:spcAft>
+            </a:pPr>
+            <a:r>
+              <a:rPr sz="2600" b="1">
                 <a:solidFill>
                   <a:srgbClr val="D4A853"/>
                 </a:solidFill>
                 <a:latin typeface="Calibri"/>
               </a:rPr>
-              <a:t>One program — Sales, Marketing, Finance, Regions</a:t>
+              <a:t>One program — Sales, Marketing, Finance, regions</a:t>
             </a:r>
           </a:p>
         </p:txBody>
@@ -8677,7 +8619,7 @@
         </p:nvSpPr>
         <p:spPr>
           <a:xfrm>
-            <a:off x="502920" y="1188720"/>
+            <a:off x="502920" y="1143000"/>
             <a:ext cx="2743200" cy="2331720"/>
           </a:xfrm>
           <a:prstGeom prst="roundRect">
@@ -8722,7 +8664,7 @@
         </p:nvSpPr>
         <p:spPr>
           <a:xfrm>
-            <a:off x="502920" y="1188720"/>
+            <a:off x="502920" y="1143000"/>
             <a:ext cx="73152" cy="2331720"/>
           </a:xfrm>
           <a:prstGeom prst="rect">
@@ -8765,7 +8707,7 @@
         </p:nvSpPr>
         <p:spPr>
           <a:xfrm>
-            <a:off x="685800" y="1325880"/>
+            <a:off x="685800" y="1280160"/>
             <a:ext cx="2423160" cy="2057400"/>
           </a:xfrm>
           <a:prstGeom prst="rect">
@@ -8780,49 +8722,40 @@
           <a:lstStyle/>
           <a:p>
             <a:pPr algn="l">
-              <a:spcBef>
+              <a:spcAft>
+                <a:spcPts val="600"/>
+              </a:spcAft>
+            </a:pPr>
+            <a:r>
+              <a:rPr sz="1100" b="1">
+                <a:solidFill>
+                  <a:srgbClr val="58A6FF"/>
+                </a:solidFill>
+                <a:latin typeface="Calibri"/>
+              </a:rPr>
+              <a:t>SALES / DEAL DESK</a:t>
+            </a:r>
+          </a:p>
+          <a:p>
+            <a:pPr algn="l">
+              <a:spcAft>
+                <a:spcPts val="600"/>
+              </a:spcAft>
+            </a:pPr>
+            <a:r>
+              <a:rPr sz="1300" b="1">
+                <a:solidFill>
+                  <a:srgbClr val="E6EDF3"/>
+                </a:solidFill>
+                <a:latin typeface="Calibri"/>
+              </a:rPr>
+              <a:t>≥80% of bids on tier + rate card by Quarter 2</a:t>
+            </a:r>
+          </a:p>
+          <a:p>
+            <a:pPr algn="l">
+              <a:spcAft>
                 <a:spcPts val="0"/>
-              </a:spcBef>
-              <a:spcAft>
-                <a:spcPts val="600"/>
-              </a:spcAft>
-            </a:pPr>
-            <a:r>
-              <a:rPr sz="1100" b="1">
-                <a:solidFill>
-                  <a:srgbClr val="58A6FF"/>
-                </a:solidFill>
-                <a:latin typeface="Calibri"/>
-              </a:rPr>
-              <a:t>SALES / DEAL DESK</a:t>
-            </a:r>
-          </a:p>
-          <a:p>
-            <a:pPr algn="l">
-              <a:spcBef>
-                <a:spcPts val="0"/>
-              </a:spcBef>
-              <a:spcAft>
-                <a:spcPts val="600"/>
-              </a:spcAft>
-            </a:pPr>
-            <a:r>
-              <a:rPr sz="1300" b="1">
-                <a:solidFill>
-                  <a:srgbClr val="E6EDF3"/>
-                </a:solidFill>
-                <a:latin typeface="Calibri"/>
-              </a:rPr>
-              <a:t>≥80% bids on tier SKU by Q2</a:t>
-            </a:r>
-          </a:p>
-          <a:p>
-            <a:pPr algn="l">
-              <a:spcBef>
-                <a:spcPts val="0"/>
-              </a:spcBef>
-              <a:spcAft>
-                <a:spcPts val="0"/>
               </a:spcAft>
             </a:pPr>
             <a:r>
@@ -8832,7 +8765,7 @@
                 </a:solidFill>
                 <a:latin typeface="Calibri"/>
               </a:rPr>
-              <a:t>Discovery kit · ROI · margin waterfall · weekly pilot deal review</a:t>
+              <a:t>Discovery kit · return-on-investment calculator · weekly pilot deal review</a:t>
             </a:r>
           </a:p>
         </p:txBody>
@@ -8845,7 +8778,7 @@
         </p:nvSpPr>
         <p:spPr>
           <a:xfrm>
-            <a:off x="3383280" y="1188720"/>
+            <a:off x="3383280" y="1143000"/>
             <a:ext cx="2743200" cy="2331720"/>
           </a:xfrm>
           <a:prstGeom prst="roundRect">
@@ -8890,7 +8823,7 @@
         </p:nvSpPr>
         <p:spPr>
           <a:xfrm>
-            <a:off x="3383280" y="1188720"/>
+            <a:off x="3383280" y="1143000"/>
             <a:ext cx="73152" cy="2331720"/>
           </a:xfrm>
           <a:prstGeom prst="rect">
@@ -8933,7 +8866,7 @@
         </p:nvSpPr>
         <p:spPr>
           <a:xfrm>
-            <a:off x="3566160" y="1325880"/>
+            <a:off x="3566160" y="1280160"/>
             <a:ext cx="2423160" cy="2057400"/>
           </a:xfrm>
           <a:prstGeom prst="rect">
@@ -8948,49 +8881,40 @@
           <a:lstStyle/>
           <a:p>
             <a:pPr algn="l">
-              <a:spcBef>
+              <a:spcAft>
+                <a:spcPts val="600"/>
+              </a:spcAft>
+            </a:pPr>
+            <a:r>
+              <a:rPr sz="1100" b="1">
+                <a:solidFill>
+                  <a:srgbClr val="A371F7"/>
+                </a:solidFill>
+                <a:latin typeface="Calibri"/>
+              </a:rPr>
+              <a:t>MARKETING</a:t>
+            </a:r>
+          </a:p>
+          <a:p>
+            <a:pPr algn="l">
+              <a:spcAft>
+                <a:spcPts val="600"/>
+              </a:spcAft>
+            </a:pPr>
+            <a:r>
+              <a:rPr sz="1300" b="1">
+                <a:solidFill>
+                  <a:srgbClr val="E6EDF3"/>
+                </a:solidFill>
+                <a:latin typeface="Calibri"/>
+              </a:rPr>
+              <a:t>One narrative: Application Operations by outcome tier</a:t>
+            </a:r>
+          </a:p>
+          <a:p>
+            <a:pPr algn="l">
+              <a:spcAft>
                 <a:spcPts val="0"/>
-              </a:spcBef>
-              <a:spcAft>
-                <a:spcPts val="600"/>
-              </a:spcAft>
-            </a:pPr>
-            <a:r>
-              <a:rPr sz="1100" b="1">
-                <a:solidFill>
-                  <a:srgbClr val="A371F7"/>
-                </a:solidFill>
-                <a:latin typeface="Calibri"/>
-              </a:rPr>
-              <a:t>MARKETING</a:t>
-            </a:r>
-          </a:p>
-          <a:p>
-            <a:pPr algn="l">
-              <a:spcBef>
-                <a:spcPts val="0"/>
-              </a:spcBef>
-              <a:spcAft>
-                <a:spcPts val="600"/>
-              </a:spcAft>
-            </a:pPr>
-            <a:r>
-              <a:rPr sz="1300" b="1">
-                <a:solidFill>
-                  <a:srgbClr val="E6EDF3"/>
-                </a:solidFill>
-                <a:latin typeface="Calibri"/>
-              </a:rPr>
-              <a:t>One narrative: Apps Ops → Autonomy</a:t>
-            </a:r>
-          </a:p>
-          <a:p>
-            <a:pPr algn="l">
-              <a:spcBef>
-                <a:spcPts val="0"/>
-              </a:spcBef>
-              <a:spcAft>
-                <a:spcPts val="0"/>
               </a:spcAft>
             </a:pPr>
             <a:r>
@@ -9000,7 +8924,7 @@
                 </a:solidFill>
                 <a:latin typeface="Calibri"/>
               </a:rPr>
-              <a:t>Tier one-pagers · proof stories · retire FTE-tower language</a:t>
+              <a:t>Tier one-pagers · proof stories · retire staffing-tower language</a:t>
             </a:r>
           </a:p>
         </p:txBody>
@@ -9013,7 +8937,7 @@
         </p:nvSpPr>
         <p:spPr>
           <a:xfrm>
-            <a:off x="6263640" y="1188720"/>
+            <a:off x="6263640" y="1143000"/>
             <a:ext cx="2743200" cy="2331720"/>
           </a:xfrm>
           <a:prstGeom prst="roundRect">
@@ -9058,7 +8982,7 @@
         </p:nvSpPr>
         <p:spPr>
           <a:xfrm>
-            <a:off x="6263640" y="1188720"/>
+            <a:off x="6263640" y="1143000"/>
             <a:ext cx="73152" cy="2331720"/>
           </a:xfrm>
           <a:prstGeom prst="rect">
@@ -9101,7 +9025,7 @@
         </p:nvSpPr>
         <p:spPr>
           <a:xfrm>
-            <a:off x="6446520" y="1325880"/>
+            <a:off x="6446520" y="1280160"/>
             <a:ext cx="2423160" cy="2057400"/>
           </a:xfrm>
           <a:prstGeom prst="rect">
@@ -9116,49 +9040,40 @@
           <a:lstStyle/>
           <a:p>
             <a:pPr algn="l">
-              <a:spcBef>
+              <a:spcAft>
+                <a:spcPts val="600"/>
+              </a:spcAft>
+            </a:pPr>
+            <a:r>
+              <a:rPr sz="1100" b="1">
+                <a:solidFill>
+                  <a:srgbClr val="D4A853"/>
+                </a:solidFill>
+                <a:latin typeface="Calibri"/>
+              </a:rPr>
+              <a:t>FINANCE</a:t>
+            </a:r>
+          </a:p>
+          <a:p>
+            <a:pPr algn="l">
+              <a:spcAft>
+                <a:spcPts val="600"/>
+              </a:spcAft>
+            </a:pPr>
+            <a:r>
+              <a:rPr sz="1300" b="1">
+                <a:solidFill>
+                  <a:srgbClr val="E6EDF3"/>
+                </a:solidFill>
+                <a:latin typeface="Calibri"/>
+              </a:rPr>
+              <a:t>Revenue-recognition compliant · gross-margin floors in bid model</a:t>
+            </a:r>
+          </a:p>
+          <a:p>
+            <a:pPr algn="l">
+              <a:spcAft>
                 <a:spcPts val="0"/>
-              </a:spcBef>
-              <a:spcAft>
-                <a:spcPts val="600"/>
-              </a:spcAft>
-            </a:pPr>
-            <a:r>
-              <a:rPr sz="1100" b="1">
-                <a:solidFill>
-                  <a:srgbClr val="D4A853"/>
-                </a:solidFill>
-                <a:latin typeface="Calibri"/>
-              </a:rPr>
-              <a:t>FINANCE</a:t>
-            </a:r>
-          </a:p>
-          <a:p>
-            <a:pPr algn="l">
-              <a:spcBef>
-                <a:spcPts val="0"/>
-              </a:spcBef>
-              <a:spcAft>
-                <a:spcPts val="600"/>
-              </a:spcAft>
-            </a:pPr>
-            <a:r>
-              <a:rPr sz="1300" b="1">
-                <a:solidFill>
-                  <a:srgbClr val="E6EDF3"/>
-                </a:solidFill>
-                <a:latin typeface="Calibri"/>
-              </a:rPr>
-              <a:t>Rev-rec compliant · GM floors in ERP</a:t>
-            </a:r>
-          </a:p>
-          <a:p>
-            <a:pPr algn="l">
-              <a:spcBef>
-                <a:spcPts val="0"/>
-              </a:spcBef>
-              <a:spcAft>
-                <a:spcPts val="0"/>
               </a:spcAft>
             </a:pPr>
             <a:r>
@@ -9168,7 +9083,7 @@
                 </a:solidFill>
                 <a:latin typeface="Calibri"/>
               </a:rPr>
-              <a:t>Platform vs milestone memo · penalty lot accounting · bid sign-off</a:t>
+              <a:t>Platform vs milestone memo · credit accounting · bid sign-off</a:t>
             </a:r>
           </a:p>
         </p:txBody>
@@ -9181,7 +9096,7 @@
         </p:nvSpPr>
         <p:spPr>
           <a:xfrm>
-            <a:off x="9144000" y="1188720"/>
+            <a:off x="9144000" y="1143000"/>
             <a:ext cx="2743200" cy="2331720"/>
           </a:xfrm>
           <a:prstGeom prst="roundRect">
@@ -9226,7 +9141,7 @@
         </p:nvSpPr>
         <p:spPr>
           <a:xfrm>
-            <a:off x="9144000" y="1188720"/>
+            <a:off x="9144000" y="1143000"/>
             <a:ext cx="73152" cy="2331720"/>
           </a:xfrm>
           <a:prstGeom prst="rect">
@@ -9269,7 +9184,7 @@
         </p:nvSpPr>
         <p:spPr>
           <a:xfrm>
-            <a:off x="9326880" y="1325880"/>
+            <a:off x="9326880" y="1280160"/>
             <a:ext cx="2423160" cy="2057400"/>
           </a:xfrm>
           <a:prstGeom prst="rect">
@@ -9284,49 +9199,40 @@
           <a:lstStyle/>
           <a:p>
             <a:pPr algn="l">
-              <a:spcBef>
+              <a:spcAft>
+                <a:spcPts val="600"/>
+              </a:spcAft>
+            </a:pPr>
+            <a:r>
+              <a:rPr sz="1100" b="1">
+                <a:solidFill>
+                  <a:srgbClr val="3FB950"/>
+                </a:solidFill>
+                <a:latin typeface="Calibri"/>
+              </a:rPr>
+              <a:t>REGIONS / DELIVERY</a:t>
+            </a:r>
+          </a:p>
+          <a:p>
+            <a:pPr algn="l">
+              <a:spcAft>
+                <a:spcPts val="600"/>
+              </a:spcAft>
+            </a:pPr>
+            <a:r>
+              <a:rPr sz="1300" b="1">
+                <a:solidFill>
+                  <a:srgbClr val="E6EDF3"/>
+                </a:solidFill>
+                <a:latin typeface="Calibri"/>
+              </a:rPr>
+              <a:t>Pilots hit standard service-level catalogue</a:t>
+            </a:r>
+          </a:p>
+          <a:p>
+            <a:pPr algn="l">
+              <a:spcAft>
                 <a:spcPts val="0"/>
-              </a:spcBef>
-              <a:spcAft>
-                <a:spcPts val="600"/>
-              </a:spcAft>
-            </a:pPr>
-            <a:r>
-              <a:rPr sz="1100" b="1">
-                <a:solidFill>
-                  <a:srgbClr val="3FB950"/>
-                </a:solidFill>
-                <a:latin typeface="Calibri"/>
-              </a:rPr>
-              <a:t>REGIONS / DELIVERY</a:t>
-            </a:r>
-          </a:p>
-          <a:p>
-            <a:pPr algn="l">
-              <a:spcBef>
-                <a:spcPts val="0"/>
-              </a:spcBef>
-              <a:spcAft>
-                <a:spcPts val="600"/>
-              </a:spcAft>
-            </a:pPr>
-            <a:r>
-              <a:rPr sz="1300" b="1">
-                <a:solidFill>
-                  <a:srgbClr val="E6EDF3"/>
-                </a:solidFill>
-                <a:latin typeface="Calibri"/>
-              </a:rPr>
-              <a:t>Pilots hit CPI catalogue</a:t>
-            </a:r>
-          </a:p>
-          <a:p>
-            <a:pPr algn="l">
-              <a:spcBef>
-                <a:spcPts val="0"/>
-              </a:spcBef>
-              <a:spcAft>
-                <a:spcPts val="0"/>
               </a:spcAft>
             </a:pPr>
             <a:r>
@@ -9336,7 +9242,7 @@
                 </a:solidFill>
                 <a:latin typeface="Calibri"/>
               </a:rPr>
-              <a:t>KT playbook · SDM board · QBR tier step-ups · train-the-trainer</a:t>
+              <a:t>Knowledge-transfer playbook · performance board · renewal step-ups</a:t>
             </a:r>
           </a:p>
         </p:txBody>
@@ -9349,8 +9255,8 @@
         </p:nvSpPr>
         <p:spPr>
           <a:xfrm>
-            <a:off x="502920" y="3749039"/>
-            <a:ext cx="11155680" cy="2331720"/>
+            <a:off x="502920" y="3703320"/>
+            <a:ext cx="11155680" cy="2377440"/>
           </a:xfrm>
           <a:prstGeom prst="roundRect">
             <a:avLst>
@@ -9395,7 +9301,7 @@
         <p:spPr>
           <a:xfrm>
             <a:off x="685800" y="3840480"/>
-            <a:ext cx="10789920" cy="2148840"/>
+            <a:ext cx="10789920" cy="2103120"/>
           </a:xfrm>
           <a:prstGeom prst="rect">
             <a:avLst/>
@@ -9409,68 +9315,56 @@
           <a:lstStyle/>
           <a:p>
             <a:pPr algn="l">
-              <a:spcBef>
+              <a:spcAft>
+                <a:spcPts val="800"/>
+              </a:spcAft>
+            </a:pPr>
+            <a:r>
+              <a:rPr sz="1200" b="1">
+                <a:solidFill>
+                  <a:srgbClr val="D4A853"/>
+                </a:solidFill>
+                <a:latin typeface="Calibri"/>
+              </a:rPr>
+              <a:t>12-MONTH SCOREBOARD  ·  Quarterly Pricing Council adjusts tiers / floors / packs</a:t>
+            </a:r>
+          </a:p>
+          <a:p>
+            <a:pPr algn="l">
+              <a:spcAft>
+                <a:spcPts val="600"/>
+              </a:spcAft>
+            </a:pPr>
+            <a:r>
+              <a:rPr sz="1300" b="0">
+                <a:solidFill>
+                  <a:srgbClr val="E6EDF3"/>
+                </a:solidFill>
+                <a:latin typeface="Calibri"/>
+              </a:rPr>
+              <a:t>Net sales  Flat → +8–12%          Gross margin  recover +3–4 points          Tier adoption  ≥80% of pipeline</a:t>
+            </a:r>
+          </a:p>
+          <a:p>
+            <a:pPr algn="l">
+              <a:spcAft>
+                <a:spcPts val="1000"/>
+              </a:spcAft>
+            </a:pPr>
+            <a:r>
+              <a:rPr sz="1300" b="0">
+                <a:solidFill>
+                  <a:srgbClr val="E6EDF3"/>
+                </a:solidFill>
+                <a:latin typeface="Calibri"/>
+              </a:rPr>
+              <a:t>Regional price variance  &lt;15%          Wins citing value / total-cost story  ≥40%          Renewal step-up  ≥25%</a:t>
+            </a:r>
+          </a:p>
+          <a:p>
+            <a:pPr algn="l">
+              <a:spcAft>
                 <a:spcPts val="0"/>
-              </a:spcBef>
-              <a:spcAft>
-                <a:spcPts val="800"/>
-              </a:spcAft>
-            </a:pPr>
-            <a:r>
-              <a:rPr sz="1200" b="1">
-                <a:solidFill>
-                  <a:srgbClr val="D4A853"/>
-                </a:solidFill>
-                <a:latin typeface="Calibri"/>
-              </a:rPr>
-              <a:t>12-MONTH SCOREBOARD  ·  Quarterly Pricing Council adjusts tiers / floors / packs</a:t>
-            </a:r>
-          </a:p>
-          <a:p>
-            <a:pPr algn="l">
-              <a:spcBef>
-                <a:spcPts val="0"/>
-              </a:spcBef>
-              <a:spcAft>
-                <a:spcPts val="600"/>
-              </a:spcAft>
-            </a:pPr>
-            <a:r>
-              <a:rPr sz="1300" b="0">
-                <a:solidFill>
-                  <a:srgbClr val="E6EDF3"/>
-                </a:solidFill>
-                <a:latin typeface="Calibri"/>
-              </a:rPr>
-              <a:t>Net sales  Flat → +8–12%          Gross margin  recover +3–4 pts          Tier SKU adoption  ≥80%</a:t>
-            </a:r>
-          </a:p>
-          <a:p>
-            <a:pPr algn="l">
-              <a:spcBef>
-                <a:spcPts val="0"/>
-              </a:spcBef>
-              <a:spcAft>
-                <a:spcPts val="1000"/>
-              </a:spcAft>
-            </a:pPr>
-            <a:r>
-              <a:rPr sz="1300" b="0">
-                <a:solidFill>
-                  <a:srgbClr val="E6EDF3"/>
-                </a:solidFill>
-                <a:latin typeface="Calibri"/>
-              </a:rPr>
-              <a:t>Regional price variance  &lt;15%          Wins citing value/TCO  ≥40%          Renewal step-up  ≥25% Optimize+</a:t>
-            </a:r>
-          </a:p>
-          <a:p>
-            <a:pPr algn="l">
-              <a:spcBef>
-                <a:spcPts val="0"/>
-              </a:spcBef>
-              <a:spcAft>
-                <a:spcPts val="0"/>
               </a:spcAft>
             </a:pPr>
             <a:r>
@@ -9480,7 +9374,7 @@
                 </a:solidFill>
                 <a:latin typeface="Calibri"/>
               </a:rPr>
-              <a:t>Feedback loop: monthly Deal Desk overrides + CR volume → quarterly pricing council (±3% rate card) → annual sunset re-test &amp; Autonomize → AO SKU merge</a:t>
+              <a:t>Feedback loop: monthly Deal Desk overrides + change-request volume → quarterly Pricing Council (±3% rate-card index) → annual sunset re-test and Transform demand check</a:t>
             </a:r>
           </a:p>
         </p:txBody>
@@ -9508,9 +9402,6 @@
           <a:lstStyle/>
           <a:p>
             <a:pPr algn="l">
-              <a:spcBef>
-                <a:spcPts val="0"/>
-              </a:spcBef>
               <a:spcAft>
                 <a:spcPts val="0"/>
               </a:spcAft>
@@ -9550,9 +9441,6 @@
           <a:lstStyle/>
           <a:p>
             <a:pPr algn="r">
-              <a:spcBef>
-                <a:spcPts val="0"/>
-              </a:spcBef>
               <a:spcAft>
                 <a:spcPts val="0"/>
               </a:spcAft>
@@ -9647,69 +9535,63 @@
           <a:noFill/>
         </p:spPr>
         <p:txBody>
+          <a:bodyPr wrap="none">
+            <a:spAutoFit/>
+          </a:bodyPr>
+          <a:lstStyle/>
+          <a:p>
+            <a:pPr algn="l">
+              <a:spcAft>
+                <a:spcPts val="0"/>
+              </a:spcAft>
+            </a:pPr>
+            <a:r>
+              <a:rPr sz="1100" b="1">
+                <a:solidFill>
+                  <a:srgbClr val="58A6FF"/>
+                </a:solidFill>
+                <a:latin typeface="Calibri"/>
+              </a:rPr>
+              <a:t>RECOMMENDATION  ·  ASK</a:t>
+            </a:r>
+          </a:p>
+        </p:txBody>
+      </p:sp>
+      <p:sp>
+        <p:nvSpPr>
+          <p:cNvPr id="4" name="TextBox 3"/>
+          <p:cNvSpPr txBox="1"/>
+          <p:nvPr/>
+        </p:nvSpPr>
+        <p:spPr>
+          <a:xfrm>
+            <a:off x="502920" y="475488"/>
+            <a:ext cx="11155680" cy="640080"/>
+          </a:xfrm>
+          <a:prstGeom prst="rect">
+            <a:avLst/>
+          </a:prstGeom>
+          <a:noFill/>
+        </p:spPr>
+        <p:txBody>
           <a:bodyPr wrap="square">
             <a:spAutoFit/>
           </a:bodyPr>
           <a:lstStyle/>
           <a:p>
             <a:pPr algn="l">
-              <a:spcBef>
+              <a:spcAft>
                 <a:spcPts val="0"/>
-              </a:spcBef>
-              <a:spcAft>
-                <a:spcPts val="0"/>
-              </a:spcAft>
-            </a:pPr>
-            <a:r>
-              <a:rPr sz="1100" b="1">
-                <a:solidFill>
-                  <a:srgbClr val="58A6FF"/>
-                </a:solidFill>
-                <a:latin typeface="Calibri"/>
-              </a:rPr>
-              <a:t>RECOMMENDATION  ·  ASK</a:t>
-            </a:r>
-          </a:p>
-        </p:txBody>
-      </p:sp>
-      <p:sp>
-        <p:nvSpPr>
-          <p:cNvPr id="4" name="TextBox 3"/>
-          <p:cNvSpPr txBox="1"/>
-          <p:nvPr/>
-        </p:nvSpPr>
-        <p:spPr>
-          <a:xfrm>
-            <a:off x="502920" y="475488"/>
-            <a:ext cx="11155680" cy="640080"/>
-          </a:xfrm>
-          <a:prstGeom prst="rect">
-            <a:avLst/>
-          </a:prstGeom>
-          <a:noFill/>
-        </p:spPr>
-        <p:txBody>
-          <a:bodyPr wrap="square">
-            <a:spAutoFit/>
-          </a:bodyPr>
-          <a:lstStyle/>
-          <a:p>
-            <a:pPr algn="l">
-              <a:spcBef>
-                <a:spcPts val="0"/>
-              </a:spcBef>
-              <a:spcAft>
-                <a:spcPts val="0"/>
-              </a:spcAft>
-            </a:pPr>
-            <a:r>
-              <a:rPr sz="2800" b="1">
+              </a:spcAft>
+            </a:pPr>
+            <a:r>
+              <a:rPr sz="2600" b="1">
                 <a:solidFill>
                   <a:srgbClr val="D4A853"/>
                 </a:solidFill>
                 <a:latin typeface="Calibri"/>
               </a:rPr>
-              <a:t>Reposition AMS. Land with tiers. Expand to autonomy.</a:t>
+              <a:t>Reposition. Land with tiers. Expand when value is proven.</a:t>
             </a:r>
           </a:p>
         </p:txBody>
@@ -9722,7 +9604,7 @@
         </p:nvSpPr>
         <p:spPr>
           <a:xfrm>
-            <a:off x="502920" y="1234440"/>
+            <a:off x="502920" y="1188720"/>
             <a:ext cx="11155680" cy="1554480"/>
           </a:xfrm>
           <a:prstGeom prst="roundRect">
@@ -9767,7 +9649,7 @@
         </p:nvSpPr>
         <p:spPr>
           <a:xfrm>
-            <a:off x="685800" y="1371600"/>
+            <a:off x="685800" y="1325880"/>
             <a:ext cx="10789920" cy="1280160"/>
           </a:xfrm>
           <a:prstGeom prst="rect">
@@ -9782,40 +9664,34 @@
           <a:lstStyle/>
           <a:p>
             <a:pPr algn="l">
-              <a:spcBef>
+              <a:spcAft>
+                <a:spcPts val="600"/>
+              </a:spcAft>
+            </a:pPr>
+            <a:r>
+              <a:rPr sz="1100" b="1">
+                <a:solidFill>
+                  <a:srgbClr val="58A6FF"/>
+                </a:solidFill>
+                <a:latin typeface="Calibri"/>
+              </a:rPr>
+              <a:t>THE CALL</a:t>
+            </a:r>
+          </a:p>
+          <a:p>
+            <a:pPr algn="l">
+              <a:spcAft>
                 <a:spcPts val="0"/>
-              </a:spcBef>
-              <a:spcAft>
-                <a:spcPts val="600"/>
-              </a:spcAft>
-            </a:pPr>
-            <a:r>
-              <a:rPr sz="1100" b="1">
-                <a:solidFill>
-                  <a:srgbClr val="58A6FF"/>
-                </a:solidFill>
-                <a:latin typeface="Calibri"/>
-              </a:rPr>
-              <a:t>THE CALL</a:t>
-            </a:r>
-          </a:p>
-          <a:p>
-            <a:pPr algn="l">
-              <a:spcBef>
-                <a:spcPts val="0"/>
-              </a:spcBef>
-              <a:spcAft>
-                <a:spcPts val="0"/>
-              </a:spcAft>
-            </a:pPr>
-            <a:r>
-              <a:rPr sz="1500" b="0">
+              </a:spcAft>
+            </a:pPr>
+            <a:r>
+              <a:rPr sz="1400" b="0">
                 <a:solidFill>
                   <a:srgbClr val="E6EDF3"/>
                 </a:solidFill>
                 <a:latin typeface="Calibri"/>
               </a:rPr>
-              <a:t>Reposition Application Managed Services as Outcome-Tiered Application Operations (Stabilize → Optimize → Autonomize). Do not sunset a delivery-capable franchise. Do not evolve tooling without fixing the commercial SKU. Fund guardrails &amp; enablement in Q1; pilot in two regions; measure with a quarterly pricing council.</a:t>
+              <a:t>Reposition Application Managed Services as Outcome-Tiered Application Operations (Stabilize → Optimize → Transform). Do not sunset a delivery-capable franchise. Do not evolve tooling without fixing the commercial sellable unit. Fund guardrails and enablement in Quarter 1; pilot in two regions; measure with a quarterly Pricing Council.</a:t>
             </a:r>
           </a:p>
         </p:txBody>
@@ -9828,8 +9704,8 @@
         </p:nvSpPr>
         <p:spPr>
           <a:xfrm>
-            <a:off x="502920" y="3017520"/>
-            <a:ext cx="5486400" cy="2194560"/>
+            <a:off x="502920" y="2971800"/>
+            <a:ext cx="5486400" cy="2240280"/>
           </a:xfrm>
           <a:prstGeom prst="roundRect">
             <a:avLst>
@@ -9873,8 +9749,8 @@
         </p:nvSpPr>
         <p:spPr>
           <a:xfrm>
-            <a:off x="685800" y="3154680"/>
-            <a:ext cx="5120640" cy="1920240"/>
+            <a:off x="685800" y="3108960"/>
+            <a:ext cx="5120640" cy="1965960"/>
           </a:xfrm>
           <a:prstGeom prst="rect">
             <a:avLst/>
@@ -9888,97 +9764,82 @@
           <a:lstStyle/>
           <a:p>
             <a:pPr algn="l">
-              <a:spcBef>
+              <a:spcAft>
+                <a:spcPts val="800"/>
+              </a:spcAft>
+            </a:pPr>
+            <a:r>
+              <a:rPr sz="1100" b="1">
+                <a:solidFill>
+                  <a:srgbClr val="D4A853"/>
+                </a:solidFill>
+                <a:latin typeface="Calibri"/>
+              </a:rPr>
+              <a:t>THOUGHT PROCESS (WHY THIS IS EXECUTIVE)</a:t>
+            </a:r>
+          </a:p>
+          <a:p>
+            <a:pPr algn="l">
+              <a:spcAft>
+                <a:spcPts val="400"/>
+              </a:spcAft>
+            </a:pPr>
+            <a:r>
+              <a:rPr sz="1200" b="0">
+                <a:solidFill>
+                  <a:srgbClr val="E6EDF3"/>
+                </a:solidFill>
+                <a:latin typeface="Calibri"/>
+              </a:rPr>
+              <a:t>Evidence before instinct — five-lens diagnostic</a:t>
+            </a:r>
+          </a:p>
+          <a:p>
+            <a:pPr algn="l">
+              <a:spcAft>
+                <a:spcPts val="400"/>
+              </a:spcAft>
+            </a:pPr>
+            <a:r>
+              <a:rPr sz="1200" b="0">
+                <a:solidFill>
+                  <a:srgbClr val="E6EDF3"/>
+                </a:solidFill>
+                <a:latin typeface="Calibri"/>
+              </a:rPr>
+              <a:t>Separate delivery quality from commercial failure</a:t>
+            </a:r>
+          </a:p>
+          <a:p>
+            <a:pPr algn="l">
+              <a:spcAft>
+                <a:spcPts val="400"/>
+              </a:spcAft>
+            </a:pPr>
+            <a:r>
+              <a:rPr sz="1200" b="0">
+                <a:solidFill>
+                  <a:srgbClr val="E6EDF3"/>
+                </a:solidFill>
+                <a:latin typeface="Calibri"/>
+              </a:rPr>
+              <a:t>Choose with trade-offs; fund Sales motion before tooling</a:t>
+            </a:r>
+          </a:p>
+          <a:p>
+            <a:pPr algn="l">
+              <a:spcAft>
                 <a:spcPts val="0"/>
-              </a:spcBef>
-              <a:spcAft>
-                <a:spcPts val="800"/>
-              </a:spcAft>
-            </a:pPr>
-            <a:r>
-              <a:rPr sz="1100" b="1">
-                <a:solidFill>
-                  <a:srgbClr val="D4A853"/>
-                </a:solidFill>
-                <a:latin typeface="Calibri"/>
-              </a:rPr>
-              <a:t>WHY CREDIBLE</a:t>
-            </a:r>
-          </a:p>
-          <a:p>
-            <a:pPr algn="l">
-              <a:spcBef>
-                <a:spcPts val="0"/>
-              </a:spcBef>
-              <a:spcAft>
-                <a:spcPts val="200"/>
-              </a:spcAft>
-            </a:pPr>
-            <a:r>
-              <a:rPr sz="1400" b="1">
+              </a:spcAft>
+            </a:pPr>
+            <a:r>
+              <a:rPr sz="1200" b="0">
                 <a:solidFill>
                   <a:srgbClr val="E6EDF3"/>
                 </a:solidFill>
                 <a:latin typeface="Calibri"/>
               </a:rPr>
-              <a:t>H3G UK — $125m</a:t>
-            </a:r>
-          </a:p>
-          <a:p>
-            <a:pPr algn="l">
-              <a:spcBef>
-                <a:spcPts val="0"/>
-              </a:spcBef>
-              <a:spcAft>
-                <a:spcPts val="800"/>
-              </a:spcAft>
-            </a:pPr>
-            <a:r>
-              <a:rPr sz="1200" b="0">
-                <a:solidFill>
-                  <a:srgbClr val="8B9CB3"/>
-                </a:solidFill>
-                <a:latin typeface="Calibri"/>
-              </a:rPr>
-              <a:t>75 CPIs · priced transition · 474→336 economics — sold transformation, not FTEs</a:t>
-            </a:r>
-          </a:p>
-          <a:p>
-            <a:pPr algn="l">
-              <a:spcBef>
-                <a:spcPts val="0"/>
-              </a:spcBef>
-              <a:spcAft>
-                <a:spcPts val="200"/>
-              </a:spcAft>
-            </a:pPr>
-            <a:r>
-              <a:rPr sz="1400" b="1">
-                <a:solidFill>
-                  <a:srgbClr val="E6EDF3"/>
-                </a:solidFill>
-                <a:latin typeface="Calibri"/>
-              </a:rPr>
-              <a:t>TEF Argentina — $100m</a:t>
-            </a:r>
-          </a:p>
-          <a:p>
-            <a:pPr algn="l">
-              <a:spcBef>
-                <a:spcPts val="0"/>
-              </a:spcBef>
-              <a:spcAft>
-                <a:spcPts val="0"/>
-              </a:spcAft>
-            </a:pPr>
-            <a:r>
-              <a:rPr sz="1200" b="0">
-                <a:solidFill>
-                  <a:srgbClr val="8B9CB3"/>
-                </a:solidFill>
-                <a:latin typeface="Calibri"/>
-              </a:rPr>
-              <a:t>Repositioned accountability &amp; KPI transparency when the story was broken → renewal</a:t>
+              <a:t>Optional packs (e.g. multi-vendor) only when data says so</a:t>
             </a:r>
           </a:p>
         </p:txBody>
@@ -9991,8 +9852,8 @@
         </p:nvSpPr>
         <p:spPr>
           <a:xfrm>
-            <a:off x="6217920" y="3017520"/>
-            <a:ext cx="5440680" cy="2194560"/>
+            <a:off x="6217920" y="2971800"/>
+            <a:ext cx="5440680" cy="2240280"/>
           </a:xfrm>
           <a:prstGeom prst="roundRect">
             <a:avLst>
@@ -10036,8 +9897,8 @@
         </p:nvSpPr>
         <p:spPr>
           <a:xfrm>
-            <a:off x="6400800" y="3154680"/>
-            <a:ext cx="5074920" cy="1920240"/>
+            <a:off x="6400800" y="3108960"/>
+            <a:ext cx="5074920" cy="1965960"/>
           </a:xfrm>
           <a:prstGeom prst="rect">
             <a:avLst/>
@@ -10051,9 +9912,6 @@
           <a:lstStyle/>
           <a:p>
             <a:pPr algn="l">
-              <a:spcBef>
-                <a:spcPts val="0"/>
-              </a:spcBef>
               <a:spcAft>
                 <a:spcPts val="800"/>
               </a:spcAft>
@@ -10070,9 +9928,6 @@
           </a:p>
           <a:p>
             <a:pPr algn="l">
-              <a:spcBef>
-                <a:spcPts val="0"/>
-              </a:spcBef>
               <a:spcAft>
                 <a:spcPts val="600"/>
               </a:spcAft>
@@ -10084,14 +9939,11 @@
                 </a:solidFill>
                 <a:latin typeface="Calibri"/>
               </a:rPr>
-              <a:t>▸  Approve reposition mandate &amp; global rate card</a:t>
-            </a:r>
-          </a:p>
-          <a:p>
-            <a:pPr algn="l">
-              <a:spcBef>
-                <a:spcPts val="0"/>
-              </a:spcBef>
+              <a:t>▸  Approve reposition mandate and global rate card</a:t>
+            </a:r>
+          </a:p>
+          <a:p>
+            <a:pPr algn="l">
               <a:spcAft>
                 <a:spcPts val="600"/>
               </a:spcAft>
@@ -10108,9 +9960,6 @@
           </a:p>
           <a:p>
             <a:pPr algn="l">
-              <a:spcBef>
-                <a:spcPts val="0"/>
-              </a:spcBef>
               <a:spcAft>
                 <a:spcPts val="600"/>
               </a:spcAft>
@@ -10122,14 +9971,11 @@
                 </a:solidFill>
                 <a:latin typeface="Calibri"/>
               </a:rPr>
-              <a:t>▸  Authorize 2 regional pilots (UK + LATAM)</a:t>
-            </a:r>
-          </a:p>
-          <a:p>
-            <a:pPr algn="l">
-              <a:spcBef>
-                <a:spcPts val="0"/>
-              </a:spcBef>
+              <a:t>▸  Authorize two regional pilots before global cutover</a:t>
+            </a:r>
+          </a:p>
+          <a:p>
+            <a:pPr algn="l">
               <a:spcAft>
                 <a:spcPts val="600"/>
               </a:spcAft>
@@ -10141,7 +9987,7 @@
                 </a:solidFill>
                 <a:latin typeface="Calibri"/>
               </a:rPr>
-              <a:t>▸  Name SPM owner + monthly steering forum</a:t>
+              <a:t>▸  Name Strategic Product Manager owner + monthly steering</a:t>
             </a:r>
           </a:p>
         </p:txBody>
@@ -10169,21 +10015,18 @@
           <a:lstStyle/>
           <a:p>
             <a:pPr algn="ctr">
-              <a:spcBef>
+              <a:spcAft>
                 <a:spcPts val="0"/>
-              </a:spcBef>
-              <a:spcAft>
-                <a:spcPts val="0"/>
-              </a:spcAft>
-            </a:pPr>
-            <a:r>
-              <a:rPr sz="1400" b="1">
+              </a:spcAft>
+            </a:pPr>
+            <a:r>
+              <a:rPr sz="1300" b="1">
                 <a:solidFill>
                   <a:srgbClr val="8B9CB3"/>
                 </a:solidFill>
                 <a:latin typeface="Calibri"/>
               </a:rPr>
-              <a:t>Q&amp;A  ·  5 minutes     ·     Detail appendix: full diagnosis scorecard, rate-card rules, CPI catalogue, enablement plan</a:t>
+              <a:t>QUESTIONS  ·  5 MINUTES     ·     Deep dive: HTML case study (diagnosis scorecard, full guardrail table, enablement plan)</a:t>
             </a:r>
           </a:p>
         </p:txBody>
@@ -10211,9 +10054,6 @@
           <a:lstStyle/>
           <a:p>
             <a:pPr algn="l">
-              <a:spcBef>
-                <a:spcPts val="0"/>
-              </a:spcBef>
               <a:spcAft>
                 <a:spcPts val="0"/>
               </a:spcAft>
@@ -10253,9 +10093,6 @@
           <a:lstStyle/>
           <a:p>
             <a:pPr algn="r">
-              <a:spcBef>
-                <a:spcPts val="0"/>
-              </a:spcBef>
               <a:spcAft>
                 <a:spcPts val="0"/>
               </a:spcAft>

</xml_diff>

<commit_message>
Clarify Case Study 1 gross margin as 28% → 22–24% example
Replace opaque “−4–6 pts” with illustrative margin path and
explicit “percentage points over 2 years” on HTML, PPTX, and PDF.

Co-authored-by: gauravch86 <gauravch86@users.noreply.github.com>
</commit_message>
<xml_diff>
--- a/case-study-1-reposition-executive.pptx
+++ b/case-study-1-reposition-executive.pptx
@@ -518,7 +518,7 @@
           </a:p>
           <a:p>
             <a:r>
-              <a:t>Open with the paradox: delivery Net Promoter Score / customer satisfaction is strong, yet net sales are flat and gross margin is down four to six points. That means this is NOT a delivery crisis — it is a commercial and go-to-market failure.</a:t>
+              <a:t>Open with the paradox: delivery Net Promoter Score / customer satisfaction is strong, yet net sales are flat and gross margin has fallen illustratively from about 28% to 22–24% — that is a drop of four to six percentage points over two years. That means this is NOT a delivery crisis — it is a commercial and go-to-market failure.</a:t>
             </a:r>
           </a:p>
           <a:p/>
@@ -546,7 +546,7 @@
           </a:p>
           <a:p>
             <a:r>
-              <a:t>• Gross margin = net sales minus direct delivery cost (points = percentage points)</a:t>
+              <a:t>• Gross margin = (net sales − direct delivery cost) ÷ net sales. Example 28% → 22–24% = −4 to −6 percentage points (not “percent of percent”)</a:t>
             </a:r>
           </a:p>
           <a:p>
@@ -4589,7 +4589,7 @@
                 </a:solidFill>
                 <a:latin typeface="Calibri"/>
               </a:rPr>
-              <a:t>GROSS MARGIN</a:t>
+              <a:t>GROSS MARGIN (ILLUSTRATIVE)</a:t>
             </a:r>
           </a:p>
           <a:p>
@@ -4605,7 +4605,7 @@
                 </a:solidFill>
                 <a:latin typeface="Calibri"/>
               </a:rPr>
-              <a:t>−4–6 points</a:t>
+              <a:t>28% → 22–24%</a:t>
             </a:r>
           </a:p>
           <a:p>
@@ -4621,7 +4621,7 @@
                 </a:solidFill>
                 <a:latin typeface="Calibri"/>
               </a:rPr>
-              <a:t>Discount · scope creep · transition overrun</a:t>
+              <a:t>−4 to −6 percentage points over 2 years</a:t>
             </a:r>
           </a:p>
         </p:txBody>
@@ -9342,7 +9342,7 @@
                 </a:solidFill>
                 <a:latin typeface="Calibri"/>
               </a:rPr>
-              <a:t>Net sales  Flat → +8–12%          Gross margin  recover +3–4 points          Tier adoption  ≥80% of pipeline</a:t>
+              <a:t>Net sales  Flat → +8–12%          Gross margin  recover 3–4 percentage points (e.g. toward 25–27%)          Tier adoption  ≥80% of pipeline</a:t>
             </a:r>
           </a:p>
           <a:p>

</xml_diff>

<commit_message>
Add live per-slide countdown timers to both executive PPTX decks
Top-right SLIDE BUDGET HUD plus gold bar that counts down when Slideshow
starts (no auto-advance). Budgets sum to exactly 10:00. PDFs show static
budgets; speaker notes include timer cues.

Co-authored-by: gauravch86 <gauravch86@users.noreply.github.com>
</commit_message>
<xml_diff>
--- a/case-study-1-reposition-executive.pptx
+++ b/case-study-1-reposition-executive.pptx
@@ -509,7 +509,7 @@
           <a:lstStyle/>
           <a:p>
             <a:r>
-              <a:t>TIMING: ~1:15</a:t>
+              <a:t>TIMING: 1:15</a:t>
             </a:r>
           </a:p>
           <a:p/>
@@ -529,10 +529,21 @@
               <a:t>Tell them the storyline is sequential — one stage per slide — so they need not hold everything at once.</a:t>
             </a:r>
           </a:p>
+          <a:p>
+            <a:r>
+              <a:t>Point at the top-right timer: each slide has a budget; gold bar counts down when Slideshow starts; you still click to advance.</a:t>
+            </a:r>
+          </a:p>
           <a:p/>
           <a:p>
             <a:r>
               <a:t>GLOSSARY: Net sales · Gross margin · Deal Desk · Attach — as before.</a:t>
+            </a:r>
+          </a:p>
+          <a:p/>
+          <a:p>
+            <a:r>
+              <a:t>ON-SLIDE TIMER: Budget 1:15 for this slide. Gold bar counts down when Slideshow opens (does not auto-advance). By end of this slide you should be at ~1:15 of 10:00 (~8:45 remaining).</a:t>
             </a:r>
           </a:p>
         </p:txBody>
@@ -627,6 +638,12 @@
               <a:t>GLOSSARY: Win/loss · Gross-margin waterfall · Pull-through · Sunset test.</a:t>
             </a:r>
           </a:p>
+          <a:p/>
+          <a:p>
+            <a:r>
+              <a:t>ON-SLIDE TIMER: Budget 1:20 for this slide. Gold bar counts down when Slideshow opens (does not auto-advance). By end of this slide you should be at ~2:35 of 10:00 (~7:25 remaining).</a:t>
+            </a:r>
+          </a:p>
         </p:txBody>
       </p:sp>
       <p:sp>
@@ -713,6 +730,12 @@
               <a:t>Next slide = evolve / reposition / sunset decision.</a:t>
             </a:r>
           </a:p>
+          <a:p/>
+          <a:p>
+            <a:r>
+              <a:t>ON-SLIDE TIMER: Budget 1:20 for this slide. Gold bar counts down when Slideshow opens (does not auto-advance). By end of this slide you should be at ~3:55 of 10:00 (~6:05 remaining).</a:t>
+            </a:r>
+          </a:p>
         </p:txBody>
       </p:sp>
       <p:sp>
@@ -804,6 +827,12 @@
               <a:t>Next = how we package and price.</a:t>
             </a:r>
           </a:p>
+          <a:p/>
+          <a:p>
+            <a:r>
+              <a:t>ON-SLIDE TIMER: Budget 1:15 for this slide. Gold bar counts down when Slideshow opens (does not auto-advance). By end of this slide you should be at ~5:10 of 10:00 (~4:50 remaining).</a:t>
+            </a:r>
+          </a:p>
         </p:txBody>
       </p:sp>
       <p:sp>
@@ -885,6 +914,12 @@
               <a:t>Mandatory priced knowledge transfer. Multi-vendor = optional pack only.</a:t>
             </a:r>
           </a:p>
+          <a:p/>
+          <a:p>
+            <a:r>
+              <a:t>ON-SLIDE TIMER: Budget 1:25 for this slide. Gold bar counts down when Slideshow opens (does not auto-advance). By end of this slide you should be at ~6:35 of 10:00 (~3:25 remaining).</a:t>
+            </a:r>
+          </a:p>
         </p:txBody>
       </p:sp>
       <p:sp>
@@ -966,6 +1001,12 @@
               <a:t>Fund commercial assets before tooling. Explicit stop list.</a:t>
             </a:r>
           </a:p>
+          <a:p/>
+          <a:p>
+            <a:r>
+              <a:t>ON-SLIDE TIMER: Budget 1:15 for this slide. Gold bar counts down when Slideshow opens (does not auto-advance). By end of this slide you should be at ~7:50 of 10:00 (~2:10 remaining).</a:t>
+            </a:r>
+          </a:p>
         </p:txBody>
       </p:sp>
       <p:sp>
@@ -1042,6 +1083,12 @@
               <a:t>Name owners. Scoreboard = how leadership knows it worked. Pricing Council = continuous refinement.</a:t>
             </a:r>
           </a:p>
+          <a:p/>
+          <a:p>
+            <a:r>
+              <a:t>ON-SLIDE TIMER: Budget 1:05 for this slide. Gold bar counts down when Slideshow opens (does not auto-advance). By end of this slide you should be at ~8:55 of 10:00 (~1:05 remaining).</a:t>
+            </a:r>
+          </a:p>
         </p:txBody>
       </p:sp>
       <p:sp>
@@ -1127,6 +1174,12 @@
           <a:p>
             <a:r>
               <a:t>Q&amp;A prep same as before (sunset / deal size / rate card / Finance / consolidation optional).</a:t>
+            </a:r>
+          </a:p>
+          <a:p/>
+          <a:p>
+            <a:r>
+              <a:t>ON-SLIDE TIMER: Budget 1:05 for this slide. Gold bar counts down when Slideshow opens (does not auto-advance). By end of this slide you should be at ~10:00 of 10:00 (~0:00 remaining).</a:t>
             </a:r>
           </a:p>
         </p:txBody>
@@ -4223,7 +4276,7 @@
         <p:spPr>
           <a:xfrm>
             <a:off x="502920" y="438912"/>
-            <a:ext cx="11155680" cy="594360"/>
+            <a:ext cx="8869680" cy="594360"/>
           </a:xfrm>
           <a:prstGeom prst="rect">
             <a:avLst/>
@@ -4828,17 +4881,33 @@
           <a:p>
             <a:pPr algn="l">
               <a:spcAft>
+                <a:spcPts val="600"/>
+              </a:spcAft>
+            </a:pPr>
+            <a:r>
+              <a:rPr sz="1400" b="1">
+                <a:solidFill>
+                  <a:srgbClr val="E6EDF3"/>
+                </a:solidFill>
+                <a:latin typeface="Calibri"/>
+              </a:rPr>
+              <a:t>4  Package &amp; price   ·   5  Guardrails &amp; invest   ·   6  Align &amp; measure   ·   7  Ask</a:t>
+            </a:r>
+          </a:p>
+          <a:p>
+            <a:pPr algn="l">
+              <a:spcAft>
                 <a:spcPts val="0"/>
               </a:spcAft>
             </a:pPr>
             <a:r>
-              <a:rPr sz="1400" b="1">
-                <a:solidFill>
-                  <a:srgbClr val="E6EDF3"/>
-                </a:solidFill>
-                <a:latin typeface="Calibri"/>
-              </a:rPr>
-              <a:t>4  Package &amp; price   ·   5  Guardrails &amp; invest   ·   6  Align &amp; measure   ·   7  Ask</a:t>
+              <a:rPr sz="1200" b="0">
+                <a:solidFill>
+                  <a:srgbClr val="8B9CB3"/>
+                </a:solidFill>
+                <a:latin typeface="Calibri"/>
+              </a:rPr>
+              <a:t>Top-right SLIDE BUDGET + gold bar = live countdown in Slideshow (does not auto-advance).</a:t>
             </a:r>
           </a:p>
         </p:txBody>
@@ -4917,6 +4986,294 @@
                 <a:latin typeface="Calibri"/>
               </a:rPr>
               <a:t>1 / 8</a:t>
+            </a:r>
+          </a:p>
+        </p:txBody>
+      </p:sp>
+      <p:sp>
+        <p:nvSpPr>
+          <p:cNvPr id="17" name="Rounded Rectangle 16"/>
+          <p:cNvSpPr/>
+          <p:nvPr/>
+        </p:nvSpPr>
+        <p:spPr>
+          <a:xfrm>
+            <a:off x="9646920" y="164592"/>
+            <a:ext cx="2331720" cy="868680"/>
+          </a:xfrm>
+          <a:prstGeom prst="roundRect">
+            <a:avLst>
+              <a:gd name="adj" fmla="val 12000"/>
+            </a:avLst>
+          </a:prstGeom>
+          <a:solidFill>
+            <a:srgbClr val="1A2332"/>
+          </a:solidFill>
+          <a:ln>
+            <a:noFill/>
+          </a:ln>
+        </p:spPr>
+        <p:style>
+          <a:lnRef idx="1">
+            <a:schemeClr val="accent1"/>
+          </a:lnRef>
+          <a:fillRef idx="3">
+            <a:schemeClr val="accent1"/>
+          </a:fillRef>
+          <a:effectRef idx="2">
+            <a:schemeClr val="accent1"/>
+          </a:effectRef>
+          <a:fontRef idx="minor">
+            <a:schemeClr val="lt1"/>
+          </a:fontRef>
+        </p:style>
+        <p:txBody>
+          <a:bodyPr rtlCol="0" anchor="ctr"/>
+          <a:lstStyle/>
+          <a:p>
+            <a:pPr algn="ctr"/>
+          </a:p>
+        </p:txBody>
+      </p:sp>
+      <p:sp>
+        <p:nvSpPr>
+          <p:cNvPr id="18" name="Rectangle 17"/>
+          <p:cNvSpPr/>
+          <p:nvPr/>
+        </p:nvSpPr>
+        <p:spPr>
+          <a:xfrm>
+            <a:off x="9646920" y="164592"/>
+            <a:ext cx="73152" cy="868680"/>
+          </a:xfrm>
+          <a:prstGeom prst="rect">
+            <a:avLst/>
+          </a:prstGeom>
+          <a:solidFill>
+            <a:srgbClr val="D4A853"/>
+          </a:solidFill>
+          <a:ln>
+            <a:noFill/>
+          </a:ln>
+        </p:spPr>
+        <p:style>
+          <a:lnRef idx="1">
+            <a:schemeClr val="accent1"/>
+          </a:lnRef>
+          <a:fillRef idx="3">
+            <a:schemeClr val="accent1"/>
+          </a:fillRef>
+          <a:effectRef idx="2">
+            <a:schemeClr val="accent1"/>
+          </a:effectRef>
+          <a:fontRef idx="minor">
+            <a:schemeClr val="lt1"/>
+          </a:fontRef>
+        </p:style>
+        <p:txBody>
+          <a:bodyPr rtlCol="0" anchor="ctr"/>
+          <a:lstStyle/>
+          <a:p>
+            <a:pPr algn="ctr"/>
+          </a:p>
+        </p:txBody>
+      </p:sp>
+      <p:sp>
+        <p:nvSpPr>
+          <p:cNvPr id="19" name="TextBox 18"/>
+          <p:cNvSpPr txBox="1"/>
+          <p:nvPr/>
+        </p:nvSpPr>
+        <p:spPr>
+          <a:xfrm>
+            <a:off x="9811512" y="219456"/>
+            <a:ext cx="2075688" cy="777240"/>
+          </a:xfrm>
+          <a:prstGeom prst="rect">
+            <a:avLst/>
+          </a:prstGeom>
+          <a:noFill/>
+        </p:spPr>
+        <p:txBody>
+          <a:bodyPr wrap="square">
+            <a:spAutoFit/>
+          </a:bodyPr>
+          <a:lstStyle/>
+          <a:p>
+            <a:pPr algn="l">
+              <a:spcAft>
+                <a:spcPts val="0"/>
+              </a:spcAft>
+            </a:pPr>
+            <a:r>
+              <a:rPr sz="900" b="1">
+                <a:solidFill>
+                  <a:srgbClr val="8B9CB3"/>
+                </a:solidFill>
+                <a:latin typeface="Calibri"/>
+              </a:rPr>
+              <a:t>SLIDE BUDGET</a:t>
+            </a:r>
+          </a:p>
+          <a:p>
+            <a:pPr algn="l">
+              <a:spcAft>
+                <a:spcPts val="0"/>
+              </a:spcAft>
+            </a:pPr>
+            <a:r>
+              <a:rPr sz="2600" b="1">
+                <a:solidFill>
+                  <a:srgbClr val="D4A853"/>
+                </a:solidFill>
+                <a:latin typeface="Calibri"/>
+              </a:rPr>
+              <a:t>1:15</a:t>
+            </a:r>
+          </a:p>
+          <a:p>
+            <a:pPr algn="l">
+              <a:spcAft>
+                <a:spcPts val="0"/>
+              </a:spcAft>
+            </a:pPr>
+            <a:r>
+              <a:rPr sz="900" b="0">
+                <a:solidFill>
+                  <a:srgbClr val="8B9CB3"/>
+                </a:solidFill>
+                <a:latin typeface="Calibri"/>
+              </a:rPr>
+              <a:t>by end 1:15 · left 8:45</a:t>
+            </a:r>
+          </a:p>
+        </p:txBody>
+      </p:sp>
+      <p:sp>
+        <p:nvSpPr>
+          <p:cNvPr id="20" name="Rounded Rectangle 19"/>
+          <p:cNvSpPr/>
+          <p:nvPr/>
+        </p:nvSpPr>
+        <p:spPr>
+          <a:xfrm>
+            <a:off x="502920" y="5961888"/>
+            <a:ext cx="11155680" cy="109728"/>
+          </a:xfrm>
+          <a:prstGeom prst="roundRect">
+            <a:avLst>
+              <a:gd name="adj" fmla="val 50000"/>
+            </a:avLst>
+          </a:prstGeom>
+          <a:solidFill>
+            <a:srgbClr val="243044"/>
+          </a:solidFill>
+          <a:ln>
+            <a:noFill/>
+          </a:ln>
+        </p:spPr>
+        <p:style>
+          <a:lnRef idx="1">
+            <a:schemeClr val="accent1"/>
+          </a:lnRef>
+          <a:fillRef idx="3">
+            <a:schemeClr val="accent1"/>
+          </a:fillRef>
+          <a:effectRef idx="2">
+            <a:schemeClr val="accent1"/>
+          </a:effectRef>
+          <a:fontRef idx="minor">
+            <a:schemeClr val="lt1"/>
+          </a:fontRef>
+        </p:style>
+        <p:txBody>
+          <a:bodyPr rtlCol="0" anchor="ctr"/>
+          <a:lstStyle/>
+          <a:p>
+            <a:pPr algn="ctr"/>
+          </a:p>
+        </p:txBody>
+      </p:sp>
+      <p:sp>
+        <p:nvSpPr>
+          <p:cNvPr id="21" name="Rounded Rectangle 20"/>
+          <p:cNvSpPr/>
+          <p:nvPr/>
+        </p:nvSpPr>
+        <p:spPr>
+          <a:xfrm>
+            <a:off x="502920" y="5961888"/>
+            <a:ext cx="11155680" cy="109728"/>
+          </a:xfrm>
+          <a:prstGeom prst="roundRect">
+            <a:avLst>
+              <a:gd name="adj" fmla="val 50000"/>
+            </a:avLst>
+          </a:prstGeom>
+          <a:solidFill>
+            <a:srgbClr val="D4A853"/>
+          </a:solidFill>
+          <a:ln>
+            <a:noFill/>
+          </a:ln>
+        </p:spPr>
+        <p:style>
+          <a:lnRef idx="1">
+            <a:schemeClr val="accent1"/>
+          </a:lnRef>
+          <a:fillRef idx="3">
+            <a:schemeClr val="accent1"/>
+          </a:fillRef>
+          <a:effectRef idx="2">
+            <a:schemeClr val="accent1"/>
+          </a:effectRef>
+          <a:fontRef idx="minor">
+            <a:schemeClr val="lt1"/>
+          </a:fontRef>
+        </p:style>
+        <p:txBody>
+          <a:bodyPr rtlCol="0" anchor="ctr"/>
+          <a:lstStyle/>
+          <a:p>
+            <a:pPr algn="ctr"/>
+          </a:p>
+        </p:txBody>
+      </p:sp>
+      <p:sp>
+        <p:nvSpPr>
+          <p:cNvPr id="22" name="TextBox 21"/>
+          <p:cNvSpPr txBox="1"/>
+          <p:nvPr/>
+        </p:nvSpPr>
+        <p:spPr>
+          <a:xfrm>
+            <a:off x="502920" y="5760720"/>
+            <a:ext cx="5029200" cy="201168"/>
+          </a:xfrm>
+          <a:prstGeom prst="rect">
+            <a:avLst/>
+          </a:prstGeom>
+          <a:noFill/>
+        </p:spPr>
+        <p:txBody>
+          <a:bodyPr wrap="none">
+            <a:spAutoFit/>
+          </a:bodyPr>
+          <a:lstStyle/>
+          <a:p>
+            <a:pPr algn="l">
+              <a:spcAft>
+                <a:spcPts val="0"/>
+              </a:spcAft>
+            </a:pPr>
+            <a:r>
+              <a:rPr sz="800" b="0">
+                <a:solidFill>
+                  <a:srgbClr val="8B9CB3"/>
+                </a:solidFill>
+                <a:latin typeface="Calibri"/>
+              </a:rPr>
+              <a:t>Countdown bar starts in Slideshow · does not auto-advance — you click when ready</a:t>
             </a:r>
           </a:p>
         </p:txBody>
@@ -4926,6 +5283,62 @@
   <p:clrMapOvr>
     <a:masterClrMapping/>
   </p:clrMapOvr>
+  <p:timing>
+    <p:tnLst>
+      <p:par>
+        <p:cTn id="1" dur="indefinite" restart="never" nodeType="tmRoot">
+          <p:childTnLst>
+            <p:seq concurrent="1" nextAc="seek">
+              <p:cTn id="2" dur="indefinite" nodeType="mainSeq">
+                <p:childTnLst>
+                  <p:par>
+                    <p:cTn id="3" fill="hold">
+                      <p:stCondLst>
+                        <p:cond delay="0"/>
+                      </p:stCondLst>
+                      <p:childTnLst>
+                        <p:par>
+                          <p:cTn id="4" fill="hold">
+                            <p:stCondLst>
+                              <p:cond delay="0"/>
+                            </p:stCondLst>
+                            <p:childTnLst>
+                              <p:animEffect transition="out" filter="wipe(left)">
+                                <p:cBhvr>
+                                  <p:cTn id="5" dur="75000" fill="hold"/>
+                                  <p:tgtEl>
+                                    <p:spTgt spid="21"/>
+                                  </p:tgtEl>
+                                </p:cBhvr>
+                              </p:animEffect>
+                            </p:childTnLst>
+                          </p:cTn>
+                        </p:par>
+                      </p:childTnLst>
+                    </p:cTn>
+                  </p:par>
+                </p:childTnLst>
+              </p:cTn>
+              <p:prevCondLst>
+                <p:cond evt="onPrev" delay="0">
+                  <p:tgtEl>
+                    <p:sldTgt/>
+                  </p:tgtEl>
+                </p:cond>
+              </p:prevCondLst>
+              <p:nextCondLst>
+                <p:cond evt="onNext" delay="0">
+                  <p:tgtEl>
+                    <p:sldTgt/>
+                  </p:tgtEl>
+                </p:cond>
+              </p:nextCondLst>
+            </p:seq>
+          </p:childTnLst>
+        </p:cTn>
+      </p:par>
+    </p:tnLst>
+  </p:timing>
 </p:sld>
 </file>
 
@@ -5030,7 +5443,7 @@
         <p:spPr>
           <a:xfrm>
             <a:off x="502920" y="438912"/>
-            <a:ext cx="11155680" cy="594360"/>
+            <a:ext cx="8869680" cy="594360"/>
           </a:xfrm>
           <a:prstGeom prst="rect">
             <a:avLst/>
@@ -6109,7 +6522,7 @@
         </p:nvSpPr>
         <p:spPr>
           <a:xfrm>
-            <a:off x="502920" y="6144768"/>
+            <a:off x="502920" y="6199632"/>
             <a:ext cx="1508760" cy="292608"/>
           </a:xfrm>
           <a:prstGeom prst="roundRect">
@@ -6154,7 +6567,7 @@
         </p:nvSpPr>
         <p:spPr>
           <a:xfrm>
-            <a:off x="502920" y="6144768"/>
+            <a:off x="502920" y="6199632"/>
             <a:ext cx="1508760" cy="45720"/>
           </a:xfrm>
           <a:prstGeom prst="rect">
@@ -6197,7 +6610,7 @@
         </p:nvSpPr>
         <p:spPr>
           <a:xfrm>
-            <a:off x="502920" y="6163056"/>
+            <a:off x="502920" y="6217920"/>
             <a:ext cx="1508760" cy="256032"/>
           </a:xfrm>
           <a:prstGeom prst="rect">
@@ -6236,7 +6649,7 @@
         </p:nvSpPr>
         <p:spPr>
           <a:xfrm>
-            <a:off x="2121408" y="6144768"/>
+            <a:off x="2121408" y="6199632"/>
             <a:ext cx="1508760" cy="292608"/>
           </a:xfrm>
           <a:prstGeom prst="roundRect">
@@ -6281,7 +6694,7 @@
         </p:nvSpPr>
         <p:spPr>
           <a:xfrm>
-            <a:off x="2121408" y="6163056"/>
+            <a:off x="2121408" y="6217920"/>
             <a:ext cx="1508760" cy="256032"/>
           </a:xfrm>
           <a:prstGeom prst="rect">
@@ -6320,7 +6733,7 @@
         </p:nvSpPr>
         <p:spPr>
           <a:xfrm>
-            <a:off x="3739896" y="6144768"/>
+            <a:off x="3739896" y="6199632"/>
             <a:ext cx="1508760" cy="292608"/>
           </a:xfrm>
           <a:prstGeom prst="roundRect">
@@ -6365,7 +6778,7 @@
         </p:nvSpPr>
         <p:spPr>
           <a:xfrm>
-            <a:off x="3739896" y="6163056"/>
+            <a:off x="3739896" y="6217920"/>
             <a:ext cx="1508760" cy="256032"/>
           </a:xfrm>
           <a:prstGeom prst="rect">
@@ -6404,7 +6817,7 @@
         </p:nvSpPr>
         <p:spPr>
           <a:xfrm>
-            <a:off x="5358384" y="6144768"/>
+            <a:off x="5358384" y="6199632"/>
             <a:ext cx="1508760" cy="292608"/>
           </a:xfrm>
           <a:prstGeom prst="roundRect">
@@ -6449,7 +6862,7 @@
         </p:nvSpPr>
         <p:spPr>
           <a:xfrm>
-            <a:off x="5358384" y="6163056"/>
+            <a:off x="5358384" y="6217920"/>
             <a:ext cx="1508760" cy="256032"/>
           </a:xfrm>
           <a:prstGeom prst="rect">
@@ -6488,7 +6901,7 @@
         </p:nvSpPr>
         <p:spPr>
           <a:xfrm>
-            <a:off x="6976872" y="6144768"/>
+            <a:off x="6976872" y="6199632"/>
             <a:ext cx="1508760" cy="292608"/>
           </a:xfrm>
           <a:prstGeom prst="roundRect">
@@ -6533,7 +6946,7 @@
         </p:nvSpPr>
         <p:spPr>
           <a:xfrm>
-            <a:off x="6976872" y="6163056"/>
+            <a:off x="6976872" y="6217920"/>
             <a:ext cx="1508760" cy="256032"/>
           </a:xfrm>
           <a:prstGeom prst="rect">
@@ -6572,7 +6985,7 @@
         </p:nvSpPr>
         <p:spPr>
           <a:xfrm>
-            <a:off x="8595360" y="6144768"/>
+            <a:off x="8595360" y="6199632"/>
             <a:ext cx="1508760" cy="292608"/>
           </a:xfrm>
           <a:prstGeom prst="roundRect">
@@ -6617,7 +7030,7 @@
         </p:nvSpPr>
         <p:spPr>
           <a:xfrm>
-            <a:off x="8595360" y="6163056"/>
+            <a:off x="8595360" y="6217920"/>
             <a:ext cx="1508760" cy="256032"/>
           </a:xfrm>
           <a:prstGeom prst="rect">
@@ -6656,7 +7069,7 @@
         </p:nvSpPr>
         <p:spPr>
           <a:xfrm>
-            <a:off x="10213848" y="6144768"/>
+            <a:off x="10213848" y="6199632"/>
             <a:ext cx="1508760" cy="292608"/>
           </a:xfrm>
           <a:prstGeom prst="roundRect">
@@ -6701,7 +7114,7 @@
         </p:nvSpPr>
         <p:spPr>
           <a:xfrm>
-            <a:off x="10213848" y="6163056"/>
+            <a:off x="10213848" y="6217920"/>
             <a:ext cx="1508760" cy="256032"/>
           </a:xfrm>
           <a:prstGeom prst="rect">
@@ -6806,6 +7219,294 @@
                 <a:latin typeface="Calibri"/>
               </a:rPr>
               <a:t>2 / 8</a:t>
+            </a:r>
+          </a:p>
+        </p:txBody>
+      </p:sp>
+      <p:sp>
+        <p:nvSpPr>
+          <p:cNvPr id="41" name="Rounded Rectangle 40"/>
+          <p:cNvSpPr/>
+          <p:nvPr/>
+        </p:nvSpPr>
+        <p:spPr>
+          <a:xfrm>
+            <a:off x="9646920" y="164592"/>
+            <a:ext cx="2331720" cy="868680"/>
+          </a:xfrm>
+          <a:prstGeom prst="roundRect">
+            <a:avLst>
+              <a:gd name="adj" fmla="val 12000"/>
+            </a:avLst>
+          </a:prstGeom>
+          <a:solidFill>
+            <a:srgbClr val="1A2332"/>
+          </a:solidFill>
+          <a:ln>
+            <a:noFill/>
+          </a:ln>
+        </p:spPr>
+        <p:style>
+          <a:lnRef idx="1">
+            <a:schemeClr val="accent1"/>
+          </a:lnRef>
+          <a:fillRef idx="3">
+            <a:schemeClr val="accent1"/>
+          </a:fillRef>
+          <a:effectRef idx="2">
+            <a:schemeClr val="accent1"/>
+          </a:effectRef>
+          <a:fontRef idx="minor">
+            <a:schemeClr val="lt1"/>
+          </a:fontRef>
+        </p:style>
+        <p:txBody>
+          <a:bodyPr rtlCol="0" anchor="ctr"/>
+          <a:lstStyle/>
+          <a:p>
+            <a:pPr algn="ctr"/>
+          </a:p>
+        </p:txBody>
+      </p:sp>
+      <p:sp>
+        <p:nvSpPr>
+          <p:cNvPr id="42" name="Rectangle 41"/>
+          <p:cNvSpPr/>
+          <p:nvPr/>
+        </p:nvSpPr>
+        <p:spPr>
+          <a:xfrm>
+            <a:off x="9646920" y="164592"/>
+            <a:ext cx="73152" cy="868680"/>
+          </a:xfrm>
+          <a:prstGeom prst="rect">
+            <a:avLst/>
+          </a:prstGeom>
+          <a:solidFill>
+            <a:srgbClr val="D4A853"/>
+          </a:solidFill>
+          <a:ln>
+            <a:noFill/>
+          </a:ln>
+        </p:spPr>
+        <p:style>
+          <a:lnRef idx="1">
+            <a:schemeClr val="accent1"/>
+          </a:lnRef>
+          <a:fillRef idx="3">
+            <a:schemeClr val="accent1"/>
+          </a:fillRef>
+          <a:effectRef idx="2">
+            <a:schemeClr val="accent1"/>
+          </a:effectRef>
+          <a:fontRef idx="minor">
+            <a:schemeClr val="lt1"/>
+          </a:fontRef>
+        </p:style>
+        <p:txBody>
+          <a:bodyPr rtlCol="0" anchor="ctr"/>
+          <a:lstStyle/>
+          <a:p>
+            <a:pPr algn="ctr"/>
+          </a:p>
+        </p:txBody>
+      </p:sp>
+      <p:sp>
+        <p:nvSpPr>
+          <p:cNvPr id="43" name="TextBox 42"/>
+          <p:cNvSpPr txBox="1"/>
+          <p:nvPr/>
+        </p:nvSpPr>
+        <p:spPr>
+          <a:xfrm>
+            <a:off x="9811512" y="219456"/>
+            <a:ext cx="2075688" cy="777240"/>
+          </a:xfrm>
+          <a:prstGeom prst="rect">
+            <a:avLst/>
+          </a:prstGeom>
+          <a:noFill/>
+        </p:spPr>
+        <p:txBody>
+          <a:bodyPr wrap="square">
+            <a:spAutoFit/>
+          </a:bodyPr>
+          <a:lstStyle/>
+          <a:p>
+            <a:pPr algn="l">
+              <a:spcAft>
+                <a:spcPts val="0"/>
+              </a:spcAft>
+            </a:pPr>
+            <a:r>
+              <a:rPr sz="900" b="1">
+                <a:solidFill>
+                  <a:srgbClr val="8B9CB3"/>
+                </a:solidFill>
+                <a:latin typeface="Calibri"/>
+              </a:rPr>
+              <a:t>SLIDE BUDGET</a:t>
+            </a:r>
+          </a:p>
+          <a:p>
+            <a:pPr algn="l">
+              <a:spcAft>
+                <a:spcPts val="0"/>
+              </a:spcAft>
+            </a:pPr>
+            <a:r>
+              <a:rPr sz="2600" b="1">
+                <a:solidFill>
+                  <a:srgbClr val="D4A853"/>
+                </a:solidFill>
+                <a:latin typeface="Calibri"/>
+              </a:rPr>
+              <a:t>1:20</a:t>
+            </a:r>
+          </a:p>
+          <a:p>
+            <a:pPr algn="l">
+              <a:spcAft>
+                <a:spcPts val="0"/>
+              </a:spcAft>
+            </a:pPr>
+            <a:r>
+              <a:rPr sz="900" b="0">
+                <a:solidFill>
+                  <a:srgbClr val="8B9CB3"/>
+                </a:solidFill>
+                <a:latin typeface="Calibri"/>
+              </a:rPr>
+              <a:t>by end 2:35 · left 7:25</a:t>
+            </a:r>
+          </a:p>
+        </p:txBody>
+      </p:sp>
+      <p:sp>
+        <p:nvSpPr>
+          <p:cNvPr id="44" name="Rounded Rectangle 43"/>
+          <p:cNvSpPr/>
+          <p:nvPr/>
+        </p:nvSpPr>
+        <p:spPr>
+          <a:xfrm>
+            <a:off x="502920" y="5961888"/>
+            <a:ext cx="11155680" cy="109728"/>
+          </a:xfrm>
+          <a:prstGeom prst="roundRect">
+            <a:avLst>
+              <a:gd name="adj" fmla="val 50000"/>
+            </a:avLst>
+          </a:prstGeom>
+          <a:solidFill>
+            <a:srgbClr val="243044"/>
+          </a:solidFill>
+          <a:ln>
+            <a:noFill/>
+          </a:ln>
+        </p:spPr>
+        <p:style>
+          <a:lnRef idx="1">
+            <a:schemeClr val="accent1"/>
+          </a:lnRef>
+          <a:fillRef idx="3">
+            <a:schemeClr val="accent1"/>
+          </a:fillRef>
+          <a:effectRef idx="2">
+            <a:schemeClr val="accent1"/>
+          </a:effectRef>
+          <a:fontRef idx="minor">
+            <a:schemeClr val="lt1"/>
+          </a:fontRef>
+        </p:style>
+        <p:txBody>
+          <a:bodyPr rtlCol="0" anchor="ctr"/>
+          <a:lstStyle/>
+          <a:p>
+            <a:pPr algn="ctr"/>
+          </a:p>
+        </p:txBody>
+      </p:sp>
+      <p:sp>
+        <p:nvSpPr>
+          <p:cNvPr id="45" name="Rounded Rectangle 44"/>
+          <p:cNvSpPr/>
+          <p:nvPr/>
+        </p:nvSpPr>
+        <p:spPr>
+          <a:xfrm>
+            <a:off x="502920" y="5961888"/>
+            <a:ext cx="11155680" cy="109728"/>
+          </a:xfrm>
+          <a:prstGeom prst="roundRect">
+            <a:avLst>
+              <a:gd name="adj" fmla="val 50000"/>
+            </a:avLst>
+          </a:prstGeom>
+          <a:solidFill>
+            <a:srgbClr val="D4A853"/>
+          </a:solidFill>
+          <a:ln>
+            <a:noFill/>
+          </a:ln>
+        </p:spPr>
+        <p:style>
+          <a:lnRef idx="1">
+            <a:schemeClr val="accent1"/>
+          </a:lnRef>
+          <a:fillRef idx="3">
+            <a:schemeClr val="accent1"/>
+          </a:fillRef>
+          <a:effectRef idx="2">
+            <a:schemeClr val="accent1"/>
+          </a:effectRef>
+          <a:fontRef idx="minor">
+            <a:schemeClr val="lt1"/>
+          </a:fontRef>
+        </p:style>
+        <p:txBody>
+          <a:bodyPr rtlCol="0" anchor="ctr"/>
+          <a:lstStyle/>
+          <a:p>
+            <a:pPr algn="ctr"/>
+          </a:p>
+        </p:txBody>
+      </p:sp>
+      <p:sp>
+        <p:nvSpPr>
+          <p:cNvPr id="46" name="TextBox 45"/>
+          <p:cNvSpPr txBox="1"/>
+          <p:nvPr/>
+        </p:nvSpPr>
+        <p:spPr>
+          <a:xfrm>
+            <a:off x="502920" y="5760720"/>
+            <a:ext cx="5029200" cy="201168"/>
+          </a:xfrm>
+          <a:prstGeom prst="rect">
+            <a:avLst/>
+          </a:prstGeom>
+          <a:noFill/>
+        </p:spPr>
+        <p:txBody>
+          <a:bodyPr wrap="none">
+            <a:spAutoFit/>
+          </a:bodyPr>
+          <a:lstStyle/>
+          <a:p>
+            <a:pPr algn="l">
+              <a:spcAft>
+                <a:spcPts val="0"/>
+              </a:spcAft>
+            </a:pPr>
+            <a:r>
+              <a:rPr sz="800" b="0">
+                <a:solidFill>
+                  <a:srgbClr val="8B9CB3"/>
+                </a:solidFill>
+                <a:latin typeface="Calibri"/>
+              </a:rPr>
+              <a:t>Countdown bar starts in Slideshow · does not auto-advance — you click when ready</a:t>
             </a:r>
           </a:p>
         </p:txBody>
@@ -6815,6 +7516,62 @@
   <p:clrMapOvr>
     <a:masterClrMapping/>
   </p:clrMapOvr>
+  <p:timing>
+    <p:tnLst>
+      <p:par>
+        <p:cTn id="1" dur="indefinite" restart="never" nodeType="tmRoot">
+          <p:childTnLst>
+            <p:seq concurrent="1" nextAc="seek">
+              <p:cTn id="2" dur="indefinite" nodeType="mainSeq">
+                <p:childTnLst>
+                  <p:par>
+                    <p:cTn id="3" fill="hold">
+                      <p:stCondLst>
+                        <p:cond delay="0"/>
+                      </p:stCondLst>
+                      <p:childTnLst>
+                        <p:par>
+                          <p:cTn id="4" fill="hold">
+                            <p:stCondLst>
+                              <p:cond delay="0"/>
+                            </p:stCondLst>
+                            <p:childTnLst>
+                              <p:animEffect transition="out" filter="wipe(left)">
+                                <p:cBhvr>
+                                  <p:cTn id="5" dur="80000" fill="hold"/>
+                                  <p:tgtEl>
+                                    <p:spTgt spid="45"/>
+                                  </p:tgtEl>
+                                </p:cBhvr>
+                              </p:animEffect>
+                            </p:childTnLst>
+                          </p:cTn>
+                        </p:par>
+                      </p:childTnLst>
+                    </p:cTn>
+                  </p:par>
+                </p:childTnLst>
+              </p:cTn>
+              <p:prevCondLst>
+                <p:cond evt="onPrev" delay="0">
+                  <p:tgtEl>
+                    <p:sldTgt/>
+                  </p:tgtEl>
+                </p:cond>
+              </p:prevCondLst>
+              <p:nextCondLst>
+                <p:cond evt="onNext" delay="0">
+                  <p:tgtEl>
+                    <p:sldTgt/>
+                  </p:tgtEl>
+                </p:cond>
+              </p:nextCondLst>
+            </p:seq>
+          </p:childTnLst>
+        </p:cTn>
+      </p:par>
+    </p:tnLst>
+  </p:timing>
 </p:sld>
 </file>
 
@@ -6919,7 +7676,7 @@
         <p:spPr>
           <a:xfrm>
             <a:off x="502920" y="438912"/>
-            <a:ext cx="11155680" cy="594360"/>
+            <a:ext cx="8869680" cy="594360"/>
           </a:xfrm>
           <a:prstGeom prst="rect">
             <a:avLst/>
@@ -7648,7 +8405,7 @@
         </p:nvSpPr>
         <p:spPr>
           <a:xfrm>
-            <a:off x="502920" y="6144768"/>
+            <a:off x="502920" y="6199632"/>
             <a:ext cx="1508760" cy="292608"/>
           </a:xfrm>
           <a:prstGeom prst="roundRect">
@@ -7693,7 +8450,7 @@
         </p:nvSpPr>
         <p:spPr>
           <a:xfrm>
-            <a:off x="502920" y="6163056"/>
+            <a:off x="502920" y="6217920"/>
             <a:ext cx="1508760" cy="256032"/>
           </a:xfrm>
           <a:prstGeom prst="rect">
@@ -7732,7 +8489,7 @@
         </p:nvSpPr>
         <p:spPr>
           <a:xfrm>
-            <a:off x="2121408" y="6144768"/>
+            <a:off x="2121408" y="6199632"/>
             <a:ext cx="1508760" cy="292608"/>
           </a:xfrm>
           <a:prstGeom prst="roundRect">
@@ -7777,7 +8534,7 @@
         </p:nvSpPr>
         <p:spPr>
           <a:xfrm>
-            <a:off x="2121408" y="6144768"/>
+            <a:off x="2121408" y="6199632"/>
             <a:ext cx="1508760" cy="45720"/>
           </a:xfrm>
           <a:prstGeom prst="rect">
@@ -7820,7 +8577,7 @@
         </p:nvSpPr>
         <p:spPr>
           <a:xfrm>
-            <a:off x="2121408" y="6163056"/>
+            <a:off x="2121408" y="6217920"/>
             <a:ext cx="1508760" cy="256032"/>
           </a:xfrm>
           <a:prstGeom prst="rect">
@@ -7859,7 +8616,7 @@
         </p:nvSpPr>
         <p:spPr>
           <a:xfrm>
-            <a:off x="3739896" y="6144768"/>
+            <a:off x="3739896" y="6199632"/>
             <a:ext cx="1508760" cy="292608"/>
           </a:xfrm>
           <a:prstGeom prst="roundRect">
@@ -7904,7 +8661,7 @@
         </p:nvSpPr>
         <p:spPr>
           <a:xfrm>
-            <a:off x="3739896" y="6163056"/>
+            <a:off x="3739896" y="6217920"/>
             <a:ext cx="1508760" cy="256032"/>
           </a:xfrm>
           <a:prstGeom prst="rect">
@@ -7943,7 +8700,7 @@
         </p:nvSpPr>
         <p:spPr>
           <a:xfrm>
-            <a:off x="5358384" y="6144768"/>
+            <a:off x="5358384" y="6199632"/>
             <a:ext cx="1508760" cy="292608"/>
           </a:xfrm>
           <a:prstGeom prst="roundRect">
@@ -7988,7 +8745,7 @@
         </p:nvSpPr>
         <p:spPr>
           <a:xfrm>
-            <a:off x="5358384" y="6163056"/>
+            <a:off x="5358384" y="6217920"/>
             <a:ext cx="1508760" cy="256032"/>
           </a:xfrm>
           <a:prstGeom prst="rect">
@@ -8027,7 +8784,7 @@
         </p:nvSpPr>
         <p:spPr>
           <a:xfrm>
-            <a:off x="6976872" y="6144768"/>
+            <a:off x="6976872" y="6199632"/>
             <a:ext cx="1508760" cy="292608"/>
           </a:xfrm>
           <a:prstGeom prst="roundRect">
@@ -8072,7 +8829,7 @@
         </p:nvSpPr>
         <p:spPr>
           <a:xfrm>
-            <a:off x="6976872" y="6163056"/>
+            <a:off x="6976872" y="6217920"/>
             <a:ext cx="1508760" cy="256032"/>
           </a:xfrm>
           <a:prstGeom prst="rect">
@@ -8111,7 +8868,7 @@
         </p:nvSpPr>
         <p:spPr>
           <a:xfrm>
-            <a:off x="8595360" y="6144768"/>
+            <a:off x="8595360" y="6199632"/>
             <a:ext cx="1508760" cy="292608"/>
           </a:xfrm>
           <a:prstGeom prst="roundRect">
@@ -8156,7 +8913,7 @@
         </p:nvSpPr>
         <p:spPr>
           <a:xfrm>
-            <a:off x="8595360" y="6163056"/>
+            <a:off x="8595360" y="6217920"/>
             <a:ext cx="1508760" cy="256032"/>
           </a:xfrm>
           <a:prstGeom prst="rect">
@@ -8195,7 +8952,7 @@
         </p:nvSpPr>
         <p:spPr>
           <a:xfrm>
-            <a:off x="10213848" y="6144768"/>
+            <a:off x="10213848" y="6199632"/>
             <a:ext cx="1508760" cy="292608"/>
           </a:xfrm>
           <a:prstGeom prst="roundRect">
@@ -8240,7 +8997,7 @@
         </p:nvSpPr>
         <p:spPr>
           <a:xfrm>
-            <a:off x="10213848" y="6163056"/>
+            <a:off x="10213848" y="6217920"/>
             <a:ext cx="1508760" cy="256032"/>
           </a:xfrm>
           <a:prstGeom prst="rect">
@@ -8345,6 +9102,294 @@
                 <a:latin typeface="Calibri"/>
               </a:rPr>
               <a:t>3 / 8</a:t>
+            </a:r>
+          </a:p>
+        </p:txBody>
+      </p:sp>
+      <p:sp>
+        <p:nvSpPr>
+          <p:cNvPr id="35" name="Rounded Rectangle 34"/>
+          <p:cNvSpPr/>
+          <p:nvPr/>
+        </p:nvSpPr>
+        <p:spPr>
+          <a:xfrm>
+            <a:off x="9646920" y="164592"/>
+            <a:ext cx="2331720" cy="868680"/>
+          </a:xfrm>
+          <a:prstGeom prst="roundRect">
+            <a:avLst>
+              <a:gd name="adj" fmla="val 12000"/>
+            </a:avLst>
+          </a:prstGeom>
+          <a:solidFill>
+            <a:srgbClr val="1A2332"/>
+          </a:solidFill>
+          <a:ln>
+            <a:noFill/>
+          </a:ln>
+        </p:spPr>
+        <p:style>
+          <a:lnRef idx="1">
+            <a:schemeClr val="accent1"/>
+          </a:lnRef>
+          <a:fillRef idx="3">
+            <a:schemeClr val="accent1"/>
+          </a:fillRef>
+          <a:effectRef idx="2">
+            <a:schemeClr val="accent1"/>
+          </a:effectRef>
+          <a:fontRef idx="minor">
+            <a:schemeClr val="lt1"/>
+          </a:fontRef>
+        </p:style>
+        <p:txBody>
+          <a:bodyPr rtlCol="0" anchor="ctr"/>
+          <a:lstStyle/>
+          <a:p>
+            <a:pPr algn="ctr"/>
+          </a:p>
+        </p:txBody>
+      </p:sp>
+      <p:sp>
+        <p:nvSpPr>
+          <p:cNvPr id="36" name="Rectangle 35"/>
+          <p:cNvSpPr/>
+          <p:nvPr/>
+        </p:nvSpPr>
+        <p:spPr>
+          <a:xfrm>
+            <a:off x="9646920" y="164592"/>
+            <a:ext cx="73152" cy="868680"/>
+          </a:xfrm>
+          <a:prstGeom prst="rect">
+            <a:avLst/>
+          </a:prstGeom>
+          <a:solidFill>
+            <a:srgbClr val="D4A853"/>
+          </a:solidFill>
+          <a:ln>
+            <a:noFill/>
+          </a:ln>
+        </p:spPr>
+        <p:style>
+          <a:lnRef idx="1">
+            <a:schemeClr val="accent1"/>
+          </a:lnRef>
+          <a:fillRef idx="3">
+            <a:schemeClr val="accent1"/>
+          </a:fillRef>
+          <a:effectRef idx="2">
+            <a:schemeClr val="accent1"/>
+          </a:effectRef>
+          <a:fontRef idx="minor">
+            <a:schemeClr val="lt1"/>
+          </a:fontRef>
+        </p:style>
+        <p:txBody>
+          <a:bodyPr rtlCol="0" anchor="ctr"/>
+          <a:lstStyle/>
+          <a:p>
+            <a:pPr algn="ctr"/>
+          </a:p>
+        </p:txBody>
+      </p:sp>
+      <p:sp>
+        <p:nvSpPr>
+          <p:cNvPr id="37" name="TextBox 36"/>
+          <p:cNvSpPr txBox="1"/>
+          <p:nvPr/>
+        </p:nvSpPr>
+        <p:spPr>
+          <a:xfrm>
+            <a:off x="9811512" y="219456"/>
+            <a:ext cx="2075688" cy="777240"/>
+          </a:xfrm>
+          <a:prstGeom prst="rect">
+            <a:avLst/>
+          </a:prstGeom>
+          <a:noFill/>
+        </p:spPr>
+        <p:txBody>
+          <a:bodyPr wrap="square">
+            <a:spAutoFit/>
+          </a:bodyPr>
+          <a:lstStyle/>
+          <a:p>
+            <a:pPr algn="l">
+              <a:spcAft>
+                <a:spcPts val="0"/>
+              </a:spcAft>
+            </a:pPr>
+            <a:r>
+              <a:rPr sz="900" b="1">
+                <a:solidFill>
+                  <a:srgbClr val="8B9CB3"/>
+                </a:solidFill>
+                <a:latin typeface="Calibri"/>
+              </a:rPr>
+              <a:t>SLIDE BUDGET</a:t>
+            </a:r>
+          </a:p>
+          <a:p>
+            <a:pPr algn="l">
+              <a:spcAft>
+                <a:spcPts val="0"/>
+              </a:spcAft>
+            </a:pPr>
+            <a:r>
+              <a:rPr sz="2600" b="1">
+                <a:solidFill>
+                  <a:srgbClr val="D4A853"/>
+                </a:solidFill>
+                <a:latin typeface="Calibri"/>
+              </a:rPr>
+              <a:t>1:20</a:t>
+            </a:r>
+          </a:p>
+          <a:p>
+            <a:pPr algn="l">
+              <a:spcAft>
+                <a:spcPts val="0"/>
+              </a:spcAft>
+            </a:pPr>
+            <a:r>
+              <a:rPr sz="900" b="0">
+                <a:solidFill>
+                  <a:srgbClr val="8B9CB3"/>
+                </a:solidFill>
+                <a:latin typeface="Calibri"/>
+              </a:rPr>
+              <a:t>by end 3:55 · left 6:05</a:t>
+            </a:r>
+          </a:p>
+        </p:txBody>
+      </p:sp>
+      <p:sp>
+        <p:nvSpPr>
+          <p:cNvPr id="38" name="Rounded Rectangle 37"/>
+          <p:cNvSpPr/>
+          <p:nvPr/>
+        </p:nvSpPr>
+        <p:spPr>
+          <a:xfrm>
+            <a:off x="502920" y="5961888"/>
+            <a:ext cx="11155680" cy="109728"/>
+          </a:xfrm>
+          <a:prstGeom prst="roundRect">
+            <a:avLst>
+              <a:gd name="adj" fmla="val 50000"/>
+            </a:avLst>
+          </a:prstGeom>
+          <a:solidFill>
+            <a:srgbClr val="243044"/>
+          </a:solidFill>
+          <a:ln>
+            <a:noFill/>
+          </a:ln>
+        </p:spPr>
+        <p:style>
+          <a:lnRef idx="1">
+            <a:schemeClr val="accent1"/>
+          </a:lnRef>
+          <a:fillRef idx="3">
+            <a:schemeClr val="accent1"/>
+          </a:fillRef>
+          <a:effectRef idx="2">
+            <a:schemeClr val="accent1"/>
+          </a:effectRef>
+          <a:fontRef idx="minor">
+            <a:schemeClr val="lt1"/>
+          </a:fontRef>
+        </p:style>
+        <p:txBody>
+          <a:bodyPr rtlCol="0" anchor="ctr"/>
+          <a:lstStyle/>
+          <a:p>
+            <a:pPr algn="ctr"/>
+          </a:p>
+        </p:txBody>
+      </p:sp>
+      <p:sp>
+        <p:nvSpPr>
+          <p:cNvPr id="39" name="Rounded Rectangle 38"/>
+          <p:cNvSpPr/>
+          <p:nvPr/>
+        </p:nvSpPr>
+        <p:spPr>
+          <a:xfrm>
+            <a:off x="502920" y="5961888"/>
+            <a:ext cx="11155680" cy="109728"/>
+          </a:xfrm>
+          <a:prstGeom prst="roundRect">
+            <a:avLst>
+              <a:gd name="adj" fmla="val 50000"/>
+            </a:avLst>
+          </a:prstGeom>
+          <a:solidFill>
+            <a:srgbClr val="D4A853"/>
+          </a:solidFill>
+          <a:ln>
+            <a:noFill/>
+          </a:ln>
+        </p:spPr>
+        <p:style>
+          <a:lnRef idx="1">
+            <a:schemeClr val="accent1"/>
+          </a:lnRef>
+          <a:fillRef idx="3">
+            <a:schemeClr val="accent1"/>
+          </a:fillRef>
+          <a:effectRef idx="2">
+            <a:schemeClr val="accent1"/>
+          </a:effectRef>
+          <a:fontRef idx="minor">
+            <a:schemeClr val="lt1"/>
+          </a:fontRef>
+        </p:style>
+        <p:txBody>
+          <a:bodyPr rtlCol="0" anchor="ctr"/>
+          <a:lstStyle/>
+          <a:p>
+            <a:pPr algn="ctr"/>
+          </a:p>
+        </p:txBody>
+      </p:sp>
+      <p:sp>
+        <p:nvSpPr>
+          <p:cNvPr id="40" name="TextBox 39"/>
+          <p:cNvSpPr txBox="1"/>
+          <p:nvPr/>
+        </p:nvSpPr>
+        <p:spPr>
+          <a:xfrm>
+            <a:off x="502920" y="5760720"/>
+            <a:ext cx="5029200" cy="201168"/>
+          </a:xfrm>
+          <a:prstGeom prst="rect">
+            <a:avLst/>
+          </a:prstGeom>
+          <a:noFill/>
+        </p:spPr>
+        <p:txBody>
+          <a:bodyPr wrap="none">
+            <a:spAutoFit/>
+          </a:bodyPr>
+          <a:lstStyle/>
+          <a:p>
+            <a:pPr algn="l">
+              <a:spcAft>
+                <a:spcPts val="0"/>
+              </a:spcAft>
+            </a:pPr>
+            <a:r>
+              <a:rPr sz="800" b="0">
+                <a:solidFill>
+                  <a:srgbClr val="8B9CB3"/>
+                </a:solidFill>
+                <a:latin typeface="Calibri"/>
+              </a:rPr>
+              <a:t>Countdown bar starts in Slideshow · does not auto-advance — you click when ready</a:t>
             </a:r>
           </a:p>
         </p:txBody>
@@ -8354,6 +9399,62 @@
   <p:clrMapOvr>
     <a:masterClrMapping/>
   </p:clrMapOvr>
+  <p:timing>
+    <p:tnLst>
+      <p:par>
+        <p:cTn id="1" dur="indefinite" restart="never" nodeType="tmRoot">
+          <p:childTnLst>
+            <p:seq concurrent="1" nextAc="seek">
+              <p:cTn id="2" dur="indefinite" nodeType="mainSeq">
+                <p:childTnLst>
+                  <p:par>
+                    <p:cTn id="3" fill="hold">
+                      <p:stCondLst>
+                        <p:cond delay="0"/>
+                      </p:stCondLst>
+                      <p:childTnLst>
+                        <p:par>
+                          <p:cTn id="4" fill="hold">
+                            <p:stCondLst>
+                              <p:cond delay="0"/>
+                            </p:stCondLst>
+                            <p:childTnLst>
+                              <p:animEffect transition="out" filter="wipe(left)">
+                                <p:cBhvr>
+                                  <p:cTn id="5" dur="80000" fill="hold"/>
+                                  <p:tgtEl>
+                                    <p:spTgt spid="39"/>
+                                  </p:tgtEl>
+                                </p:cBhvr>
+                              </p:animEffect>
+                            </p:childTnLst>
+                          </p:cTn>
+                        </p:par>
+                      </p:childTnLst>
+                    </p:cTn>
+                  </p:par>
+                </p:childTnLst>
+              </p:cTn>
+              <p:prevCondLst>
+                <p:cond evt="onPrev" delay="0">
+                  <p:tgtEl>
+                    <p:sldTgt/>
+                  </p:tgtEl>
+                </p:cond>
+              </p:prevCondLst>
+              <p:nextCondLst>
+                <p:cond evt="onNext" delay="0">
+                  <p:tgtEl>
+                    <p:sldTgt/>
+                  </p:tgtEl>
+                </p:cond>
+              </p:nextCondLst>
+            </p:seq>
+          </p:childTnLst>
+        </p:cTn>
+      </p:par>
+    </p:tnLst>
+  </p:timing>
 </p:sld>
 </file>
 
@@ -8458,7 +9559,7 @@
         <p:spPr>
           <a:xfrm>
             <a:off x="502920" y="438912"/>
-            <a:ext cx="11155680" cy="594360"/>
+            <a:ext cx="8869680" cy="594360"/>
           </a:xfrm>
           <a:prstGeom prst="rect">
             <a:avLst/>
@@ -9151,7 +10252,7 @@
         </p:nvSpPr>
         <p:spPr>
           <a:xfrm>
-            <a:off x="502920" y="6144768"/>
+            <a:off x="502920" y="6199632"/>
             <a:ext cx="1508760" cy="292608"/>
           </a:xfrm>
           <a:prstGeom prst="roundRect">
@@ -9196,7 +10297,7 @@
         </p:nvSpPr>
         <p:spPr>
           <a:xfrm>
-            <a:off x="502920" y="6163056"/>
+            <a:off x="502920" y="6217920"/>
             <a:ext cx="1508760" cy="256032"/>
           </a:xfrm>
           <a:prstGeom prst="rect">
@@ -9235,7 +10336,7 @@
         </p:nvSpPr>
         <p:spPr>
           <a:xfrm>
-            <a:off x="2121408" y="6144768"/>
+            <a:off x="2121408" y="6199632"/>
             <a:ext cx="1508760" cy="292608"/>
           </a:xfrm>
           <a:prstGeom prst="roundRect">
@@ -9280,7 +10381,7 @@
         </p:nvSpPr>
         <p:spPr>
           <a:xfrm>
-            <a:off x="2121408" y="6163056"/>
+            <a:off x="2121408" y="6217920"/>
             <a:ext cx="1508760" cy="256032"/>
           </a:xfrm>
           <a:prstGeom prst="rect">
@@ -9319,7 +10420,7 @@
         </p:nvSpPr>
         <p:spPr>
           <a:xfrm>
-            <a:off x="3739896" y="6144768"/>
+            <a:off x="3739896" y="6199632"/>
             <a:ext cx="1508760" cy="292608"/>
           </a:xfrm>
           <a:prstGeom prst="roundRect">
@@ -9364,7 +10465,7 @@
         </p:nvSpPr>
         <p:spPr>
           <a:xfrm>
-            <a:off x="3739896" y="6144768"/>
+            <a:off x="3739896" y="6199632"/>
             <a:ext cx="1508760" cy="45720"/>
           </a:xfrm>
           <a:prstGeom prst="rect">
@@ -9407,7 +10508,7 @@
         </p:nvSpPr>
         <p:spPr>
           <a:xfrm>
-            <a:off x="3739896" y="6163056"/>
+            <a:off x="3739896" y="6217920"/>
             <a:ext cx="1508760" cy="256032"/>
           </a:xfrm>
           <a:prstGeom prst="rect">
@@ -9446,7 +10547,7 @@
         </p:nvSpPr>
         <p:spPr>
           <a:xfrm>
-            <a:off x="5358384" y="6144768"/>
+            <a:off x="5358384" y="6199632"/>
             <a:ext cx="1508760" cy="292608"/>
           </a:xfrm>
           <a:prstGeom prst="roundRect">
@@ -9491,7 +10592,7 @@
         </p:nvSpPr>
         <p:spPr>
           <a:xfrm>
-            <a:off x="5358384" y="6163056"/>
+            <a:off x="5358384" y="6217920"/>
             <a:ext cx="1508760" cy="256032"/>
           </a:xfrm>
           <a:prstGeom prst="rect">
@@ -9530,7 +10631,7 @@
         </p:nvSpPr>
         <p:spPr>
           <a:xfrm>
-            <a:off x="6976872" y="6144768"/>
+            <a:off x="6976872" y="6199632"/>
             <a:ext cx="1508760" cy="292608"/>
           </a:xfrm>
           <a:prstGeom prst="roundRect">
@@ -9575,7 +10676,7 @@
         </p:nvSpPr>
         <p:spPr>
           <a:xfrm>
-            <a:off x="6976872" y="6163056"/>
+            <a:off x="6976872" y="6217920"/>
             <a:ext cx="1508760" cy="256032"/>
           </a:xfrm>
           <a:prstGeom prst="rect">
@@ -9614,7 +10715,7 @@
         </p:nvSpPr>
         <p:spPr>
           <a:xfrm>
-            <a:off x="8595360" y="6144768"/>
+            <a:off x="8595360" y="6199632"/>
             <a:ext cx="1508760" cy="292608"/>
           </a:xfrm>
           <a:prstGeom prst="roundRect">
@@ -9659,7 +10760,7 @@
         </p:nvSpPr>
         <p:spPr>
           <a:xfrm>
-            <a:off x="8595360" y="6163056"/>
+            <a:off x="8595360" y="6217920"/>
             <a:ext cx="1508760" cy="256032"/>
           </a:xfrm>
           <a:prstGeom prst="rect">
@@ -9698,7 +10799,7 @@
         </p:nvSpPr>
         <p:spPr>
           <a:xfrm>
-            <a:off x="10213848" y="6144768"/>
+            <a:off x="10213848" y="6199632"/>
             <a:ext cx="1508760" cy="292608"/>
           </a:xfrm>
           <a:prstGeom prst="roundRect">
@@ -9743,7 +10844,7 @@
         </p:nvSpPr>
         <p:spPr>
           <a:xfrm>
-            <a:off x="10213848" y="6163056"/>
+            <a:off x="10213848" y="6217920"/>
             <a:ext cx="1508760" cy="256032"/>
           </a:xfrm>
           <a:prstGeom prst="rect">
@@ -9848,6 +10949,294 @@
                 <a:latin typeface="Calibri"/>
               </a:rPr>
               <a:t>4 / 8</a:t>
+            </a:r>
+          </a:p>
+        </p:txBody>
+      </p:sp>
+      <p:sp>
+        <p:nvSpPr>
+          <p:cNvPr id="33" name="Rounded Rectangle 32"/>
+          <p:cNvSpPr/>
+          <p:nvPr/>
+        </p:nvSpPr>
+        <p:spPr>
+          <a:xfrm>
+            <a:off x="9646920" y="164592"/>
+            <a:ext cx="2331720" cy="868680"/>
+          </a:xfrm>
+          <a:prstGeom prst="roundRect">
+            <a:avLst>
+              <a:gd name="adj" fmla="val 12000"/>
+            </a:avLst>
+          </a:prstGeom>
+          <a:solidFill>
+            <a:srgbClr val="1A2332"/>
+          </a:solidFill>
+          <a:ln>
+            <a:noFill/>
+          </a:ln>
+        </p:spPr>
+        <p:style>
+          <a:lnRef idx="1">
+            <a:schemeClr val="accent1"/>
+          </a:lnRef>
+          <a:fillRef idx="3">
+            <a:schemeClr val="accent1"/>
+          </a:fillRef>
+          <a:effectRef idx="2">
+            <a:schemeClr val="accent1"/>
+          </a:effectRef>
+          <a:fontRef idx="minor">
+            <a:schemeClr val="lt1"/>
+          </a:fontRef>
+        </p:style>
+        <p:txBody>
+          <a:bodyPr rtlCol="0" anchor="ctr"/>
+          <a:lstStyle/>
+          <a:p>
+            <a:pPr algn="ctr"/>
+          </a:p>
+        </p:txBody>
+      </p:sp>
+      <p:sp>
+        <p:nvSpPr>
+          <p:cNvPr id="34" name="Rectangle 33"/>
+          <p:cNvSpPr/>
+          <p:nvPr/>
+        </p:nvSpPr>
+        <p:spPr>
+          <a:xfrm>
+            <a:off x="9646920" y="164592"/>
+            <a:ext cx="73152" cy="868680"/>
+          </a:xfrm>
+          <a:prstGeom prst="rect">
+            <a:avLst/>
+          </a:prstGeom>
+          <a:solidFill>
+            <a:srgbClr val="D4A853"/>
+          </a:solidFill>
+          <a:ln>
+            <a:noFill/>
+          </a:ln>
+        </p:spPr>
+        <p:style>
+          <a:lnRef idx="1">
+            <a:schemeClr val="accent1"/>
+          </a:lnRef>
+          <a:fillRef idx="3">
+            <a:schemeClr val="accent1"/>
+          </a:fillRef>
+          <a:effectRef idx="2">
+            <a:schemeClr val="accent1"/>
+          </a:effectRef>
+          <a:fontRef idx="minor">
+            <a:schemeClr val="lt1"/>
+          </a:fontRef>
+        </p:style>
+        <p:txBody>
+          <a:bodyPr rtlCol="0" anchor="ctr"/>
+          <a:lstStyle/>
+          <a:p>
+            <a:pPr algn="ctr"/>
+          </a:p>
+        </p:txBody>
+      </p:sp>
+      <p:sp>
+        <p:nvSpPr>
+          <p:cNvPr id="35" name="TextBox 34"/>
+          <p:cNvSpPr txBox="1"/>
+          <p:nvPr/>
+        </p:nvSpPr>
+        <p:spPr>
+          <a:xfrm>
+            <a:off x="9811512" y="219456"/>
+            <a:ext cx="2075688" cy="777240"/>
+          </a:xfrm>
+          <a:prstGeom prst="rect">
+            <a:avLst/>
+          </a:prstGeom>
+          <a:noFill/>
+        </p:spPr>
+        <p:txBody>
+          <a:bodyPr wrap="square">
+            <a:spAutoFit/>
+          </a:bodyPr>
+          <a:lstStyle/>
+          <a:p>
+            <a:pPr algn="l">
+              <a:spcAft>
+                <a:spcPts val="0"/>
+              </a:spcAft>
+            </a:pPr>
+            <a:r>
+              <a:rPr sz="900" b="1">
+                <a:solidFill>
+                  <a:srgbClr val="8B9CB3"/>
+                </a:solidFill>
+                <a:latin typeface="Calibri"/>
+              </a:rPr>
+              <a:t>SLIDE BUDGET</a:t>
+            </a:r>
+          </a:p>
+          <a:p>
+            <a:pPr algn="l">
+              <a:spcAft>
+                <a:spcPts val="0"/>
+              </a:spcAft>
+            </a:pPr>
+            <a:r>
+              <a:rPr sz="2600" b="1">
+                <a:solidFill>
+                  <a:srgbClr val="D4A853"/>
+                </a:solidFill>
+                <a:latin typeface="Calibri"/>
+              </a:rPr>
+              <a:t>1:15</a:t>
+            </a:r>
+          </a:p>
+          <a:p>
+            <a:pPr algn="l">
+              <a:spcAft>
+                <a:spcPts val="0"/>
+              </a:spcAft>
+            </a:pPr>
+            <a:r>
+              <a:rPr sz="900" b="0">
+                <a:solidFill>
+                  <a:srgbClr val="8B9CB3"/>
+                </a:solidFill>
+                <a:latin typeface="Calibri"/>
+              </a:rPr>
+              <a:t>by end 5:10 · left 4:50</a:t>
+            </a:r>
+          </a:p>
+        </p:txBody>
+      </p:sp>
+      <p:sp>
+        <p:nvSpPr>
+          <p:cNvPr id="36" name="Rounded Rectangle 35"/>
+          <p:cNvSpPr/>
+          <p:nvPr/>
+        </p:nvSpPr>
+        <p:spPr>
+          <a:xfrm>
+            <a:off x="502920" y="5961888"/>
+            <a:ext cx="11155680" cy="109728"/>
+          </a:xfrm>
+          <a:prstGeom prst="roundRect">
+            <a:avLst>
+              <a:gd name="adj" fmla="val 50000"/>
+            </a:avLst>
+          </a:prstGeom>
+          <a:solidFill>
+            <a:srgbClr val="243044"/>
+          </a:solidFill>
+          <a:ln>
+            <a:noFill/>
+          </a:ln>
+        </p:spPr>
+        <p:style>
+          <a:lnRef idx="1">
+            <a:schemeClr val="accent1"/>
+          </a:lnRef>
+          <a:fillRef idx="3">
+            <a:schemeClr val="accent1"/>
+          </a:fillRef>
+          <a:effectRef idx="2">
+            <a:schemeClr val="accent1"/>
+          </a:effectRef>
+          <a:fontRef idx="minor">
+            <a:schemeClr val="lt1"/>
+          </a:fontRef>
+        </p:style>
+        <p:txBody>
+          <a:bodyPr rtlCol="0" anchor="ctr"/>
+          <a:lstStyle/>
+          <a:p>
+            <a:pPr algn="ctr"/>
+          </a:p>
+        </p:txBody>
+      </p:sp>
+      <p:sp>
+        <p:nvSpPr>
+          <p:cNvPr id="37" name="Rounded Rectangle 36"/>
+          <p:cNvSpPr/>
+          <p:nvPr/>
+        </p:nvSpPr>
+        <p:spPr>
+          <a:xfrm>
+            <a:off x="502920" y="5961888"/>
+            <a:ext cx="11155680" cy="109728"/>
+          </a:xfrm>
+          <a:prstGeom prst="roundRect">
+            <a:avLst>
+              <a:gd name="adj" fmla="val 50000"/>
+            </a:avLst>
+          </a:prstGeom>
+          <a:solidFill>
+            <a:srgbClr val="D4A853"/>
+          </a:solidFill>
+          <a:ln>
+            <a:noFill/>
+          </a:ln>
+        </p:spPr>
+        <p:style>
+          <a:lnRef idx="1">
+            <a:schemeClr val="accent1"/>
+          </a:lnRef>
+          <a:fillRef idx="3">
+            <a:schemeClr val="accent1"/>
+          </a:fillRef>
+          <a:effectRef idx="2">
+            <a:schemeClr val="accent1"/>
+          </a:effectRef>
+          <a:fontRef idx="minor">
+            <a:schemeClr val="lt1"/>
+          </a:fontRef>
+        </p:style>
+        <p:txBody>
+          <a:bodyPr rtlCol="0" anchor="ctr"/>
+          <a:lstStyle/>
+          <a:p>
+            <a:pPr algn="ctr"/>
+          </a:p>
+        </p:txBody>
+      </p:sp>
+      <p:sp>
+        <p:nvSpPr>
+          <p:cNvPr id="38" name="TextBox 37"/>
+          <p:cNvSpPr txBox="1"/>
+          <p:nvPr/>
+        </p:nvSpPr>
+        <p:spPr>
+          <a:xfrm>
+            <a:off x="502920" y="5760720"/>
+            <a:ext cx="5029200" cy="201168"/>
+          </a:xfrm>
+          <a:prstGeom prst="rect">
+            <a:avLst/>
+          </a:prstGeom>
+          <a:noFill/>
+        </p:spPr>
+        <p:txBody>
+          <a:bodyPr wrap="none">
+            <a:spAutoFit/>
+          </a:bodyPr>
+          <a:lstStyle/>
+          <a:p>
+            <a:pPr algn="l">
+              <a:spcAft>
+                <a:spcPts val="0"/>
+              </a:spcAft>
+            </a:pPr>
+            <a:r>
+              <a:rPr sz="800" b="0">
+                <a:solidFill>
+                  <a:srgbClr val="8B9CB3"/>
+                </a:solidFill>
+                <a:latin typeface="Calibri"/>
+              </a:rPr>
+              <a:t>Countdown bar starts in Slideshow · does not auto-advance — you click when ready</a:t>
             </a:r>
           </a:p>
         </p:txBody>
@@ -9857,6 +11246,62 @@
   <p:clrMapOvr>
     <a:masterClrMapping/>
   </p:clrMapOvr>
+  <p:timing>
+    <p:tnLst>
+      <p:par>
+        <p:cTn id="1" dur="indefinite" restart="never" nodeType="tmRoot">
+          <p:childTnLst>
+            <p:seq concurrent="1" nextAc="seek">
+              <p:cTn id="2" dur="indefinite" nodeType="mainSeq">
+                <p:childTnLst>
+                  <p:par>
+                    <p:cTn id="3" fill="hold">
+                      <p:stCondLst>
+                        <p:cond delay="0"/>
+                      </p:stCondLst>
+                      <p:childTnLst>
+                        <p:par>
+                          <p:cTn id="4" fill="hold">
+                            <p:stCondLst>
+                              <p:cond delay="0"/>
+                            </p:stCondLst>
+                            <p:childTnLst>
+                              <p:animEffect transition="out" filter="wipe(left)">
+                                <p:cBhvr>
+                                  <p:cTn id="5" dur="75000" fill="hold"/>
+                                  <p:tgtEl>
+                                    <p:spTgt spid="37"/>
+                                  </p:tgtEl>
+                                </p:cBhvr>
+                              </p:animEffect>
+                            </p:childTnLst>
+                          </p:cTn>
+                        </p:par>
+                      </p:childTnLst>
+                    </p:cTn>
+                  </p:par>
+                </p:childTnLst>
+              </p:cTn>
+              <p:prevCondLst>
+                <p:cond evt="onPrev" delay="0">
+                  <p:tgtEl>
+                    <p:sldTgt/>
+                  </p:tgtEl>
+                </p:cond>
+              </p:prevCondLst>
+              <p:nextCondLst>
+                <p:cond evt="onNext" delay="0">
+                  <p:tgtEl>
+                    <p:sldTgt/>
+                  </p:tgtEl>
+                </p:cond>
+              </p:nextCondLst>
+            </p:seq>
+          </p:childTnLst>
+        </p:cTn>
+      </p:par>
+    </p:tnLst>
+  </p:timing>
 </p:sld>
 </file>
 
@@ -9961,7 +11406,7 @@
         <p:spPr>
           <a:xfrm>
             <a:off x="502920" y="438912"/>
-            <a:ext cx="11155680" cy="594360"/>
+            <a:ext cx="8869680" cy="594360"/>
           </a:xfrm>
           <a:prstGeom prst="rect">
             <a:avLst/>
@@ -10847,7 +12292,7 @@
         </p:nvSpPr>
         <p:spPr>
           <a:xfrm>
-            <a:off x="502920" y="6144768"/>
+            <a:off x="502920" y="6199632"/>
             <a:ext cx="1508760" cy="292608"/>
           </a:xfrm>
           <a:prstGeom prst="roundRect">
@@ -10892,7 +12337,7 @@
         </p:nvSpPr>
         <p:spPr>
           <a:xfrm>
-            <a:off x="502920" y="6163056"/>
+            <a:off x="502920" y="6217920"/>
             <a:ext cx="1508760" cy="256032"/>
           </a:xfrm>
           <a:prstGeom prst="rect">
@@ -10931,7 +12376,7 @@
         </p:nvSpPr>
         <p:spPr>
           <a:xfrm>
-            <a:off x="2121408" y="6144768"/>
+            <a:off x="2121408" y="6199632"/>
             <a:ext cx="1508760" cy="292608"/>
           </a:xfrm>
           <a:prstGeom prst="roundRect">
@@ -10976,7 +12421,7 @@
         </p:nvSpPr>
         <p:spPr>
           <a:xfrm>
-            <a:off x="2121408" y="6163056"/>
+            <a:off x="2121408" y="6217920"/>
             <a:ext cx="1508760" cy="256032"/>
           </a:xfrm>
           <a:prstGeom prst="rect">
@@ -11015,7 +12460,7 @@
         </p:nvSpPr>
         <p:spPr>
           <a:xfrm>
-            <a:off x="3739896" y="6144768"/>
+            <a:off x="3739896" y="6199632"/>
             <a:ext cx="1508760" cy="292608"/>
           </a:xfrm>
           <a:prstGeom prst="roundRect">
@@ -11060,7 +12505,7 @@
         </p:nvSpPr>
         <p:spPr>
           <a:xfrm>
-            <a:off x="3739896" y="6163056"/>
+            <a:off x="3739896" y="6217920"/>
             <a:ext cx="1508760" cy="256032"/>
           </a:xfrm>
           <a:prstGeom prst="rect">
@@ -11099,7 +12544,7 @@
         </p:nvSpPr>
         <p:spPr>
           <a:xfrm>
-            <a:off x="5358384" y="6144768"/>
+            <a:off x="5358384" y="6199632"/>
             <a:ext cx="1508760" cy="292608"/>
           </a:xfrm>
           <a:prstGeom prst="roundRect">
@@ -11144,7 +12589,7 @@
         </p:nvSpPr>
         <p:spPr>
           <a:xfrm>
-            <a:off x="5358384" y="6144768"/>
+            <a:off x="5358384" y="6199632"/>
             <a:ext cx="1508760" cy="45720"/>
           </a:xfrm>
           <a:prstGeom prst="rect">
@@ -11187,7 +12632,7 @@
         </p:nvSpPr>
         <p:spPr>
           <a:xfrm>
-            <a:off x="5358384" y="6163056"/>
+            <a:off x="5358384" y="6217920"/>
             <a:ext cx="1508760" cy="256032"/>
           </a:xfrm>
           <a:prstGeom prst="rect">
@@ -11226,7 +12671,7 @@
         </p:nvSpPr>
         <p:spPr>
           <a:xfrm>
-            <a:off x="6976872" y="6144768"/>
+            <a:off x="6976872" y="6199632"/>
             <a:ext cx="1508760" cy="292608"/>
           </a:xfrm>
           <a:prstGeom prst="roundRect">
@@ -11271,7 +12716,7 @@
         </p:nvSpPr>
         <p:spPr>
           <a:xfrm>
-            <a:off x="6976872" y="6163056"/>
+            <a:off x="6976872" y="6217920"/>
             <a:ext cx="1508760" cy="256032"/>
           </a:xfrm>
           <a:prstGeom prst="rect">
@@ -11310,7 +12755,7 @@
         </p:nvSpPr>
         <p:spPr>
           <a:xfrm>
-            <a:off x="8595360" y="6144768"/>
+            <a:off x="8595360" y="6199632"/>
             <a:ext cx="1508760" cy="292608"/>
           </a:xfrm>
           <a:prstGeom prst="roundRect">
@@ -11355,7 +12800,7 @@
         </p:nvSpPr>
         <p:spPr>
           <a:xfrm>
-            <a:off x="8595360" y="6163056"/>
+            <a:off x="8595360" y="6217920"/>
             <a:ext cx="1508760" cy="256032"/>
           </a:xfrm>
           <a:prstGeom prst="rect">
@@ -11394,7 +12839,7 @@
         </p:nvSpPr>
         <p:spPr>
           <a:xfrm>
-            <a:off x="10213848" y="6144768"/>
+            <a:off x="10213848" y="6199632"/>
             <a:ext cx="1508760" cy="292608"/>
           </a:xfrm>
           <a:prstGeom prst="roundRect">
@@ -11439,7 +12884,7 @@
         </p:nvSpPr>
         <p:spPr>
           <a:xfrm>
-            <a:off x="10213848" y="6163056"/>
+            <a:off x="10213848" y="6217920"/>
             <a:ext cx="1508760" cy="256032"/>
           </a:xfrm>
           <a:prstGeom prst="rect">
@@ -11544,6 +12989,294 @@
                 <a:latin typeface="Calibri"/>
               </a:rPr>
               <a:t>5 / 8</a:t>
+            </a:r>
+          </a:p>
+        </p:txBody>
+      </p:sp>
+      <p:sp>
+        <p:nvSpPr>
+          <p:cNvPr id="36" name="Rounded Rectangle 35"/>
+          <p:cNvSpPr/>
+          <p:nvPr/>
+        </p:nvSpPr>
+        <p:spPr>
+          <a:xfrm>
+            <a:off x="9646920" y="164592"/>
+            <a:ext cx="2331720" cy="868680"/>
+          </a:xfrm>
+          <a:prstGeom prst="roundRect">
+            <a:avLst>
+              <a:gd name="adj" fmla="val 12000"/>
+            </a:avLst>
+          </a:prstGeom>
+          <a:solidFill>
+            <a:srgbClr val="1A2332"/>
+          </a:solidFill>
+          <a:ln>
+            <a:noFill/>
+          </a:ln>
+        </p:spPr>
+        <p:style>
+          <a:lnRef idx="1">
+            <a:schemeClr val="accent1"/>
+          </a:lnRef>
+          <a:fillRef idx="3">
+            <a:schemeClr val="accent1"/>
+          </a:fillRef>
+          <a:effectRef idx="2">
+            <a:schemeClr val="accent1"/>
+          </a:effectRef>
+          <a:fontRef idx="minor">
+            <a:schemeClr val="lt1"/>
+          </a:fontRef>
+        </p:style>
+        <p:txBody>
+          <a:bodyPr rtlCol="0" anchor="ctr"/>
+          <a:lstStyle/>
+          <a:p>
+            <a:pPr algn="ctr"/>
+          </a:p>
+        </p:txBody>
+      </p:sp>
+      <p:sp>
+        <p:nvSpPr>
+          <p:cNvPr id="37" name="Rectangle 36"/>
+          <p:cNvSpPr/>
+          <p:nvPr/>
+        </p:nvSpPr>
+        <p:spPr>
+          <a:xfrm>
+            <a:off x="9646920" y="164592"/>
+            <a:ext cx="73152" cy="868680"/>
+          </a:xfrm>
+          <a:prstGeom prst="rect">
+            <a:avLst/>
+          </a:prstGeom>
+          <a:solidFill>
+            <a:srgbClr val="D4A853"/>
+          </a:solidFill>
+          <a:ln>
+            <a:noFill/>
+          </a:ln>
+        </p:spPr>
+        <p:style>
+          <a:lnRef idx="1">
+            <a:schemeClr val="accent1"/>
+          </a:lnRef>
+          <a:fillRef idx="3">
+            <a:schemeClr val="accent1"/>
+          </a:fillRef>
+          <a:effectRef idx="2">
+            <a:schemeClr val="accent1"/>
+          </a:effectRef>
+          <a:fontRef idx="minor">
+            <a:schemeClr val="lt1"/>
+          </a:fontRef>
+        </p:style>
+        <p:txBody>
+          <a:bodyPr rtlCol="0" anchor="ctr"/>
+          <a:lstStyle/>
+          <a:p>
+            <a:pPr algn="ctr"/>
+          </a:p>
+        </p:txBody>
+      </p:sp>
+      <p:sp>
+        <p:nvSpPr>
+          <p:cNvPr id="38" name="TextBox 37"/>
+          <p:cNvSpPr txBox="1"/>
+          <p:nvPr/>
+        </p:nvSpPr>
+        <p:spPr>
+          <a:xfrm>
+            <a:off x="9811512" y="219456"/>
+            <a:ext cx="2075688" cy="777240"/>
+          </a:xfrm>
+          <a:prstGeom prst="rect">
+            <a:avLst/>
+          </a:prstGeom>
+          <a:noFill/>
+        </p:spPr>
+        <p:txBody>
+          <a:bodyPr wrap="square">
+            <a:spAutoFit/>
+          </a:bodyPr>
+          <a:lstStyle/>
+          <a:p>
+            <a:pPr algn="l">
+              <a:spcAft>
+                <a:spcPts val="0"/>
+              </a:spcAft>
+            </a:pPr>
+            <a:r>
+              <a:rPr sz="900" b="1">
+                <a:solidFill>
+                  <a:srgbClr val="8B9CB3"/>
+                </a:solidFill>
+                <a:latin typeface="Calibri"/>
+              </a:rPr>
+              <a:t>SLIDE BUDGET</a:t>
+            </a:r>
+          </a:p>
+          <a:p>
+            <a:pPr algn="l">
+              <a:spcAft>
+                <a:spcPts val="0"/>
+              </a:spcAft>
+            </a:pPr>
+            <a:r>
+              <a:rPr sz="2600" b="1">
+                <a:solidFill>
+                  <a:srgbClr val="D4A853"/>
+                </a:solidFill>
+                <a:latin typeface="Calibri"/>
+              </a:rPr>
+              <a:t>1:25</a:t>
+            </a:r>
+          </a:p>
+          <a:p>
+            <a:pPr algn="l">
+              <a:spcAft>
+                <a:spcPts val="0"/>
+              </a:spcAft>
+            </a:pPr>
+            <a:r>
+              <a:rPr sz="900" b="0">
+                <a:solidFill>
+                  <a:srgbClr val="8B9CB3"/>
+                </a:solidFill>
+                <a:latin typeface="Calibri"/>
+              </a:rPr>
+              <a:t>by end 6:35 · left 3:25</a:t>
+            </a:r>
+          </a:p>
+        </p:txBody>
+      </p:sp>
+      <p:sp>
+        <p:nvSpPr>
+          <p:cNvPr id="39" name="Rounded Rectangle 38"/>
+          <p:cNvSpPr/>
+          <p:nvPr/>
+        </p:nvSpPr>
+        <p:spPr>
+          <a:xfrm>
+            <a:off x="502920" y="5961888"/>
+            <a:ext cx="11155680" cy="109728"/>
+          </a:xfrm>
+          <a:prstGeom prst="roundRect">
+            <a:avLst>
+              <a:gd name="adj" fmla="val 50000"/>
+            </a:avLst>
+          </a:prstGeom>
+          <a:solidFill>
+            <a:srgbClr val="243044"/>
+          </a:solidFill>
+          <a:ln>
+            <a:noFill/>
+          </a:ln>
+        </p:spPr>
+        <p:style>
+          <a:lnRef idx="1">
+            <a:schemeClr val="accent1"/>
+          </a:lnRef>
+          <a:fillRef idx="3">
+            <a:schemeClr val="accent1"/>
+          </a:fillRef>
+          <a:effectRef idx="2">
+            <a:schemeClr val="accent1"/>
+          </a:effectRef>
+          <a:fontRef idx="minor">
+            <a:schemeClr val="lt1"/>
+          </a:fontRef>
+        </p:style>
+        <p:txBody>
+          <a:bodyPr rtlCol="0" anchor="ctr"/>
+          <a:lstStyle/>
+          <a:p>
+            <a:pPr algn="ctr"/>
+          </a:p>
+        </p:txBody>
+      </p:sp>
+      <p:sp>
+        <p:nvSpPr>
+          <p:cNvPr id="40" name="Rounded Rectangle 39"/>
+          <p:cNvSpPr/>
+          <p:nvPr/>
+        </p:nvSpPr>
+        <p:spPr>
+          <a:xfrm>
+            <a:off x="502920" y="5961888"/>
+            <a:ext cx="11155680" cy="109728"/>
+          </a:xfrm>
+          <a:prstGeom prst="roundRect">
+            <a:avLst>
+              <a:gd name="adj" fmla="val 50000"/>
+            </a:avLst>
+          </a:prstGeom>
+          <a:solidFill>
+            <a:srgbClr val="D4A853"/>
+          </a:solidFill>
+          <a:ln>
+            <a:noFill/>
+          </a:ln>
+        </p:spPr>
+        <p:style>
+          <a:lnRef idx="1">
+            <a:schemeClr val="accent1"/>
+          </a:lnRef>
+          <a:fillRef idx="3">
+            <a:schemeClr val="accent1"/>
+          </a:fillRef>
+          <a:effectRef idx="2">
+            <a:schemeClr val="accent1"/>
+          </a:effectRef>
+          <a:fontRef idx="minor">
+            <a:schemeClr val="lt1"/>
+          </a:fontRef>
+        </p:style>
+        <p:txBody>
+          <a:bodyPr rtlCol="0" anchor="ctr"/>
+          <a:lstStyle/>
+          <a:p>
+            <a:pPr algn="ctr"/>
+          </a:p>
+        </p:txBody>
+      </p:sp>
+      <p:sp>
+        <p:nvSpPr>
+          <p:cNvPr id="41" name="TextBox 40"/>
+          <p:cNvSpPr txBox="1"/>
+          <p:nvPr/>
+        </p:nvSpPr>
+        <p:spPr>
+          <a:xfrm>
+            <a:off x="502920" y="5760720"/>
+            <a:ext cx="5029200" cy="201168"/>
+          </a:xfrm>
+          <a:prstGeom prst="rect">
+            <a:avLst/>
+          </a:prstGeom>
+          <a:noFill/>
+        </p:spPr>
+        <p:txBody>
+          <a:bodyPr wrap="none">
+            <a:spAutoFit/>
+          </a:bodyPr>
+          <a:lstStyle/>
+          <a:p>
+            <a:pPr algn="l">
+              <a:spcAft>
+                <a:spcPts val="0"/>
+              </a:spcAft>
+            </a:pPr>
+            <a:r>
+              <a:rPr sz="800" b="0">
+                <a:solidFill>
+                  <a:srgbClr val="8B9CB3"/>
+                </a:solidFill>
+                <a:latin typeface="Calibri"/>
+              </a:rPr>
+              <a:t>Countdown bar starts in Slideshow · does not auto-advance — you click when ready</a:t>
             </a:r>
           </a:p>
         </p:txBody>
@@ -11553,6 +13286,62 @@
   <p:clrMapOvr>
     <a:masterClrMapping/>
   </p:clrMapOvr>
+  <p:timing>
+    <p:tnLst>
+      <p:par>
+        <p:cTn id="1" dur="indefinite" restart="never" nodeType="tmRoot">
+          <p:childTnLst>
+            <p:seq concurrent="1" nextAc="seek">
+              <p:cTn id="2" dur="indefinite" nodeType="mainSeq">
+                <p:childTnLst>
+                  <p:par>
+                    <p:cTn id="3" fill="hold">
+                      <p:stCondLst>
+                        <p:cond delay="0"/>
+                      </p:stCondLst>
+                      <p:childTnLst>
+                        <p:par>
+                          <p:cTn id="4" fill="hold">
+                            <p:stCondLst>
+                              <p:cond delay="0"/>
+                            </p:stCondLst>
+                            <p:childTnLst>
+                              <p:animEffect transition="out" filter="wipe(left)">
+                                <p:cBhvr>
+                                  <p:cTn id="5" dur="85000" fill="hold"/>
+                                  <p:tgtEl>
+                                    <p:spTgt spid="40"/>
+                                  </p:tgtEl>
+                                </p:cBhvr>
+                              </p:animEffect>
+                            </p:childTnLst>
+                          </p:cTn>
+                        </p:par>
+                      </p:childTnLst>
+                    </p:cTn>
+                  </p:par>
+                </p:childTnLst>
+              </p:cTn>
+              <p:prevCondLst>
+                <p:cond evt="onPrev" delay="0">
+                  <p:tgtEl>
+                    <p:sldTgt/>
+                  </p:tgtEl>
+                </p:cond>
+              </p:prevCondLst>
+              <p:nextCondLst>
+                <p:cond evt="onNext" delay="0">
+                  <p:tgtEl>
+                    <p:sldTgt/>
+                  </p:tgtEl>
+                </p:cond>
+              </p:nextCondLst>
+            </p:seq>
+          </p:childTnLst>
+        </p:cTn>
+      </p:par>
+    </p:tnLst>
+  </p:timing>
 </p:sld>
 </file>
 
@@ -11657,7 +13446,7 @@
         <p:spPr>
           <a:xfrm>
             <a:off x="502920" y="438912"/>
-            <a:ext cx="11155680" cy="594360"/>
+            <a:ext cx="8869680" cy="594360"/>
           </a:xfrm>
           <a:prstGeom prst="rect">
             <a:avLst/>
@@ -12394,7 +14183,7 @@
         </p:nvSpPr>
         <p:spPr>
           <a:xfrm>
-            <a:off x="502920" y="6144768"/>
+            <a:off x="502920" y="6199632"/>
             <a:ext cx="1508760" cy="292608"/>
           </a:xfrm>
           <a:prstGeom prst="roundRect">
@@ -12439,7 +14228,7 @@
         </p:nvSpPr>
         <p:spPr>
           <a:xfrm>
-            <a:off x="502920" y="6163056"/>
+            <a:off x="502920" y="6217920"/>
             <a:ext cx="1508760" cy="256032"/>
           </a:xfrm>
           <a:prstGeom prst="rect">
@@ -12478,7 +14267,7 @@
         </p:nvSpPr>
         <p:spPr>
           <a:xfrm>
-            <a:off x="2121408" y="6144768"/>
+            <a:off x="2121408" y="6199632"/>
             <a:ext cx="1508760" cy="292608"/>
           </a:xfrm>
           <a:prstGeom prst="roundRect">
@@ -12523,7 +14312,7 @@
         </p:nvSpPr>
         <p:spPr>
           <a:xfrm>
-            <a:off x="2121408" y="6163056"/>
+            <a:off x="2121408" y="6217920"/>
             <a:ext cx="1508760" cy="256032"/>
           </a:xfrm>
           <a:prstGeom prst="rect">
@@ -12562,7 +14351,7 @@
         </p:nvSpPr>
         <p:spPr>
           <a:xfrm>
-            <a:off x="3739896" y="6144768"/>
+            <a:off x="3739896" y="6199632"/>
             <a:ext cx="1508760" cy="292608"/>
           </a:xfrm>
           <a:prstGeom prst="roundRect">
@@ -12607,7 +14396,7 @@
         </p:nvSpPr>
         <p:spPr>
           <a:xfrm>
-            <a:off x="3739896" y="6163056"/>
+            <a:off x="3739896" y="6217920"/>
             <a:ext cx="1508760" cy="256032"/>
           </a:xfrm>
           <a:prstGeom prst="rect">
@@ -12646,7 +14435,7 @@
         </p:nvSpPr>
         <p:spPr>
           <a:xfrm>
-            <a:off x="5358384" y="6144768"/>
+            <a:off x="5358384" y="6199632"/>
             <a:ext cx="1508760" cy="292608"/>
           </a:xfrm>
           <a:prstGeom prst="roundRect">
@@ -12691,7 +14480,7 @@
         </p:nvSpPr>
         <p:spPr>
           <a:xfrm>
-            <a:off x="5358384" y="6163056"/>
+            <a:off x="5358384" y="6217920"/>
             <a:ext cx="1508760" cy="256032"/>
           </a:xfrm>
           <a:prstGeom prst="rect">
@@ -12730,7 +14519,7 @@
         </p:nvSpPr>
         <p:spPr>
           <a:xfrm>
-            <a:off x="6976872" y="6144768"/>
+            <a:off x="6976872" y="6199632"/>
             <a:ext cx="1508760" cy="292608"/>
           </a:xfrm>
           <a:prstGeom prst="roundRect">
@@ -12775,7 +14564,7 @@
         </p:nvSpPr>
         <p:spPr>
           <a:xfrm>
-            <a:off x="6976872" y="6144768"/>
+            <a:off x="6976872" y="6199632"/>
             <a:ext cx="1508760" cy="45720"/>
           </a:xfrm>
           <a:prstGeom prst="rect">
@@ -12818,7 +14607,7 @@
         </p:nvSpPr>
         <p:spPr>
           <a:xfrm>
-            <a:off x="6976872" y="6163056"/>
+            <a:off x="6976872" y="6217920"/>
             <a:ext cx="1508760" cy="256032"/>
           </a:xfrm>
           <a:prstGeom prst="rect">
@@ -12857,7 +14646,7 @@
         </p:nvSpPr>
         <p:spPr>
           <a:xfrm>
-            <a:off x="8595360" y="6144768"/>
+            <a:off x="8595360" y="6199632"/>
             <a:ext cx="1508760" cy="292608"/>
           </a:xfrm>
           <a:prstGeom prst="roundRect">
@@ -12902,7 +14691,7 @@
         </p:nvSpPr>
         <p:spPr>
           <a:xfrm>
-            <a:off x="8595360" y="6163056"/>
+            <a:off x="8595360" y="6217920"/>
             <a:ext cx="1508760" cy="256032"/>
           </a:xfrm>
           <a:prstGeom prst="rect">
@@ -12941,7 +14730,7 @@
         </p:nvSpPr>
         <p:spPr>
           <a:xfrm>
-            <a:off x="10213848" y="6144768"/>
+            <a:off x="10213848" y="6199632"/>
             <a:ext cx="1508760" cy="292608"/>
           </a:xfrm>
           <a:prstGeom prst="roundRect">
@@ -12986,7 +14775,7 @@
         </p:nvSpPr>
         <p:spPr>
           <a:xfrm>
-            <a:off x="10213848" y="6163056"/>
+            <a:off x="10213848" y="6217920"/>
             <a:ext cx="1508760" cy="256032"/>
           </a:xfrm>
           <a:prstGeom prst="rect">
@@ -13091,6 +14880,294 @@
                 <a:latin typeface="Calibri"/>
               </a:rPr>
               <a:t>6 / 8</a:t>
+            </a:r>
+          </a:p>
+        </p:txBody>
+      </p:sp>
+      <p:sp>
+        <p:nvSpPr>
+          <p:cNvPr id="31" name="Rounded Rectangle 30"/>
+          <p:cNvSpPr/>
+          <p:nvPr/>
+        </p:nvSpPr>
+        <p:spPr>
+          <a:xfrm>
+            <a:off x="9646920" y="164592"/>
+            <a:ext cx="2331720" cy="868680"/>
+          </a:xfrm>
+          <a:prstGeom prst="roundRect">
+            <a:avLst>
+              <a:gd name="adj" fmla="val 12000"/>
+            </a:avLst>
+          </a:prstGeom>
+          <a:solidFill>
+            <a:srgbClr val="1A2332"/>
+          </a:solidFill>
+          <a:ln>
+            <a:noFill/>
+          </a:ln>
+        </p:spPr>
+        <p:style>
+          <a:lnRef idx="1">
+            <a:schemeClr val="accent1"/>
+          </a:lnRef>
+          <a:fillRef idx="3">
+            <a:schemeClr val="accent1"/>
+          </a:fillRef>
+          <a:effectRef idx="2">
+            <a:schemeClr val="accent1"/>
+          </a:effectRef>
+          <a:fontRef idx="minor">
+            <a:schemeClr val="lt1"/>
+          </a:fontRef>
+        </p:style>
+        <p:txBody>
+          <a:bodyPr rtlCol="0" anchor="ctr"/>
+          <a:lstStyle/>
+          <a:p>
+            <a:pPr algn="ctr"/>
+          </a:p>
+        </p:txBody>
+      </p:sp>
+      <p:sp>
+        <p:nvSpPr>
+          <p:cNvPr id="32" name="Rectangle 31"/>
+          <p:cNvSpPr/>
+          <p:nvPr/>
+        </p:nvSpPr>
+        <p:spPr>
+          <a:xfrm>
+            <a:off x="9646920" y="164592"/>
+            <a:ext cx="73152" cy="868680"/>
+          </a:xfrm>
+          <a:prstGeom prst="rect">
+            <a:avLst/>
+          </a:prstGeom>
+          <a:solidFill>
+            <a:srgbClr val="D4A853"/>
+          </a:solidFill>
+          <a:ln>
+            <a:noFill/>
+          </a:ln>
+        </p:spPr>
+        <p:style>
+          <a:lnRef idx="1">
+            <a:schemeClr val="accent1"/>
+          </a:lnRef>
+          <a:fillRef idx="3">
+            <a:schemeClr val="accent1"/>
+          </a:fillRef>
+          <a:effectRef idx="2">
+            <a:schemeClr val="accent1"/>
+          </a:effectRef>
+          <a:fontRef idx="minor">
+            <a:schemeClr val="lt1"/>
+          </a:fontRef>
+        </p:style>
+        <p:txBody>
+          <a:bodyPr rtlCol="0" anchor="ctr"/>
+          <a:lstStyle/>
+          <a:p>
+            <a:pPr algn="ctr"/>
+          </a:p>
+        </p:txBody>
+      </p:sp>
+      <p:sp>
+        <p:nvSpPr>
+          <p:cNvPr id="33" name="TextBox 32"/>
+          <p:cNvSpPr txBox="1"/>
+          <p:nvPr/>
+        </p:nvSpPr>
+        <p:spPr>
+          <a:xfrm>
+            <a:off x="9811512" y="219456"/>
+            <a:ext cx="2075688" cy="777240"/>
+          </a:xfrm>
+          <a:prstGeom prst="rect">
+            <a:avLst/>
+          </a:prstGeom>
+          <a:noFill/>
+        </p:spPr>
+        <p:txBody>
+          <a:bodyPr wrap="square">
+            <a:spAutoFit/>
+          </a:bodyPr>
+          <a:lstStyle/>
+          <a:p>
+            <a:pPr algn="l">
+              <a:spcAft>
+                <a:spcPts val="0"/>
+              </a:spcAft>
+            </a:pPr>
+            <a:r>
+              <a:rPr sz="900" b="1">
+                <a:solidFill>
+                  <a:srgbClr val="8B9CB3"/>
+                </a:solidFill>
+                <a:latin typeface="Calibri"/>
+              </a:rPr>
+              <a:t>SLIDE BUDGET</a:t>
+            </a:r>
+          </a:p>
+          <a:p>
+            <a:pPr algn="l">
+              <a:spcAft>
+                <a:spcPts val="0"/>
+              </a:spcAft>
+            </a:pPr>
+            <a:r>
+              <a:rPr sz="2600" b="1">
+                <a:solidFill>
+                  <a:srgbClr val="D4A853"/>
+                </a:solidFill>
+                <a:latin typeface="Calibri"/>
+              </a:rPr>
+              <a:t>1:15</a:t>
+            </a:r>
+          </a:p>
+          <a:p>
+            <a:pPr algn="l">
+              <a:spcAft>
+                <a:spcPts val="0"/>
+              </a:spcAft>
+            </a:pPr>
+            <a:r>
+              <a:rPr sz="900" b="0">
+                <a:solidFill>
+                  <a:srgbClr val="8B9CB3"/>
+                </a:solidFill>
+                <a:latin typeface="Calibri"/>
+              </a:rPr>
+              <a:t>by end 7:50 · left 2:10</a:t>
+            </a:r>
+          </a:p>
+        </p:txBody>
+      </p:sp>
+      <p:sp>
+        <p:nvSpPr>
+          <p:cNvPr id="34" name="Rounded Rectangle 33"/>
+          <p:cNvSpPr/>
+          <p:nvPr/>
+        </p:nvSpPr>
+        <p:spPr>
+          <a:xfrm>
+            <a:off x="502920" y="5961888"/>
+            <a:ext cx="11155680" cy="109728"/>
+          </a:xfrm>
+          <a:prstGeom prst="roundRect">
+            <a:avLst>
+              <a:gd name="adj" fmla="val 50000"/>
+            </a:avLst>
+          </a:prstGeom>
+          <a:solidFill>
+            <a:srgbClr val="243044"/>
+          </a:solidFill>
+          <a:ln>
+            <a:noFill/>
+          </a:ln>
+        </p:spPr>
+        <p:style>
+          <a:lnRef idx="1">
+            <a:schemeClr val="accent1"/>
+          </a:lnRef>
+          <a:fillRef idx="3">
+            <a:schemeClr val="accent1"/>
+          </a:fillRef>
+          <a:effectRef idx="2">
+            <a:schemeClr val="accent1"/>
+          </a:effectRef>
+          <a:fontRef idx="minor">
+            <a:schemeClr val="lt1"/>
+          </a:fontRef>
+        </p:style>
+        <p:txBody>
+          <a:bodyPr rtlCol="0" anchor="ctr"/>
+          <a:lstStyle/>
+          <a:p>
+            <a:pPr algn="ctr"/>
+          </a:p>
+        </p:txBody>
+      </p:sp>
+      <p:sp>
+        <p:nvSpPr>
+          <p:cNvPr id="35" name="Rounded Rectangle 34"/>
+          <p:cNvSpPr/>
+          <p:nvPr/>
+        </p:nvSpPr>
+        <p:spPr>
+          <a:xfrm>
+            <a:off x="502920" y="5961888"/>
+            <a:ext cx="11155680" cy="109728"/>
+          </a:xfrm>
+          <a:prstGeom prst="roundRect">
+            <a:avLst>
+              <a:gd name="adj" fmla="val 50000"/>
+            </a:avLst>
+          </a:prstGeom>
+          <a:solidFill>
+            <a:srgbClr val="D4A853"/>
+          </a:solidFill>
+          <a:ln>
+            <a:noFill/>
+          </a:ln>
+        </p:spPr>
+        <p:style>
+          <a:lnRef idx="1">
+            <a:schemeClr val="accent1"/>
+          </a:lnRef>
+          <a:fillRef idx="3">
+            <a:schemeClr val="accent1"/>
+          </a:fillRef>
+          <a:effectRef idx="2">
+            <a:schemeClr val="accent1"/>
+          </a:effectRef>
+          <a:fontRef idx="minor">
+            <a:schemeClr val="lt1"/>
+          </a:fontRef>
+        </p:style>
+        <p:txBody>
+          <a:bodyPr rtlCol="0" anchor="ctr"/>
+          <a:lstStyle/>
+          <a:p>
+            <a:pPr algn="ctr"/>
+          </a:p>
+        </p:txBody>
+      </p:sp>
+      <p:sp>
+        <p:nvSpPr>
+          <p:cNvPr id="36" name="TextBox 35"/>
+          <p:cNvSpPr txBox="1"/>
+          <p:nvPr/>
+        </p:nvSpPr>
+        <p:spPr>
+          <a:xfrm>
+            <a:off x="502920" y="5760720"/>
+            <a:ext cx="5029200" cy="201168"/>
+          </a:xfrm>
+          <a:prstGeom prst="rect">
+            <a:avLst/>
+          </a:prstGeom>
+          <a:noFill/>
+        </p:spPr>
+        <p:txBody>
+          <a:bodyPr wrap="none">
+            <a:spAutoFit/>
+          </a:bodyPr>
+          <a:lstStyle/>
+          <a:p>
+            <a:pPr algn="l">
+              <a:spcAft>
+                <a:spcPts val="0"/>
+              </a:spcAft>
+            </a:pPr>
+            <a:r>
+              <a:rPr sz="800" b="0">
+                <a:solidFill>
+                  <a:srgbClr val="8B9CB3"/>
+                </a:solidFill>
+                <a:latin typeface="Calibri"/>
+              </a:rPr>
+              <a:t>Countdown bar starts in Slideshow · does not auto-advance — you click when ready</a:t>
             </a:r>
           </a:p>
         </p:txBody>
@@ -13100,6 +15177,62 @@
   <p:clrMapOvr>
     <a:masterClrMapping/>
   </p:clrMapOvr>
+  <p:timing>
+    <p:tnLst>
+      <p:par>
+        <p:cTn id="1" dur="indefinite" restart="never" nodeType="tmRoot">
+          <p:childTnLst>
+            <p:seq concurrent="1" nextAc="seek">
+              <p:cTn id="2" dur="indefinite" nodeType="mainSeq">
+                <p:childTnLst>
+                  <p:par>
+                    <p:cTn id="3" fill="hold">
+                      <p:stCondLst>
+                        <p:cond delay="0"/>
+                      </p:stCondLst>
+                      <p:childTnLst>
+                        <p:par>
+                          <p:cTn id="4" fill="hold">
+                            <p:stCondLst>
+                              <p:cond delay="0"/>
+                            </p:stCondLst>
+                            <p:childTnLst>
+                              <p:animEffect transition="out" filter="wipe(left)">
+                                <p:cBhvr>
+                                  <p:cTn id="5" dur="75000" fill="hold"/>
+                                  <p:tgtEl>
+                                    <p:spTgt spid="35"/>
+                                  </p:tgtEl>
+                                </p:cBhvr>
+                              </p:animEffect>
+                            </p:childTnLst>
+                          </p:cTn>
+                        </p:par>
+                      </p:childTnLst>
+                    </p:cTn>
+                  </p:par>
+                </p:childTnLst>
+              </p:cTn>
+              <p:prevCondLst>
+                <p:cond evt="onPrev" delay="0">
+                  <p:tgtEl>
+                    <p:sldTgt/>
+                  </p:tgtEl>
+                </p:cond>
+              </p:prevCondLst>
+              <p:nextCondLst>
+                <p:cond evt="onNext" delay="0">
+                  <p:tgtEl>
+                    <p:sldTgt/>
+                  </p:tgtEl>
+                </p:cond>
+              </p:nextCondLst>
+            </p:seq>
+          </p:childTnLst>
+        </p:cTn>
+      </p:par>
+    </p:tnLst>
+  </p:timing>
 </p:sld>
 </file>
 
@@ -13204,7 +15337,7 @@
         <p:spPr>
           <a:xfrm>
             <a:off x="502920" y="438912"/>
-            <a:ext cx="11155680" cy="594360"/>
+            <a:ext cx="8869680" cy="594360"/>
           </a:xfrm>
           <a:prstGeom prst="rect">
             <a:avLst/>
@@ -14137,7 +16270,7 @@
         </p:nvSpPr>
         <p:spPr>
           <a:xfrm>
-            <a:off x="502920" y="6144768"/>
+            <a:off x="502920" y="6199632"/>
             <a:ext cx="1508760" cy="292608"/>
           </a:xfrm>
           <a:prstGeom prst="roundRect">
@@ -14182,7 +16315,7 @@
         </p:nvSpPr>
         <p:spPr>
           <a:xfrm>
-            <a:off x="502920" y="6163056"/>
+            <a:off x="502920" y="6217920"/>
             <a:ext cx="1508760" cy="256032"/>
           </a:xfrm>
           <a:prstGeom prst="rect">
@@ -14221,7 +16354,7 @@
         </p:nvSpPr>
         <p:spPr>
           <a:xfrm>
-            <a:off x="2121408" y="6144768"/>
+            <a:off x="2121408" y="6199632"/>
             <a:ext cx="1508760" cy="292608"/>
           </a:xfrm>
           <a:prstGeom prst="roundRect">
@@ -14266,7 +16399,7 @@
         </p:nvSpPr>
         <p:spPr>
           <a:xfrm>
-            <a:off x="2121408" y="6163056"/>
+            <a:off x="2121408" y="6217920"/>
             <a:ext cx="1508760" cy="256032"/>
           </a:xfrm>
           <a:prstGeom prst="rect">
@@ -14305,7 +16438,7 @@
         </p:nvSpPr>
         <p:spPr>
           <a:xfrm>
-            <a:off x="3739896" y="6144768"/>
+            <a:off x="3739896" y="6199632"/>
             <a:ext cx="1508760" cy="292608"/>
           </a:xfrm>
           <a:prstGeom prst="roundRect">
@@ -14350,7 +16483,7 @@
         </p:nvSpPr>
         <p:spPr>
           <a:xfrm>
-            <a:off x="3739896" y="6163056"/>
+            <a:off x="3739896" y="6217920"/>
             <a:ext cx="1508760" cy="256032"/>
           </a:xfrm>
           <a:prstGeom prst="rect">
@@ -14389,7 +16522,7 @@
         </p:nvSpPr>
         <p:spPr>
           <a:xfrm>
-            <a:off x="5358384" y="6144768"/>
+            <a:off x="5358384" y="6199632"/>
             <a:ext cx="1508760" cy="292608"/>
           </a:xfrm>
           <a:prstGeom prst="roundRect">
@@ -14434,7 +16567,7 @@
         </p:nvSpPr>
         <p:spPr>
           <a:xfrm>
-            <a:off x="5358384" y="6163056"/>
+            <a:off x="5358384" y="6217920"/>
             <a:ext cx="1508760" cy="256032"/>
           </a:xfrm>
           <a:prstGeom prst="rect">
@@ -14473,7 +16606,7 @@
         </p:nvSpPr>
         <p:spPr>
           <a:xfrm>
-            <a:off x="6976872" y="6144768"/>
+            <a:off x="6976872" y="6199632"/>
             <a:ext cx="1508760" cy="292608"/>
           </a:xfrm>
           <a:prstGeom prst="roundRect">
@@ -14518,7 +16651,7 @@
         </p:nvSpPr>
         <p:spPr>
           <a:xfrm>
-            <a:off x="6976872" y="6163056"/>
+            <a:off x="6976872" y="6217920"/>
             <a:ext cx="1508760" cy="256032"/>
           </a:xfrm>
           <a:prstGeom prst="rect">
@@ -14557,7 +16690,7 @@
         </p:nvSpPr>
         <p:spPr>
           <a:xfrm>
-            <a:off x="8595360" y="6144768"/>
+            <a:off x="8595360" y="6199632"/>
             <a:ext cx="1508760" cy="292608"/>
           </a:xfrm>
           <a:prstGeom prst="roundRect">
@@ -14602,7 +16735,7 @@
         </p:nvSpPr>
         <p:spPr>
           <a:xfrm>
-            <a:off x="8595360" y="6144768"/>
+            <a:off x="8595360" y="6199632"/>
             <a:ext cx="1508760" cy="45720"/>
           </a:xfrm>
           <a:prstGeom prst="rect">
@@ -14645,7 +16778,7 @@
         </p:nvSpPr>
         <p:spPr>
           <a:xfrm>
-            <a:off x="8595360" y="6163056"/>
+            <a:off x="8595360" y="6217920"/>
             <a:ext cx="1508760" cy="256032"/>
           </a:xfrm>
           <a:prstGeom prst="rect">
@@ -14684,7 +16817,7 @@
         </p:nvSpPr>
         <p:spPr>
           <a:xfrm>
-            <a:off x="10213848" y="6144768"/>
+            <a:off x="10213848" y="6199632"/>
             <a:ext cx="1508760" cy="292608"/>
           </a:xfrm>
           <a:prstGeom prst="roundRect">
@@ -14729,7 +16862,7 @@
         </p:nvSpPr>
         <p:spPr>
           <a:xfrm>
-            <a:off x="10213848" y="6163056"/>
+            <a:off x="10213848" y="6217920"/>
             <a:ext cx="1508760" cy="256032"/>
           </a:xfrm>
           <a:prstGeom prst="rect">
@@ -14834,6 +16967,294 @@
                 <a:latin typeface="Calibri"/>
               </a:rPr>
               <a:t>7 / 8</a:t>
+            </a:r>
+          </a:p>
+        </p:txBody>
+      </p:sp>
+      <p:sp>
+        <p:nvSpPr>
+          <p:cNvPr id="39" name="Rounded Rectangle 38"/>
+          <p:cNvSpPr/>
+          <p:nvPr/>
+        </p:nvSpPr>
+        <p:spPr>
+          <a:xfrm>
+            <a:off x="9646920" y="164592"/>
+            <a:ext cx="2331720" cy="868680"/>
+          </a:xfrm>
+          <a:prstGeom prst="roundRect">
+            <a:avLst>
+              <a:gd name="adj" fmla="val 12000"/>
+            </a:avLst>
+          </a:prstGeom>
+          <a:solidFill>
+            <a:srgbClr val="1A2332"/>
+          </a:solidFill>
+          <a:ln>
+            <a:noFill/>
+          </a:ln>
+        </p:spPr>
+        <p:style>
+          <a:lnRef idx="1">
+            <a:schemeClr val="accent1"/>
+          </a:lnRef>
+          <a:fillRef idx="3">
+            <a:schemeClr val="accent1"/>
+          </a:fillRef>
+          <a:effectRef idx="2">
+            <a:schemeClr val="accent1"/>
+          </a:effectRef>
+          <a:fontRef idx="minor">
+            <a:schemeClr val="lt1"/>
+          </a:fontRef>
+        </p:style>
+        <p:txBody>
+          <a:bodyPr rtlCol="0" anchor="ctr"/>
+          <a:lstStyle/>
+          <a:p>
+            <a:pPr algn="ctr"/>
+          </a:p>
+        </p:txBody>
+      </p:sp>
+      <p:sp>
+        <p:nvSpPr>
+          <p:cNvPr id="40" name="Rectangle 39"/>
+          <p:cNvSpPr/>
+          <p:nvPr/>
+        </p:nvSpPr>
+        <p:spPr>
+          <a:xfrm>
+            <a:off x="9646920" y="164592"/>
+            <a:ext cx="73152" cy="868680"/>
+          </a:xfrm>
+          <a:prstGeom prst="rect">
+            <a:avLst/>
+          </a:prstGeom>
+          <a:solidFill>
+            <a:srgbClr val="D4A853"/>
+          </a:solidFill>
+          <a:ln>
+            <a:noFill/>
+          </a:ln>
+        </p:spPr>
+        <p:style>
+          <a:lnRef idx="1">
+            <a:schemeClr val="accent1"/>
+          </a:lnRef>
+          <a:fillRef idx="3">
+            <a:schemeClr val="accent1"/>
+          </a:fillRef>
+          <a:effectRef idx="2">
+            <a:schemeClr val="accent1"/>
+          </a:effectRef>
+          <a:fontRef idx="minor">
+            <a:schemeClr val="lt1"/>
+          </a:fontRef>
+        </p:style>
+        <p:txBody>
+          <a:bodyPr rtlCol="0" anchor="ctr"/>
+          <a:lstStyle/>
+          <a:p>
+            <a:pPr algn="ctr"/>
+          </a:p>
+        </p:txBody>
+      </p:sp>
+      <p:sp>
+        <p:nvSpPr>
+          <p:cNvPr id="41" name="TextBox 40"/>
+          <p:cNvSpPr txBox="1"/>
+          <p:nvPr/>
+        </p:nvSpPr>
+        <p:spPr>
+          <a:xfrm>
+            <a:off x="9811512" y="219456"/>
+            <a:ext cx="2075688" cy="777240"/>
+          </a:xfrm>
+          <a:prstGeom prst="rect">
+            <a:avLst/>
+          </a:prstGeom>
+          <a:noFill/>
+        </p:spPr>
+        <p:txBody>
+          <a:bodyPr wrap="square">
+            <a:spAutoFit/>
+          </a:bodyPr>
+          <a:lstStyle/>
+          <a:p>
+            <a:pPr algn="l">
+              <a:spcAft>
+                <a:spcPts val="0"/>
+              </a:spcAft>
+            </a:pPr>
+            <a:r>
+              <a:rPr sz="900" b="1">
+                <a:solidFill>
+                  <a:srgbClr val="8B9CB3"/>
+                </a:solidFill>
+                <a:latin typeface="Calibri"/>
+              </a:rPr>
+              <a:t>SLIDE BUDGET</a:t>
+            </a:r>
+          </a:p>
+          <a:p>
+            <a:pPr algn="l">
+              <a:spcAft>
+                <a:spcPts val="0"/>
+              </a:spcAft>
+            </a:pPr>
+            <a:r>
+              <a:rPr sz="2600" b="1">
+                <a:solidFill>
+                  <a:srgbClr val="D4A853"/>
+                </a:solidFill>
+                <a:latin typeface="Calibri"/>
+              </a:rPr>
+              <a:t>1:05</a:t>
+            </a:r>
+          </a:p>
+          <a:p>
+            <a:pPr algn="l">
+              <a:spcAft>
+                <a:spcPts val="0"/>
+              </a:spcAft>
+            </a:pPr>
+            <a:r>
+              <a:rPr sz="900" b="0">
+                <a:solidFill>
+                  <a:srgbClr val="8B9CB3"/>
+                </a:solidFill>
+                <a:latin typeface="Calibri"/>
+              </a:rPr>
+              <a:t>by end 8:55 · left 1:05</a:t>
+            </a:r>
+          </a:p>
+        </p:txBody>
+      </p:sp>
+      <p:sp>
+        <p:nvSpPr>
+          <p:cNvPr id="42" name="Rounded Rectangle 41"/>
+          <p:cNvSpPr/>
+          <p:nvPr/>
+        </p:nvSpPr>
+        <p:spPr>
+          <a:xfrm>
+            <a:off x="502920" y="5961888"/>
+            <a:ext cx="11155680" cy="109728"/>
+          </a:xfrm>
+          <a:prstGeom prst="roundRect">
+            <a:avLst>
+              <a:gd name="adj" fmla="val 50000"/>
+            </a:avLst>
+          </a:prstGeom>
+          <a:solidFill>
+            <a:srgbClr val="243044"/>
+          </a:solidFill>
+          <a:ln>
+            <a:noFill/>
+          </a:ln>
+        </p:spPr>
+        <p:style>
+          <a:lnRef idx="1">
+            <a:schemeClr val="accent1"/>
+          </a:lnRef>
+          <a:fillRef idx="3">
+            <a:schemeClr val="accent1"/>
+          </a:fillRef>
+          <a:effectRef idx="2">
+            <a:schemeClr val="accent1"/>
+          </a:effectRef>
+          <a:fontRef idx="minor">
+            <a:schemeClr val="lt1"/>
+          </a:fontRef>
+        </p:style>
+        <p:txBody>
+          <a:bodyPr rtlCol="0" anchor="ctr"/>
+          <a:lstStyle/>
+          <a:p>
+            <a:pPr algn="ctr"/>
+          </a:p>
+        </p:txBody>
+      </p:sp>
+      <p:sp>
+        <p:nvSpPr>
+          <p:cNvPr id="43" name="Rounded Rectangle 42"/>
+          <p:cNvSpPr/>
+          <p:nvPr/>
+        </p:nvSpPr>
+        <p:spPr>
+          <a:xfrm>
+            <a:off x="502920" y="5961888"/>
+            <a:ext cx="11155680" cy="109728"/>
+          </a:xfrm>
+          <a:prstGeom prst="roundRect">
+            <a:avLst>
+              <a:gd name="adj" fmla="val 50000"/>
+            </a:avLst>
+          </a:prstGeom>
+          <a:solidFill>
+            <a:srgbClr val="D4A853"/>
+          </a:solidFill>
+          <a:ln>
+            <a:noFill/>
+          </a:ln>
+        </p:spPr>
+        <p:style>
+          <a:lnRef idx="1">
+            <a:schemeClr val="accent1"/>
+          </a:lnRef>
+          <a:fillRef idx="3">
+            <a:schemeClr val="accent1"/>
+          </a:fillRef>
+          <a:effectRef idx="2">
+            <a:schemeClr val="accent1"/>
+          </a:effectRef>
+          <a:fontRef idx="minor">
+            <a:schemeClr val="lt1"/>
+          </a:fontRef>
+        </p:style>
+        <p:txBody>
+          <a:bodyPr rtlCol="0" anchor="ctr"/>
+          <a:lstStyle/>
+          <a:p>
+            <a:pPr algn="ctr"/>
+          </a:p>
+        </p:txBody>
+      </p:sp>
+      <p:sp>
+        <p:nvSpPr>
+          <p:cNvPr id="44" name="TextBox 43"/>
+          <p:cNvSpPr txBox="1"/>
+          <p:nvPr/>
+        </p:nvSpPr>
+        <p:spPr>
+          <a:xfrm>
+            <a:off x="502920" y="5760720"/>
+            <a:ext cx="5029200" cy="201168"/>
+          </a:xfrm>
+          <a:prstGeom prst="rect">
+            <a:avLst/>
+          </a:prstGeom>
+          <a:noFill/>
+        </p:spPr>
+        <p:txBody>
+          <a:bodyPr wrap="none">
+            <a:spAutoFit/>
+          </a:bodyPr>
+          <a:lstStyle/>
+          <a:p>
+            <a:pPr algn="l">
+              <a:spcAft>
+                <a:spcPts val="0"/>
+              </a:spcAft>
+            </a:pPr>
+            <a:r>
+              <a:rPr sz="800" b="0">
+                <a:solidFill>
+                  <a:srgbClr val="8B9CB3"/>
+                </a:solidFill>
+                <a:latin typeface="Calibri"/>
+              </a:rPr>
+              <a:t>Countdown bar starts in Slideshow · does not auto-advance — you click when ready</a:t>
             </a:r>
           </a:p>
         </p:txBody>
@@ -14843,6 +17264,62 @@
   <p:clrMapOvr>
     <a:masterClrMapping/>
   </p:clrMapOvr>
+  <p:timing>
+    <p:tnLst>
+      <p:par>
+        <p:cTn id="1" dur="indefinite" restart="never" nodeType="tmRoot">
+          <p:childTnLst>
+            <p:seq concurrent="1" nextAc="seek">
+              <p:cTn id="2" dur="indefinite" nodeType="mainSeq">
+                <p:childTnLst>
+                  <p:par>
+                    <p:cTn id="3" fill="hold">
+                      <p:stCondLst>
+                        <p:cond delay="0"/>
+                      </p:stCondLst>
+                      <p:childTnLst>
+                        <p:par>
+                          <p:cTn id="4" fill="hold">
+                            <p:stCondLst>
+                              <p:cond delay="0"/>
+                            </p:stCondLst>
+                            <p:childTnLst>
+                              <p:animEffect transition="out" filter="wipe(left)">
+                                <p:cBhvr>
+                                  <p:cTn id="5" dur="65000" fill="hold"/>
+                                  <p:tgtEl>
+                                    <p:spTgt spid="43"/>
+                                  </p:tgtEl>
+                                </p:cBhvr>
+                              </p:animEffect>
+                            </p:childTnLst>
+                          </p:cTn>
+                        </p:par>
+                      </p:childTnLst>
+                    </p:cTn>
+                  </p:par>
+                </p:childTnLst>
+              </p:cTn>
+              <p:prevCondLst>
+                <p:cond evt="onPrev" delay="0">
+                  <p:tgtEl>
+                    <p:sldTgt/>
+                  </p:tgtEl>
+                </p:cond>
+              </p:prevCondLst>
+              <p:nextCondLst>
+                <p:cond evt="onNext" delay="0">
+                  <p:tgtEl>
+                    <p:sldTgt/>
+                  </p:tgtEl>
+                </p:cond>
+              </p:nextCondLst>
+            </p:seq>
+          </p:childTnLst>
+        </p:cTn>
+      </p:par>
+    </p:tnLst>
+  </p:timing>
 </p:sld>
 </file>
 
@@ -14947,7 +17424,7 @@
         <p:spPr>
           <a:xfrm>
             <a:off x="502920" y="438912"/>
-            <a:ext cx="11155680" cy="594360"/>
+            <a:ext cx="8869680" cy="594360"/>
           </a:xfrm>
           <a:prstGeom prst="rect">
             <a:avLst/>
@@ -15547,7 +18024,7 @@
         </p:nvSpPr>
         <p:spPr>
           <a:xfrm>
-            <a:off x="502920" y="6144768"/>
+            <a:off x="502920" y="6199632"/>
             <a:ext cx="1508760" cy="292608"/>
           </a:xfrm>
           <a:prstGeom prst="roundRect">
@@ -15592,7 +18069,7 @@
         </p:nvSpPr>
         <p:spPr>
           <a:xfrm>
-            <a:off x="502920" y="6163056"/>
+            <a:off x="502920" y="6217920"/>
             <a:ext cx="1508760" cy="256032"/>
           </a:xfrm>
           <a:prstGeom prst="rect">
@@ -15631,7 +18108,7 @@
         </p:nvSpPr>
         <p:spPr>
           <a:xfrm>
-            <a:off x="2121408" y="6144768"/>
+            <a:off x="2121408" y="6199632"/>
             <a:ext cx="1508760" cy="292608"/>
           </a:xfrm>
           <a:prstGeom prst="roundRect">
@@ -15676,7 +18153,7 @@
         </p:nvSpPr>
         <p:spPr>
           <a:xfrm>
-            <a:off x="2121408" y="6163056"/>
+            <a:off x="2121408" y="6217920"/>
             <a:ext cx="1508760" cy="256032"/>
           </a:xfrm>
           <a:prstGeom prst="rect">
@@ -15715,7 +18192,7 @@
         </p:nvSpPr>
         <p:spPr>
           <a:xfrm>
-            <a:off x="3739896" y="6144768"/>
+            <a:off x="3739896" y="6199632"/>
             <a:ext cx="1508760" cy="292608"/>
           </a:xfrm>
           <a:prstGeom prst="roundRect">
@@ -15760,7 +18237,7 @@
         </p:nvSpPr>
         <p:spPr>
           <a:xfrm>
-            <a:off x="3739896" y="6163056"/>
+            <a:off x="3739896" y="6217920"/>
             <a:ext cx="1508760" cy="256032"/>
           </a:xfrm>
           <a:prstGeom prst="rect">
@@ -15799,7 +18276,7 @@
         </p:nvSpPr>
         <p:spPr>
           <a:xfrm>
-            <a:off x="5358384" y="6144768"/>
+            <a:off x="5358384" y="6199632"/>
             <a:ext cx="1508760" cy="292608"/>
           </a:xfrm>
           <a:prstGeom prst="roundRect">
@@ -15844,7 +18321,7 @@
         </p:nvSpPr>
         <p:spPr>
           <a:xfrm>
-            <a:off x="5358384" y="6163056"/>
+            <a:off x="5358384" y="6217920"/>
             <a:ext cx="1508760" cy="256032"/>
           </a:xfrm>
           <a:prstGeom prst="rect">
@@ -15883,7 +18360,7 @@
         </p:nvSpPr>
         <p:spPr>
           <a:xfrm>
-            <a:off x="6976872" y="6144768"/>
+            <a:off x="6976872" y="6199632"/>
             <a:ext cx="1508760" cy="292608"/>
           </a:xfrm>
           <a:prstGeom prst="roundRect">
@@ -15928,7 +18405,7 @@
         </p:nvSpPr>
         <p:spPr>
           <a:xfrm>
-            <a:off x="6976872" y="6163056"/>
+            <a:off x="6976872" y="6217920"/>
             <a:ext cx="1508760" cy="256032"/>
           </a:xfrm>
           <a:prstGeom prst="rect">
@@ -15967,7 +18444,7 @@
         </p:nvSpPr>
         <p:spPr>
           <a:xfrm>
-            <a:off x="8595360" y="6144768"/>
+            <a:off x="8595360" y="6199632"/>
             <a:ext cx="1508760" cy="292608"/>
           </a:xfrm>
           <a:prstGeom prst="roundRect">
@@ -16012,7 +18489,7 @@
         </p:nvSpPr>
         <p:spPr>
           <a:xfrm>
-            <a:off x="8595360" y="6163056"/>
+            <a:off x="8595360" y="6217920"/>
             <a:ext cx="1508760" cy="256032"/>
           </a:xfrm>
           <a:prstGeom prst="rect">
@@ -16051,7 +18528,7 @@
         </p:nvSpPr>
         <p:spPr>
           <a:xfrm>
-            <a:off x="10213848" y="6144768"/>
+            <a:off x="10213848" y="6199632"/>
             <a:ext cx="1508760" cy="292608"/>
           </a:xfrm>
           <a:prstGeom prst="roundRect">
@@ -16096,7 +18573,7 @@
         </p:nvSpPr>
         <p:spPr>
           <a:xfrm>
-            <a:off x="10213848" y="6144768"/>
+            <a:off x="10213848" y="6199632"/>
             <a:ext cx="1508760" cy="45720"/>
           </a:xfrm>
           <a:prstGeom prst="rect">
@@ -16139,7 +18616,7 @@
         </p:nvSpPr>
         <p:spPr>
           <a:xfrm>
-            <a:off x="10213848" y="6163056"/>
+            <a:off x="10213848" y="6217920"/>
             <a:ext cx="1508760" cy="256032"/>
           </a:xfrm>
           <a:prstGeom prst="rect">
@@ -16244,6 +18721,294 @@
                 <a:latin typeface="Calibri"/>
               </a:rPr>
               <a:t>8 / 8</a:t>
+            </a:r>
+          </a:p>
+        </p:txBody>
+      </p:sp>
+      <p:sp>
+        <p:nvSpPr>
+          <p:cNvPr id="32" name="Rounded Rectangle 31"/>
+          <p:cNvSpPr/>
+          <p:nvPr/>
+        </p:nvSpPr>
+        <p:spPr>
+          <a:xfrm>
+            <a:off x="9646920" y="164592"/>
+            <a:ext cx="2331720" cy="868680"/>
+          </a:xfrm>
+          <a:prstGeom prst="roundRect">
+            <a:avLst>
+              <a:gd name="adj" fmla="val 12000"/>
+            </a:avLst>
+          </a:prstGeom>
+          <a:solidFill>
+            <a:srgbClr val="1A2332"/>
+          </a:solidFill>
+          <a:ln>
+            <a:noFill/>
+          </a:ln>
+        </p:spPr>
+        <p:style>
+          <a:lnRef idx="1">
+            <a:schemeClr val="accent1"/>
+          </a:lnRef>
+          <a:fillRef idx="3">
+            <a:schemeClr val="accent1"/>
+          </a:fillRef>
+          <a:effectRef idx="2">
+            <a:schemeClr val="accent1"/>
+          </a:effectRef>
+          <a:fontRef idx="minor">
+            <a:schemeClr val="lt1"/>
+          </a:fontRef>
+        </p:style>
+        <p:txBody>
+          <a:bodyPr rtlCol="0" anchor="ctr"/>
+          <a:lstStyle/>
+          <a:p>
+            <a:pPr algn="ctr"/>
+          </a:p>
+        </p:txBody>
+      </p:sp>
+      <p:sp>
+        <p:nvSpPr>
+          <p:cNvPr id="33" name="Rectangle 32"/>
+          <p:cNvSpPr/>
+          <p:nvPr/>
+        </p:nvSpPr>
+        <p:spPr>
+          <a:xfrm>
+            <a:off x="9646920" y="164592"/>
+            <a:ext cx="73152" cy="868680"/>
+          </a:xfrm>
+          <a:prstGeom prst="rect">
+            <a:avLst/>
+          </a:prstGeom>
+          <a:solidFill>
+            <a:srgbClr val="D4A853"/>
+          </a:solidFill>
+          <a:ln>
+            <a:noFill/>
+          </a:ln>
+        </p:spPr>
+        <p:style>
+          <a:lnRef idx="1">
+            <a:schemeClr val="accent1"/>
+          </a:lnRef>
+          <a:fillRef idx="3">
+            <a:schemeClr val="accent1"/>
+          </a:fillRef>
+          <a:effectRef idx="2">
+            <a:schemeClr val="accent1"/>
+          </a:effectRef>
+          <a:fontRef idx="minor">
+            <a:schemeClr val="lt1"/>
+          </a:fontRef>
+        </p:style>
+        <p:txBody>
+          <a:bodyPr rtlCol="0" anchor="ctr"/>
+          <a:lstStyle/>
+          <a:p>
+            <a:pPr algn="ctr"/>
+          </a:p>
+        </p:txBody>
+      </p:sp>
+      <p:sp>
+        <p:nvSpPr>
+          <p:cNvPr id="34" name="TextBox 33"/>
+          <p:cNvSpPr txBox="1"/>
+          <p:nvPr/>
+        </p:nvSpPr>
+        <p:spPr>
+          <a:xfrm>
+            <a:off x="9811512" y="219456"/>
+            <a:ext cx="2075688" cy="777240"/>
+          </a:xfrm>
+          <a:prstGeom prst="rect">
+            <a:avLst/>
+          </a:prstGeom>
+          <a:noFill/>
+        </p:spPr>
+        <p:txBody>
+          <a:bodyPr wrap="square">
+            <a:spAutoFit/>
+          </a:bodyPr>
+          <a:lstStyle/>
+          <a:p>
+            <a:pPr algn="l">
+              <a:spcAft>
+                <a:spcPts val="0"/>
+              </a:spcAft>
+            </a:pPr>
+            <a:r>
+              <a:rPr sz="900" b="1">
+                <a:solidFill>
+                  <a:srgbClr val="8B9CB3"/>
+                </a:solidFill>
+                <a:latin typeface="Calibri"/>
+              </a:rPr>
+              <a:t>SLIDE BUDGET</a:t>
+            </a:r>
+          </a:p>
+          <a:p>
+            <a:pPr algn="l">
+              <a:spcAft>
+                <a:spcPts val="0"/>
+              </a:spcAft>
+            </a:pPr>
+            <a:r>
+              <a:rPr sz="2600" b="1">
+                <a:solidFill>
+                  <a:srgbClr val="D4A853"/>
+                </a:solidFill>
+                <a:latin typeface="Calibri"/>
+              </a:rPr>
+              <a:t>1:05</a:t>
+            </a:r>
+          </a:p>
+          <a:p>
+            <a:pPr algn="l">
+              <a:spcAft>
+                <a:spcPts val="0"/>
+              </a:spcAft>
+            </a:pPr>
+            <a:r>
+              <a:rPr sz="900" b="0">
+                <a:solidFill>
+                  <a:srgbClr val="8B9CB3"/>
+                </a:solidFill>
+                <a:latin typeface="Calibri"/>
+              </a:rPr>
+              <a:t>by end 10:00 · left 0:00</a:t>
+            </a:r>
+          </a:p>
+        </p:txBody>
+      </p:sp>
+      <p:sp>
+        <p:nvSpPr>
+          <p:cNvPr id="35" name="Rounded Rectangle 34"/>
+          <p:cNvSpPr/>
+          <p:nvPr/>
+        </p:nvSpPr>
+        <p:spPr>
+          <a:xfrm>
+            <a:off x="502920" y="5961888"/>
+            <a:ext cx="11155680" cy="109728"/>
+          </a:xfrm>
+          <a:prstGeom prst="roundRect">
+            <a:avLst>
+              <a:gd name="adj" fmla="val 50000"/>
+            </a:avLst>
+          </a:prstGeom>
+          <a:solidFill>
+            <a:srgbClr val="243044"/>
+          </a:solidFill>
+          <a:ln>
+            <a:noFill/>
+          </a:ln>
+        </p:spPr>
+        <p:style>
+          <a:lnRef idx="1">
+            <a:schemeClr val="accent1"/>
+          </a:lnRef>
+          <a:fillRef idx="3">
+            <a:schemeClr val="accent1"/>
+          </a:fillRef>
+          <a:effectRef idx="2">
+            <a:schemeClr val="accent1"/>
+          </a:effectRef>
+          <a:fontRef idx="minor">
+            <a:schemeClr val="lt1"/>
+          </a:fontRef>
+        </p:style>
+        <p:txBody>
+          <a:bodyPr rtlCol="0" anchor="ctr"/>
+          <a:lstStyle/>
+          <a:p>
+            <a:pPr algn="ctr"/>
+          </a:p>
+        </p:txBody>
+      </p:sp>
+      <p:sp>
+        <p:nvSpPr>
+          <p:cNvPr id="36" name="Rounded Rectangle 35"/>
+          <p:cNvSpPr/>
+          <p:nvPr/>
+        </p:nvSpPr>
+        <p:spPr>
+          <a:xfrm>
+            <a:off x="502920" y="5961888"/>
+            <a:ext cx="11155680" cy="109728"/>
+          </a:xfrm>
+          <a:prstGeom prst="roundRect">
+            <a:avLst>
+              <a:gd name="adj" fmla="val 50000"/>
+            </a:avLst>
+          </a:prstGeom>
+          <a:solidFill>
+            <a:srgbClr val="D4A853"/>
+          </a:solidFill>
+          <a:ln>
+            <a:noFill/>
+          </a:ln>
+        </p:spPr>
+        <p:style>
+          <a:lnRef idx="1">
+            <a:schemeClr val="accent1"/>
+          </a:lnRef>
+          <a:fillRef idx="3">
+            <a:schemeClr val="accent1"/>
+          </a:fillRef>
+          <a:effectRef idx="2">
+            <a:schemeClr val="accent1"/>
+          </a:effectRef>
+          <a:fontRef idx="minor">
+            <a:schemeClr val="lt1"/>
+          </a:fontRef>
+        </p:style>
+        <p:txBody>
+          <a:bodyPr rtlCol="0" anchor="ctr"/>
+          <a:lstStyle/>
+          <a:p>
+            <a:pPr algn="ctr"/>
+          </a:p>
+        </p:txBody>
+      </p:sp>
+      <p:sp>
+        <p:nvSpPr>
+          <p:cNvPr id="37" name="TextBox 36"/>
+          <p:cNvSpPr txBox="1"/>
+          <p:nvPr/>
+        </p:nvSpPr>
+        <p:spPr>
+          <a:xfrm>
+            <a:off x="502920" y="5760720"/>
+            <a:ext cx="5029200" cy="201168"/>
+          </a:xfrm>
+          <a:prstGeom prst="rect">
+            <a:avLst/>
+          </a:prstGeom>
+          <a:noFill/>
+        </p:spPr>
+        <p:txBody>
+          <a:bodyPr wrap="none">
+            <a:spAutoFit/>
+          </a:bodyPr>
+          <a:lstStyle/>
+          <a:p>
+            <a:pPr algn="l">
+              <a:spcAft>
+                <a:spcPts val="0"/>
+              </a:spcAft>
+            </a:pPr>
+            <a:r>
+              <a:rPr sz="800" b="0">
+                <a:solidFill>
+                  <a:srgbClr val="8B9CB3"/>
+                </a:solidFill>
+                <a:latin typeface="Calibri"/>
+              </a:rPr>
+              <a:t>Countdown bar starts in Slideshow · does not auto-advance — you click when ready</a:t>
             </a:r>
           </a:p>
         </p:txBody>
@@ -16253,6 +19018,62 @@
   <p:clrMapOvr>
     <a:masterClrMapping/>
   </p:clrMapOvr>
+  <p:timing>
+    <p:tnLst>
+      <p:par>
+        <p:cTn id="1" dur="indefinite" restart="never" nodeType="tmRoot">
+          <p:childTnLst>
+            <p:seq concurrent="1" nextAc="seek">
+              <p:cTn id="2" dur="indefinite" nodeType="mainSeq">
+                <p:childTnLst>
+                  <p:par>
+                    <p:cTn id="3" fill="hold">
+                      <p:stCondLst>
+                        <p:cond delay="0"/>
+                      </p:stCondLst>
+                      <p:childTnLst>
+                        <p:par>
+                          <p:cTn id="4" fill="hold">
+                            <p:stCondLst>
+                              <p:cond delay="0"/>
+                            </p:stCondLst>
+                            <p:childTnLst>
+                              <p:animEffect transition="out" filter="wipe(left)">
+                                <p:cBhvr>
+                                  <p:cTn id="5" dur="65000" fill="hold"/>
+                                  <p:tgtEl>
+                                    <p:spTgt spid="36"/>
+                                  </p:tgtEl>
+                                </p:cBhvr>
+                              </p:animEffect>
+                            </p:childTnLst>
+                          </p:cTn>
+                        </p:par>
+                      </p:childTnLst>
+                    </p:cTn>
+                  </p:par>
+                </p:childTnLst>
+              </p:cTn>
+              <p:prevCondLst>
+                <p:cond evt="onPrev" delay="0">
+                  <p:tgtEl>
+                    <p:sldTgt/>
+                  </p:tgtEl>
+                </p:cond>
+              </p:prevCondLst>
+              <p:nextCondLst>
+                <p:cond evt="onNext" delay="0">
+                  <p:tgtEl>
+                    <p:sldTgt/>
+                  </p:tgtEl>
+                </p:cond>
+              </p:nextCondLst>
+            </p:seq>
+          </p:childTnLst>
+        </p:cTn>
+      </p:par>
+    </p:tnLst>
+  </p:timing>
 </p:sld>
 </file>
 

</xml_diff>

<commit_message>
Add live presenter coach timer that records time per slide
Introduce presenter-timer.html as a second-screen stopwatch that tracks
actual elapsed time vs budget, nudges MOVE ON when over, and logs a
per-slide rehearsal summary. PPTX decks now also reveal a red MOVE ON
cue when the slide budget countdown ends.

Co-authored-by: gauravch86 <gauravch86@users.noreply.github.com>
</commit_message>
<xml_diff>
--- a/case-study-1-reposition-executive.pptx
+++ b/case-study-1-reposition-executive.pptx
@@ -543,7 +543,7 @@
           <a:p/>
           <a:p>
             <a:r>
-              <a:t>ON-SLIDE TIMER: Budget 1:15 for this slide. Gold bar counts down when Slideshow opens (does not auto-advance). By end of this slide you should be at ~1:15 of 10:00 (~8:45 remaining).</a:t>
+              <a:t>ON-SLIDE TIMER: Budget 1:15 for this slide. Gold bar counts down in Slideshow; red MOVE ON appears when budget ends (does not auto-advance). Prefer presenter-timer.html on a second screen for a live stopwatch that records actual seconds per slide. By end of this slide you should be at ~1:15 of 10:00 (~8:45 remaining).</a:t>
             </a:r>
           </a:p>
         </p:txBody>
@@ -641,7 +641,7 @@
           <a:p/>
           <a:p>
             <a:r>
-              <a:t>ON-SLIDE TIMER: Budget 1:20 for this slide. Gold bar counts down when Slideshow opens (does not auto-advance). By end of this slide you should be at ~2:35 of 10:00 (~7:25 remaining).</a:t>
+              <a:t>ON-SLIDE TIMER: Budget 1:20 for this slide. Gold bar counts down in Slideshow; red MOVE ON appears when budget ends (does not auto-advance). Prefer presenter-timer.html on a second screen for a live stopwatch that records actual seconds per slide. By end of this slide you should be at ~2:35 of 10:00 (~7:25 remaining).</a:t>
             </a:r>
           </a:p>
         </p:txBody>
@@ -733,7 +733,7 @@
           <a:p/>
           <a:p>
             <a:r>
-              <a:t>ON-SLIDE TIMER: Budget 1:20 for this slide. Gold bar counts down when Slideshow opens (does not auto-advance). By end of this slide you should be at ~3:55 of 10:00 (~6:05 remaining).</a:t>
+              <a:t>ON-SLIDE TIMER: Budget 1:20 for this slide. Gold bar counts down in Slideshow; red MOVE ON appears when budget ends (does not auto-advance). Prefer presenter-timer.html on a second screen for a live stopwatch that records actual seconds per slide. By end of this slide you should be at ~3:55 of 10:00 (~6:05 remaining).</a:t>
             </a:r>
           </a:p>
         </p:txBody>
@@ -830,7 +830,7 @@
           <a:p/>
           <a:p>
             <a:r>
-              <a:t>ON-SLIDE TIMER: Budget 1:15 for this slide. Gold bar counts down when Slideshow opens (does not auto-advance). By end of this slide you should be at ~5:10 of 10:00 (~4:50 remaining).</a:t>
+              <a:t>ON-SLIDE TIMER: Budget 1:15 for this slide. Gold bar counts down in Slideshow; red MOVE ON appears when budget ends (does not auto-advance). Prefer presenter-timer.html on a second screen for a live stopwatch that records actual seconds per slide. By end of this slide you should be at ~5:10 of 10:00 (~4:50 remaining).</a:t>
             </a:r>
           </a:p>
         </p:txBody>
@@ -917,7 +917,7 @@
           <a:p/>
           <a:p>
             <a:r>
-              <a:t>ON-SLIDE TIMER: Budget 1:25 for this slide. Gold bar counts down when Slideshow opens (does not auto-advance). By end of this slide you should be at ~6:35 of 10:00 (~3:25 remaining).</a:t>
+              <a:t>ON-SLIDE TIMER: Budget 1:25 for this slide. Gold bar counts down in Slideshow; red MOVE ON appears when budget ends (does not auto-advance). Prefer presenter-timer.html on a second screen for a live stopwatch that records actual seconds per slide. By end of this slide you should be at ~6:35 of 10:00 (~3:25 remaining).</a:t>
             </a:r>
           </a:p>
         </p:txBody>
@@ -1004,7 +1004,7 @@
           <a:p/>
           <a:p>
             <a:r>
-              <a:t>ON-SLIDE TIMER: Budget 1:15 for this slide. Gold bar counts down when Slideshow opens (does not auto-advance). By end of this slide you should be at ~7:50 of 10:00 (~2:10 remaining).</a:t>
+              <a:t>ON-SLIDE TIMER: Budget 1:15 for this slide. Gold bar counts down in Slideshow; red MOVE ON appears when budget ends (does not auto-advance). Prefer presenter-timer.html on a second screen for a live stopwatch that records actual seconds per slide. By end of this slide you should be at ~7:50 of 10:00 (~2:10 remaining).</a:t>
             </a:r>
           </a:p>
         </p:txBody>
@@ -1086,7 +1086,7 @@
           <a:p/>
           <a:p>
             <a:r>
-              <a:t>ON-SLIDE TIMER: Budget 1:05 for this slide. Gold bar counts down when Slideshow opens (does not auto-advance). By end of this slide you should be at ~8:55 of 10:00 (~1:05 remaining).</a:t>
+              <a:t>ON-SLIDE TIMER: Budget 1:05 for this slide. Gold bar counts down in Slideshow; red MOVE ON appears when budget ends (does not auto-advance). Prefer presenter-timer.html on a second screen for a live stopwatch that records actual seconds per slide. By end of this slide you should be at ~8:55 of 10:00 (~1:05 remaining).</a:t>
             </a:r>
           </a:p>
         </p:txBody>
@@ -1179,7 +1179,7 @@
           <a:p/>
           <a:p>
             <a:r>
-              <a:t>ON-SLIDE TIMER: Budget 1:05 for this slide. Gold bar counts down when Slideshow opens (does not auto-advance). By end of this slide you should be at ~10:00 of 10:00 (~0:00 remaining).</a:t>
+              <a:t>ON-SLIDE TIMER: Budget 1:05 for this slide. Gold bar counts down in Slideshow; red MOVE ON appears when budget ends (does not auto-advance). Prefer presenter-timer.html on a second screen for a live stopwatch that records actual seconds per slide. By end of this slide you should be at ~10:00 of 10:00 (~0:00 remaining).</a:t>
             </a:r>
           </a:p>
         </p:txBody>
@@ -4897,6 +4897,22 @@
           <a:p>
             <a:pPr algn="l">
               <a:spcAft>
+                <a:spcPts val="200"/>
+              </a:spcAft>
+            </a:pPr>
+            <a:r>
+              <a:rPr sz="1200" b="0">
+                <a:solidFill>
+                  <a:srgbClr val="8B9CB3"/>
+                </a:solidFill>
+                <a:latin typeface="Calibri"/>
+              </a:rPr>
+              <a:t>Top-right SLIDE BUDGET + gold bar countdown; red MOVE ON when budget ends (Slideshow).</a:t>
+            </a:r>
+          </a:p>
+          <a:p>
+            <a:pPr algn="l">
+              <a:spcAft>
                 <a:spcPts val="0"/>
               </a:spcAft>
             </a:pPr>
@@ -4907,7 +4923,7 @@
                 </a:solidFill>
                 <a:latin typeface="Calibri"/>
               </a:rPr>
-              <a:t>Top-right SLIDE BUDGET + gold bar = live countdown in Slideshow (does not auto-advance).</a:t>
+              <a:t>For a live stopwatch that records actual seconds/slide: open presenter-timer.html on a second screen.</a:t>
             </a:r>
           </a:p>
         </p:txBody>
@@ -5273,7 +5289,61 @@
                 </a:solidFill>
                 <a:latin typeface="Calibri"/>
               </a:rPr>
-              <a:t>Countdown bar starts in Slideshow · does not auto-advance — you click when ready</a:t>
+              <a:t>Countdown starts in Slideshow · red MOVE ON appears when budget ends · does not auto-advance</a:t>
+            </a:r>
+          </a:p>
+        </p:txBody>
+      </p:sp>
+      <p:sp>
+        <p:nvSpPr>
+          <p:cNvPr id="23" name="Rounded Rectangle 22"/>
+          <p:cNvSpPr/>
+          <p:nvPr/>
+        </p:nvSpPr>
+        <p:spPr>
+          <a:xfrm>
+            <a:off x="9189720" y="5614416"/>
+            <a:ext cx="2468880" cy="292608"/>
+          </a:xfrm>
+          <a:prstGeom prst="roundRect">
+            <a:avLst>
+              <a:gd name="adj" fmla="val 20000"/>
+            </a:avLst>
+          </a:prstGeom>
+          <a:solidFill>
+            <a:srgbClr val="F87171"/>
+          </a:solidFill>
+          <a:ln>
+            <a:noFill/>
+          </a:ln>
+        </p:spPr>
+        <p:style>
+          <a:lnRef idx="1">
+            <a:schemeClr val="accent1"/>
+          </a:lnRef>
+          <a:fillRef idx="3">
+            <a:schemeClr val="accent1"/>
+          </a:fillRef>
+          <a:effectRef idx="2">
+            <a:schemeClr val="accent1"/>
+          </a:effectRef>
+          <a:fontRef idx="minor">
+            <a:schemeClr val="lt1"/>
+          </a:fontRef>
+        </p:style>
+        <p:txBody>
+          <a:bodyPr rtlCol="0" anchor="ctr" wrap="none"/>
+          <a:lstStyle/>
+          <a:p>
+            <a:pPr algn="ctr"/>
+            <a:r>
+              <a:rPr sz="1200" b="1">
+                <a:solidFill>
+                  <a:srgbClr val="E6EDF3"/>
+                </a:solidFill>
+                <a:latin typeface="Calibri"/>
+              </a:rPr>
+              <a:t>MOVE ON  →</a:t>
             </a:r>
           </a:p>
         </p:txBody>
@@ -5303,14 +5373,58 @@
                               <p:cond delay="0"/>
                             </p:stCondLst>
                             <p:childTnLst>
+                              <p:set>
+                                <p:cBhvr>
+                                  <p:cTn id="5" dur="1" fill="hold"/>
+                                  <p:tgtEl>
+                                    <p:spTgt spid="23"/>
+                                  </p:tgtEl>
+                                  <p:attrNameLst>
+                                    <p:attrName>style.visibility</p:attrName>
+                                  </p:attrNameLst>
+                                </p:cBhvr>
+                                <p:to>
+                                  <p:strVal val="hidden"/>
+                                </p:to>
+                              </p:set>
                               <p:animEffect transition="out" filter="wipe(left)">
                                 <p:cBhvr>
-                                  <p:cTn id="5" dur="75000" fill="hold"/>
+                                  <p:cTn id="6" dur="75000" fill="hold"/>
                                   <p:tgtEl>
                                     <p:spTgt spid="21"/>
                                   </p:tgtEl>
                                 </p:cBhvr>
                               </p:animEffect>
+                              <p:animEffect transition="in" filter="fade">
+                                <p:cBhvr>
+                                  <p:cTn id="7" dur="400" fill="hold">
+                                    <p:stCondLst>
+                                      <p:cond delay="75000"/>
+                                    </p:stCondLst>
+                                  </p:cTn>
+                                  <p:tgtEl>
+                                    <p:spTgt spid="23"/>
+                                  </p:tgtEl>
+                                </p:cBhvr>
+                              </p:animEffect>
+                              <p:set>
+                                <p:cBhvr>
+                                  <p:cTn id="8" dur="1" fill="hold">
+                                    <p:stCondLst>
+                                      <p:cond delay="75000"/>
+                                    </p:stCondLst>
+                                  </p:cTn>
+                                  <p:tgtEl>
+                                    <p:spTgt spid="23"/>
+                                  </p:tgtEl>
+                                  <p:attrNameLst>
+                                    <p:attrName>style.visibility</p:attrName>
+                                  </p:attrNameLst>
+                                </p:cBhvr>
+                                <p:to>
+                                  <p:strVal val="visible"/>
+                                </p:to>
+                              </p:set>
                             </p:childTnLst>
                           </p:cTn>
                         </p:par>
@@ -7506,7 +7620,61 @@
                 </a:solidFill>
                 <a:latin typeface="Calibri"/>
               </a:rPr>
-              <a:t>Countdown bar starts in Slideshow · does not auto-advance — you click when ready</a:t>
+              <a:t>Countdown starts in Slideshow · red MOVE ON appears when budget ends · does not auto-advance</a:t>
+            </a:r>
+          </a:p>
+        </p:txBody>
+      </p:sp>
+      <p:sp>
+        <p:nvSpPr>
+          <p:cNvPr id="47" name="Rounded Rectangle 46"/>
+          <p:cNvSpPr/>
+          <p:nvPr/>
+        </p:nvSpPr>
+        <p:spPr>
+          <a:xfrm>
+            <a:off x="9189720" y="5614416"/>
+            <a:ext cx="2468880" cy="292608"/>
+          </a:xfrm>
+          <a:prstGeom prst="roundRect">
+            <a:avLst>
+              <a:gd name="adj" fmla="val 20000"/>
+            </a:avLst>
+          </a:prstGeom>
+          <a:solidFill>
+            <a:srgbClr val="F87171"/>
+          </a:solidFill>
+          <a:ln>
+            <a:noFill/>
+          </a:ln>
+        </p:spPr>
+        <p:style>
+          <a:lnRef idx="1">
+            <a:schemeClr val="accent1"/>
+          </a:lnRef>
+          <a:fillRef idx="3">
+            <a:schemeClr val="accent1"/>
+          </a:fillRef>
+          <a:effectRef idx="2">
+            <a:schemeClr val="accent1"/>
+          </a:effectRef>
+          <a:fontRef idx="minor">
+            <a:schemeClr val="lt1"/>
+          </a:fontRef>
+        </p:style>
+        <p:txBody>
+          <a:bodyPr rtlCol="0" anchor="ctr" wrap="none"/>
+          <a:lstStyle/>
+          <a:p>
+            <a:pPr algn="ctr"/>
+            <a:r>
+              <a:rPr sz="1200" b="1">
+                <a:solidFill>
+                  <a:srgbClr val="E6EDF3"/>
+                </a:solidFill>
+                <a:latin typeface="Calibri"/>
+              </a:rPr>
+              <a:t>MOVE ON  →</a:t>
             </a:r>
           </a:p>
         </p:txBody>
@@ -7536,14 +7704,58 @@
                               <p:cond delay="0"/>
                             </p:stCondLst>
                             <p:childTnLst>
+                              <p:set>
+                                <p:cBhvr>
+                                  <p:cTn id="5" dur="1" fill="hold"/>
+                                  <p:tgtEl>
+                                    <p:spTgt spid="47"/>
+                                  </p:tgtEl>
+                                  <p:attrNameLst>
+                                    <p:attrName>style.visibility</p:attrName>
+                                  </p:attrNameLst>
+                                </p:cBhvr>
+                                <p:to>
+                                  <p:strVal val="hidden"/>
+                                </p:to>
+                              </p:set>
                               <p:animEffect transition="out" filter="wipe(left)">
                                 <p:cBhvr>
-                                  <p:cTn id="5" dur="80000" fill="hold"/>
+                                  <p:cTn id="6" dur="80000" fill="hold"/>
                                   <p:tgtEl>
                                     <p:spTgt spid="45"/>
                                   </p:tgtEl>
                                 </p:cBhvr>
                               </p:animEffect>
+                              <p:animEffect transition="in" filter="fade">
+                                <p:cBhvr>
+                                  <p:cTn id="7" dur="400" fill="hold">
+                                    <p:stCondLst>
+                                      <p:cond delay="80000"/>
+                                    </p:stCondLst>
+                                  </p:cTn>
+                                  <p:tgtEl>
+                                    <p:spTgt spid="47"/>
+                                  </p:tgtEl>
+                                </p:cBhvr>
+                              </p:animEffect>
+                              <p:set>
+                                <p:cBhvr>
+                                  <p:cTn id="8" dur="1" fill="hold">
+                                    <p:stCondLst>
+                                      <p:cond delay="80000"/>
+                                    </p:stCondLst>
+                                  </p:cTn>
+                                  <p:tgtEl>
+                                    <p:spTgt spid="47"/>
+                                  </p:tgtEl>
+                                  <p:attrNameLst>
+                                    <p:attrName>style.visibility</p:attrName>
+                                  </p:attrNameLst>
+                                </p:cBhvr>
+                                <p:to>
+                                  <p:strVal val="visible"/>
+                                </p:to>
+                              </p:set>
                             </p:childTnLst>
                           </p:cTn>
                         </p:par>
@@ -9389,7 +9601,61 @@
                 </a:solidFill>
                 <a:latin typeface="Calibri"/>
               </a:rPr>
-              <a:t>Countdown bar starts in Slideshow · does not auto-advance — you click when ready</a:t>
+              <a:t>Countdown starts in Slideshow · red MOVE ON appears when budget ends · does not auto-advance</a:t>
+            </a:r>
+          </a:p>
+        </p:txBody>
+      </p:sp>
+      <p:sp>
+        <p:nvSpPr>
+          <p:cNvPr id="41" name="Rounded Rectangle 40"/>
+          <p:cNvSpPr/>
+          <p:nvPr/>
+        </p:nvSpPr>
+        <p:spPr>
+          <a:xfrm>
+            <a:off x="9189720" y="5614416"/>
+            <a:ext cx="2468880" cy="292608"/>
+          </a:xfrm>
+          <a:prstGeom prst="roundRect">
+            <a:avLst>
+              <a:gd name="adj" fmla="val 20000"/>
+            </a:avLst>
+          </a:prstGeom>
+          <a:solidFill>
+            <a:srgbClr val="F87171"/>
+          </a:solidFill>
+          <a:ln>
+            <a:noFill/>
+          </a:ln>
+        </p:spPr>
+        <p:style>
+          <a:lnRef idx="1">
+            <a:schemeClr val="accent1"/>
+          </a:lnRef>
+          <a:fillRef idx="3">
+            <a:schemeClr val="accent1"/>
+          </a:fillRef>
+          <a:effectRef idx="2">
+            <a:schemeClr val="accent1"/>
+          </a:effectRef>
+          <a:fontRef idx="minor">
+            <a:schemeClr val="lt1"/>
+          </a:fontRef>
+        </p:style>
+        <p:txBody>
+          <a:bodyPr rtlCol="0" anchor="ctr" wrap="none"/>
+          <a:lstStyle/>
+          <a:p>
+            <a:pPr algn="ctr"/>
+            <a:r>
+              <a:rPr sz="1200" b="1">
+                <a:solidFill>
+                  <a:srgbClr val="E6EDF3"/>
+                </a:solidFill>
+                <a:latin typeface="Calibri"/>
+              </a:rPr>
+              <a:t>MOVE ON  →</a:t>
             </a:r>
           </a:p>
         </p:txBody>
@@ -9419,14 +9685,58 @@
                               <p:cond delay="0"/>
                             </p:stCondLst>
                             <p:childTnLst>
+                              <p:set>
+                                <p:cBhvr>
+                                  <p:cTn id="5" dur="1" fill="hold"/>
+                                  <p:tgtEl>
+                                    <p:spTgt spid="41"/>
+                                  </p:tgtEl>
+                                  <p:attrNameLst>
+                                    <p:attrName>style.visibility</p:attrName>
+                                  </p:attrNameLst>
+                                </p:cBhvr>
+                                <p:to>
+                                  <p:strVal val="hidden"/>
+                                </p:to>
+                              </p:set>
                               <p:animEffect transition="out" filter="wipe(left)">
                                 <p:cBhvr>
-                                  <p:cTn id="5" dur="80000" fill="hold"/>
+                                  <p:cTn id="6" dur="80000" fill="hold"/>
                                   <p:tgtEl>
                                     <p:spTgt spid="39"/>
                                   </p:tgtEl>
                                 </p:cBhvr>
                               </p:animEffect>
+                              <p:animEffect transition="in" filter="fade">
+                                <p:cBhvr>
+                                  <p:cTn id="7" dur="400" fill="hold">
+                                    <p:stCondLst>
+                                      <p:cond delay="80000"/>
+                                    </p:stCondLst>
+                                  </p:cTn>
+                                  <p:tgtEl>
+                                    <p:spTgt spid="41"/>
+                                  </p:tgtEl>
+                                </p:cBhvr>
+                              </p:animEffect>
+                              <p:set>
+                                <p:cBhvr>
+                                  <p:cTn id="8" dur="1" fill="hold">
+                                    <p:stCondLst>
+                                      <p:cond delay="80000"/>
+                                    </p:stCondLst>
+                                  </p:cTn>
+                                  <p:tgtEl>
+                                    <p:spTgt spid="41"/>
+                                  </p:tgtEl>
+                                  <p:attrNameLst>
+                                    <p:attrName>style.visibility</p:attrName>
+                                  </p:attrNameLst>
+                                </p:cBhvr>
+                                <p:to>
+                                  <p:strVal val="visible"/>
+                                </p:to>
+                              </p:set>
                             </p:childTnLst>
                           </p:cTn>
                         </p:par>
@@ -11236,7 +11546,61 @@
                 </a:solidFill>
                 <a:latin typeface="Calibri"/>
               </a:rPr>
-              <a:t>Countdown bar starts in Slideshow · does not auto-advance — you click when ready</a:t>
+              <a:t>Countdown starts in Slideshow · red MOVE ON appears when budget ends · does not auto-advance</a:t>
+            </a:r>
+          </a:p>
+        </p:txBody>
+      </p:sp>
+      <p:sp>
+        <p:nvSpPr>
+          <p:cNvPr id="39" name="Rounded Rectangle 38"/>
+          <p:cNvSpPr/>
+          <p:nvPr/>
+        </p:nvSpPr>
+        <p:spPr>
+          <a:xfrm>
+            <a:off x="9189720" y="5614416"/>
+            <a:ext cx="2468880" cy="292608"/>
+          </a:xfrm>
+          <a:prstGeom prst="roundRect">
+            <a:avLst>
+              <a:gd name="adj" fmla="val 20000"/>
+            </a:avLst>
+          </a:prstGeom>
+          <a:solidFill>
+            <a:srgbClr val="F87171"/>
+          </a:solidFill>
+          <a:ln>
+            <a:noFill/>
+          </a:ln>
+        </p:spPr>
+        <p:style>
+          <a:lnRef idx="1">
+            <a:schemeClr val="accent1"/>
+          </a:lnRef>
+          <a:fillRef idx="3">
+            <a:schemeClr val="accent1"/>
+          </a:fillRef>
+          <a:effectRef idx="2">
+            <a:schemeClr val="accent1"/>
+          </a:effectRef>
+          <a:fontRef idx="minor">
+            <a:schemeClr val="lt1"/>
+          </a:fontRef>
+        </p:style>
+        <p:txBody>
+          <a:bodyPr rtlCol="0" anchor="ctr" wrap="none"/>
+          <a:lstStyle/>
+          <a:p>
+            <a:pPr algn="ctr"/>
+            <a:r>
+              <a:rPr sz="1200" b="1">
+                <a:solidFill>
+                  <a:srgbClr val="E6EDF3"/>
+                </a:solidFill>
+                <a:latin typeface="Calibri"/>
+              </a:rPr>
+              <a:t>MOVE ON  →</a:t>
             </a:r>
           </a:p>
         </p:txBody>
@@ -11266,14 +11630,58 @@
                               <p:cond delay="0"/>
                             </p:stCondLst>
                             <p:childTnLst>
+                              <p:set>
+                                <p:cBhvr>
+                                  <p:cTn id="5" dur="1" fill="hold"/>
+                                  <p:tgtEl>
+                                    <p:spTgt spid="39"/>
+                                  </p:tgtEl>
+                                  <p:attrNameLst>
+                                    <p:attrName>style.visibility</p:attrName>
+                                  </p:attrNameLst>
+                                </p:cBhvr>
+                                <p:to>
+                                  <p:strVal val="hidden"/>
+                                </p:to>
+                              </p:set>
                               <p:animEffect transition="out" filter="wipe(left)">
                                 <p:cBhvr>
-                                  <p:cTn id="5" dur="75000" fill="hold"/>
+                                  <p:cTn id="6" dur="75000" fill="hold"/>
                                   <p:tgtEl>
                                     <p:spTgt spid="37"/>
                                   </p:tgtEl>
                                 </p:cBhvr>
                               </p:animEffect>
+                              <p:animEffect transition="in" filter="fade">
+                                <p:cBhvr>
+                                  <p:cTn id="7" dur="400" fill="hold">
+                                    <p:stCondLst>
+                                      <p:cond delay="75000"/>
+                                    </p:stCondLst>
+                                  </p:cTn>
+                                  <p:tgtEl>
+                                    <p:spTgt spid="39"/>
+                                  </p:tgtEl>
+                                </p:cBhvr>
+                              </p:animEffect>
+                              <p:set>
+                                <p:cBhvr>
+                                  <p:cTn id="8" dur="1" fill="hold">
+                                    <p:stCondLst>
+                                      <p:cond delay="75000"/>
+                                    </p:stCondLst>
+                                  </p:cTn>
+                                  <p:tgtEl>
+                                    <p:spTgt spid="39"/>
+                                  </p:tgtEl>
+                                  <p:attrNameLst>
+                                    <p:attrName>style.visibility</p:attrName>
+                                  </p:attrNameLst>
+                                </p:cBhvr>
+                                <p:to>
+                                  <p:strVal val="visible"/>
+                                </p:to>
+                              </p:set>
                             </p:childTnLst>
                           </p:cTn>
                         </p:par>
@@ -13276,7 +13684,61 @@
                 </a:solidFill>
                 <a:latin typeface="Calibri"/>
               </a:rPr>
-              <a:t>Countdown bar starts in Slideshow · does not auto-advance — you click when ready</a:t>
+              <a:t>Countdown starts in Slideshow · red MOVE ON appears when budget ends · does not auto-advance</a:t>
+            </a:r>
+          </a:p>
+        </p:txBody>
+      </p:sp>
+      <p:sp>
+        <p:nvSpPr>
+          <p:cNvPr id="42" name="Rounded Rectangle 41"/>
+          <p:cNvSpPr/>
+          <p:nvPr/>
+        </p:nvSpPr>
+        <p:spPr>
+          <a:xfrm>
+            <a:off x="9189720" y="5614416"/>
+            <a:ext cx="2468880" cy="292608"/>
+          </a:xfrm>
+          <a:prstGeom prst="roundRect">
+            <a:avLst>
+              <a:gd name="adj" fmla="val 20000"/>
+            </a:avLst>
+          </a:prstGeom>
+          <a:solidFill>
+            <a:srgbClr val="F87171"/>
+          </a:solidFill>
+          <a:ln>
+            <a:noFill/>
+          </a:ln>
+        </p:spPr>
+        <p:style>
+          <a:lnRef idx="1">
+            <a:schemeClr val="accent1"/>
+          </a:lnRef>
+          <a:fillRef idx="3">
+            <a:schemeClr val="accent1"/>
+          </a:fillRef>
+          <a:effectRef idx="2">
+            <a:schemeClr val="accent1"/>
+          </a:effectRef>
+          <a:fontRef idx="minor">
+            <a:schemeClr val="lt1"/>
+          </a:fontRef>
+        </p:style>
+        <p:txBody>
+          <a:bodyPr rtlCol="0" anchor="ctr" wrap="none"/>
+          <a:lstStyle/>
+          <a:p>
+            <a:pPr algn="ctr"/>
+            <a:r>
+              <a:rPr sz="1200" b="1">
+                <a:solidFill>
+                  <a:srgbClr val="E6EDF3"/>
+                </a:solidFill>
+                <a:latin typeface="Calibri"/>
+              </a:rPr>
+              <a:t>MOVE ON  →</a:t>
             </a:r>
           </a:p>
         </p:txBody>
@@ -13306,14 +13768,58 @@
                               <p:cond delay="0"/>
                             </p:stCondLst>
                             <p:childTnLst>
+                              <p:set>
+                                <p:cBhvr>
+                                  <p:cTn id="5" dur="1" fill="hold"/>
+                                  <p:tgtEl>
+                                    <p:spTgt spid="42"/>
+                                  </p:tgtEl>
+                                  <p:attrNameLst>
+                                    <p:attrName>style.visibility</p:attrName>
+                                  </p:attrNameLst>
+                                </p:cBhvr>
+                                <p:to>
+                                  <p:strVal val="hidden"/>
+                                </p:to>
+                              </p:set>
                               <p:animEffect transition="out" filter="wipe(left)">
                                 <p:cBhvr>
-                                  <p:cTn id="5" dur="85000" fill="hold"/>
+                                  <p:cTn id="6" dur="85000" fill="hold"/>
                                   <p:tgtEl>
                                     <p:spTgt spid="40"/>
                                   </p:tgtEl>
                                 </p:cBhvr>
                               </p:animEffect>
+                              <p:animEffect transition="in" filter="fade">
+                                <p:cBhvr>
+                                  <p:cTn id="7" dur="400" fill="hold">
+                                    <p:stCondLst>
+                                      <p:cond delay="85000"/>
+                                    </p:stCondLst>
+                                  </p:cTn>
+                                  <p:tgtEl>
+                                    <p:spTgt spid="42"/>
+                                  </p:tgtEl>
+                                </p:cBhvr>
+                              </p:animEffect>
+                              <p:set>
+                                <p:cBhvr>
+                                  <p:cTn id="8" dur="1" fill="hold">
+                                    <p:stCondLst>
+                                      <p:cond delay="85000"/>
+                                    </p:stCondLst>
+                                  </p:cTn>
+                                  <p:tgtEl>
+                                    <p:spTgt spid="42"/>
+                                  </p:tgtEl>
+                                  <p:attrNameLst>
+                                    <p:attrName>style.visibility</p:attrName>
+                                  </p:attrNameLst>
+                                </p:cBhvr>
+                                <p:to>
+                                  <p:strVal val="visible"/>
+                                </p:to>
+                              </p:set>
                             </p:childTnLst>
                           </p:cTn>
                         </p:par>
@@ -15167,7 +15673,61 @@
                 </a:solidFill>
                 <a:latin typeface="Calibri"/>
               </a:rPr>
-              <a:t>Countdown bar starts in Slideshow · does not auto-advance — you click when ready</a:t>
+              <a:t>Countdown starts in Slideshow · red MOVE ON appears when budget ends · does not auto-advance</a:t>
+            </a:r>
+          </a:p>
+        </p:txBody>
+      </p:sp>
+      <p:sp>
+        <p:nvSpPr>
+          <p:cNvPr id="37" name="Rounded Rectangle 36"/>
+          <p:cNvSpPr/>
+          <p:nvPr/>
+        </p:nvSpPr>
+        <p:spPr>
+          <a:xfrm>
+            <a:off x="9189720" y="5614416"/>
+            <a:ext cx="2468880" cy="292608"/>
+          </a:xfrm>
+          <a:prstGeom prst="roundRect">
+            <a:avLst>
+              <a:gd name="adj" fmla="val 20000"/>
+            </a:avLst>
+          </a:prstGeom>
+          <a:solidFill>
+            <a:srgbClr val="F87171"/>
+          </a:solidFill>
+          <a:ln>
+            <a:noFill/>
+          </a:ln>
+        </p:spPr>
+        <p:style>
+          <a:lnRef idx="1">
+            <a:schemeClr val="accent1"/>
+          </a:lnRef>
+          <a:fillRef idx="3">
+            <a:schemeClr val="accent1"/>
+          </a:fillRef>
+          <a:effectRef idx="2">
+            <a:schemeClr val="accent1"/>
+          </a:effectRef>
+          <a:fontRef idx="minor">
+            <a:schemeClr val="lt1"/>
+          </a:fontRef>
+        </p:style>
+        <p:txBody>
+          <a:bodyPr rtlCol="0" anchor="ctr" wrap="none"/>
+          <a:lstStyle/>
+          <a:p>
+            <a:pPr algn="ctr"/>
+            <a:r>
+              <a:rPr sz="1200" b="1">
+                <a:solidFill>
+                  <a:srgbClr val="E6EDF3"/>
+                </a:solidFill>
+                <a:latin typeface="Calibri"/>
+              </a:rPr>
+              <a:t>MOVE ON  →</a:t>
             </a:r>
           </a:p>
         </p:txBody>
@@ -15197,14 +15757,58 @@
                               <p:cond delay="0"/>
                             </p:stCondLst>
                             <p:childTnLst>
+                              <p:set>
+                                <p:cBhvr>
+                                  <p:cTn id="5" dur="1" fill="hold"/>
+                                  <p:tgtEl>
+                                    <p:spTgt spid="37"/>
+                                  </p:tgtEl>
+                                  <p:attrNameLst>
+                                    <p:attrName>style.visibility</p:attrName>
+                                  </p:attrNameLst>
+                                </p:cBhvr>
+                                <p:to>
+                                  <p:strVal val="hidden"/>
+                                </p:to>
+                              </p:set>
                               <p:animEffect transition="out" filter="wipe(left)">
                                 <p:cBhvr>
-                                  <p:cTn id="5" dur="75000" fill="hold"/>
+                                  <p:cTn id="6" dur="75000" fill="hold"/>
                                   <p:tgtEl>
                                     <p:spTgt spid="35"/>
                                   </p:tgtEl>
                                 </p:cBhvr>
                               </p:animEffect>
+                              <p:animEffect transition="in" filter="fade">
+                                <p:cBhvr>
+                                  <p:cTn id="7" dur="400" fill="hold">
+                                    <p:stCondLst>
+                                      <p:cond delay="75000"/>
+                                    </p:stCondLst>
+                                  </p:cTn>
+                                  <p:tgtEl>
+                                    <p:spTgt spid="37"/>
+                                  </p:tgtEl>
+                                </p:cBhvr>
+                              </p:animEffect>
+                              <p:set>
+                                <p:cBhvr>
+                                  <p:cTn id="8" dur="1" fill="hold">
+                                    <p:stCondLst>
+                                      <p:cond delay="75000"/>
+                                    </p:stCondLst>
+                                  </p:cTn>
+                                  <p:tgtEl>
+                                    <p:spTgt spid="37"/>
+                                  </p:tgtEl>
+                                  <p:attrNameLst>
+                                    <p:attrName>style.visibility</p:attrName>
+                                  </p:attrNameLst>
+                                </p:cBhvr>
+                                <p:to>
+                                  <p:strVal val="visible"/>
+                                </p:to>
+                              </p:set>
                             </p:childTnLst>
                           </p:cTn>
                         </p:par>
@@ -17254,7 +17858,61 @@
                 </a:solidFill>
                 <a:latin typeface="Calibri"/>
               </a:rPr>
-              <a:t>Countdown bar starts in Slideshow · does not auto-advance — you click when ready</a:t>
+              <a:t>Countdown starts in Slideshow · red MOVE ON appears when budget ends · does not auto-advance</a:t>
+            </a:r>
+          </a:p>
+        </p:txBody>
+      </p:sp>
+      <p:sp>
+        <p:nvSpPr>
+          <p:cNvPr id="45" name="Rounded Rectangle 44"/>
+          <p:cNvSpPr/>
+          <p:nvPr/>
+        </p:nvSpPr>
+        <p:spPr>
+          <a:xfrm>
+            <a:off x="9189720" y="5614416"/>
+            <a:ext cx="2468880" cy="292608"/>
+          </a:xfrm>
+          <a:prstGeom prst="roundRect">
+            <a:avLst>
+              <a:gd name="adj" fmla="val 20000"/>
+            </a:avLst>
+          </a:prstGeom>
+          <a:solidFill>
+            <a:srgbClr val="F87171"/>
+          </a:solidFill>
+          <a:ln>
+            <a:noFill/>
+          </a:ln>
+        </p:spPr>
+        <p:style>
+          <a:lnRef idx="1">
+            <a:schemeClr val="accent1"/>
+          </a:lnRef>
+          <a:fillRef idx="3">
+            <a:schemeClr val="accent1"/>
+          </a:fillRef>
+          <a:effectRef idx="2">
+            <a:schemeClr val="accent1"/>
+          </a:effectRef>
+          <a:fontRef idx="minor">
+            <a:schemeClr val="lt1"/>
+          </a:fontRef>
+        </p:style>
+        <p:txBody>
+          <a:bodyPr rtlCol="0" anchor="ctr" wrap="none"/>
+          <a:lstStyle/>
+          <a:p>
+            <a:pPr algn="ctr"/>
+            <a:r>
+              <a:rPr sz="1200" b="1">
+                <a:solidFill>
+                  <a:srgbClr val="E6EDF3"/>
+                </a:solidFill>
+                <a:latin typeface="Calibri"/>
+              </a:rPr>
+              <a:t>MOVE ON  →</a:t>
             </a:r>
           </a:p>
         </p:txBody>
@@ -17284,14 +17942,58 @@
                               <p:cond delay="0"/>
                             </p:stCondLst>
                             <p:childTnLst>
+                              <p:set>
+                                <p:cBhvr>
+                                  <p:cTn id="5" dur="1" fill="hold"/>
+                                  <p:tgtEl>
+                                    <p:spTgt spid="45"/>
+                                  </p:tgtEl>
+                                  <p:attrNameLst>
+                                    <p:attrName>style.visibility</p:attrName>
+                                  </p:attrNameLst>
+                                </p:cBhvr>
+                                <p:to>
+                                  <p:strVal val="hidden"/>
+                                </p:to>
+                              </p:set>
                               <p:animEffect transition="out" filter="wipe(left)">
                                 <p:cBhvr>
-                                  <p:cTn id="5" dur="65000" fill="hold"/>
+                                  <p:cTn id="6" dur="65000" fill="hold"/>
                                   <p:tgtEl>
                                     <p:spTgt spid="43"/>
                                   </p:tgtEl>
                                 </p:cBhvr>
                               </p:animEffect>
+                              <p:animEffect transition="in" filter="fade">
+                                <p:cBhvr>
+                                  <p:cTn id="7" dur="400" fill="hold">
+                                    <p:stCondLst>
+                                      <p:cond delay="65000"/>
+                                    </p:stCondLst>
+                                  </p:cTn>
+                                  <p:tgtEl>
+                                    <p:spTgt spid="45"/>
+                                  </p:tgtEl>
+                                </p:cBhvr>
+                              </p:animEffect>
+                              <p:set>
+                                <p:cBhvr>
+                                  <p:cTn id="8" dur="1" fill="hold">
+                                    <p:stCondLst>
+                                      <p:cond delay="65000"/>
+                                    </p:stCondLst>
+                                  </p:cTn>
+                                  <p:tgtEl>
+                                    <p:spTgt spid="45"/>
+                                  </p:tgtEl>
+                                  <p:attrNameLst>
+                                    <p:attrName>style.visibility</p:attrName>
+                                  </p:attrNameLst>
+                                </p:cBhvr>
+                                <p:to>
+                                  <p:strVal val="visible"/>
+                                </p:to>
+                              </p:set>
                             </p:childTnLst>
                           </p:cTn>
                         </p:par>
@@ -19008,7 +19710,61 @@
                 </a:solidFill>
                 <a:latin typeface="Calibri"/>
               </a:rPr>
-              <a:t>Countdown bar starts in Slideshow · does not auto-advance — you click when ready</a:t>
+              <a:t>Countdown starts in Slideshow · red MOVE ON appears when budget ends · does not auto-advance</a:t>
+            </a:r>
+          </a:p>
+        </p:txBody>
+      </p:sp>
+      <p:sp>
+        <p:nvSpPr>
+          <p:cNvPr id="38" name="Rounded Rectangle 37"/>
+          <p:cNvSpPr/>
+          <p:nvPr/>
+        </p:nvSpPr>
+        <p:spPr>
+          <a:xfrm>
+            <a:off x="9189720" y="5614416"/>
+            <a:ext cx="2468880" cy="292608"/>
+          </a:xfrm>
+          <a:prstGeom prst="roundRect">
+            <a:avLst>
+              <a:gd name="adj" fmla="val 20000"/>
+            </a:avLst>
+          </a:prstGeom>
+          <a:solidFill>
+            <a:srgbClr val="F87171"/>
+          </a:solidFill>
+          <a:ln>
+            <a:noFill/>
+          </a:ln>
+        </p:spPr>
+        <p:style>
+          <a:lnRef idx="1">
+            <a:schemeClr val="accent1"/>
+          </a:lnRef>
+          <a:fillRef idx="3">
+            <a:schemeClr val="accent1"/>
+          </a:fillRef>
+          <a:effectRef idx="2">
+            <a:schemeClr val="accent1"/>
+          </a:effectRef>
+          <a:fontRef idx="minor">
+            <a:schemeClr val="lt1"/>
+          </a:fontRef>
+        </p:style>
+        <p:txBody>
+          <a:bodyPr rtlCol="0" anchor="ctr" wrap="none"/>
+          <a:lstStyle/>
+          <a:p>
+            <a:pPr algn="ctr"/>
+            <a:r>
+              <a:rPr sz="1200" b="1">
+                <a:solidFill>
+                  <a:srgbClr val="E6EDF3"/>
+                </a:solidFill>
+                <a:latin typeface="Calibri"/>
+              </a:rPr>
+              <a:t>MOVE ON  →</a:t>
             </a:r>
           </a:p>
         </p:txBody>
@@ -19038,14 +19794,58 @@
                               <p:cond delay="0"/>
                             </p:stCondLst>
                             <p:childTnLst>
+                              <p:set>
+                                <p:cBhvr>
+                                  <p:cTn id="5" dur="1" fill="hold"/>
+                                  <p:tgtEl>
+                                    <p:spTgt spid="38"/>
+                                  </p:tgtEl>
+                                  <p:attrNameLst>
+                                    <p:attrName>style.visibility</p:attrName>
+                                  </p:attrNameLst>
+                                </p:cBhvr>
+                                <p:to>
+                                  <p:strVal val="hidden"/>
+                                </p:to>
+                              </p:set>
                               <p:animEffect transition="out" filter="wipe(left)">
                                 <p:cBhvr>
-                                  <p:cTn id="5" dur="65000" fill="hold"/>
+                                  <p:cTn id="6" dur="65000" fill="hold"/>
                                   <p:tgtEl>
                                     <p:spTgt spid="36"/>
                                   </p:tgtEl>
                                 </p:cBhvr>
                               </p:animEffect>
+                              <p:animEffect transition="in" filter="fade">
+                                <p:cBhvr>
+                                  <p:cTn id="7" dur="400" fill="hold">
+                                    <p:stCondLst>
+                                      <p:cond delay="65000"/>
+                                    </p:stCondLst>
+                                  </p:cTn>
+                                  <p:tgtEl>
+                                    <p:spTgt spid="38"/>
+                                  </p:tgtEl>
+                                </p:cBhvr>
+                              </p:animEffect>
+                              <p:set>
+                                <p:cBhvr>
+                                  <p:cTn id="8" dur="1" fill="hold">
+                                    <p:stCondLst>
+                                      <p:cond delay="65000"/>
+                                    </p:stCondLst>
+                                  </p:cTn>
+                                  <p:tgtEl>
+                                    <p:spTgt spid="38"/>
+                                  </p:tgtEl>
+                                  <p:attrNameLst>
+                                    <p:attrName>style.visibility</p:attrName>
+                                  </p:attrNameLst>
+                                </p:cBhvr>
+                                <p:to>
+                                  <p:strVal val="visible"/>
+                                </p:to>
+                              </p:set>
                             </p:childTnLst>
                           </p:cTn>
                         </p:par>

</xml_diff>

<commit_message>
Restore CS1 opening to data-led prior framing
Bring slide 1 back to Net sales / gross margin / delivery satisfaction plus
executive framing and storyline, without inventing SPM job-profile cards.
Keep timers off and retain commercial refinements (top 10 accounts,
discount-as-trade) inside the case narrative.

Co-authored-by: gauravch86 <gauravch86@users.noreply.github.com>
</commit_message>
<xml_diff>
--- a/case-study-1-reposition-executive.pptx
+++ b/case-study-1-reposition-executive.pptx
@@ -515,22 +515,22 @@
           <a:p/>
           <a:p>
             <a:r>
-              <a:t>Open on the dual SPM mandate: new revenue AND margin/EBIT — not “fix delivery” alone.</a:t>
-            </a:r>
-          </a:p>
-          <a:p>
-            <a:r>
-              <a:t>Paradox: NPS strong, sales flat, GM illustratively 28%→22–24%.</a:t>
-            </a:r>
-          </a:p>
-          <a:p>
-            <a:r>
-              <a:t>Preview the storyline as answering the case asks in order: package/price → guardrails/invest → align/metrics → ask.</a:t>
-            </a:r>
-          </a:p>
-          <a:p>
-            <a:r>
-              <a:t>Discount thesis in one line: discount to protect topline only when we trade for scope/term/investment.</a:t>
+              <a:t>Paradox first: delivery satisfaction strong, sales flat, margin illustratively 28% → 22–24%.</a:t>
+            </a:r>
+          </a:p>
+          <a:p>
+            <a:r>
+              <a:t>Commercial problem, not delivery. Storyline is sequential — one stage per slide.</a:t>
+            </a:r>
+          </a:p>
+          <a:p>
+            <a:r>
+              <a:t>In framing: we will fix packaging/pricing so net sales and gross margin recover together;</a:t>
+            </a:r>
+          </a:p>
+          <a:p>
+            <a:r>
+              <a:t>discounts are a trade for scope/term/attach — not free bleed.</a:t>
             </a:r>
           </a:p>
         </p:txBody>
@@ -1036,7 +1036,7 @@
           </a:p>
           <a:p>
             <a:r>
-              <a:t>Scoreboard splits NEW REVENUE vs MARGIN/EBIT so interviewers hear the dual SPM mandate.</a:t>
+              <a:t>Scoreboard tracks net sales and gross margin recovery plus commercial hygiene (tier adoption, discount trades).</a:t>
             </a:r>
           </a:p>
           <a:p>
@@ -1117,23 +1117,18 @@
           <a:p/>
           <a:p>
             <a:r>
-              <a:t>Restate dual outcome: new revenue + margin recovery.</a:t>
-            </a:r>
-          </a:p>
-          <a:p>
-            <a:r>
-              <a:t>Point at “case asks covered” — packaging, guardrails, invest, align, metrics.</a:t>
-            </a:r>
-          </a:p>
-          <a:p>
-            <a:r>
-              <a:t>Four asks. Hand to questions.</a:t>
+              <a:t>Restate call. Point at the four-step thought process — that is the interview signal.</a:t>
+            </a:r>
+          </a:p>
+          <a:p>
+            <a:r>
+              <a:t>Then four asks. Hand to questions.</a:t>
             </a:r>
           </a:p>
           <a:p/>
           <a:p>
             <a:r>
-              <a:t>Q&amp;A: discount philosophy · sunset · deal size dip · Finance rev-rec · optional multi-vendor pack.</a:t>
+              <a:t>Q&amp;A: discount-as-trade · sunset · deal size dip · Finance rev-rec · optional multi-vendor pack.</a:t>
             </a:r>
           </a:p>
         </p:txBody>
@@ -4216,7 +4211,7 @@
                 </a:solidFill>
                 <a:latin typeface="Calibri"/>
               </a:rPr>
-              <a:t>STRATEGIC PRODUCT MANAGER  ·  CASE STUDY 1  ·  DUAL MANDATE: NEW REVENUE + MARGIN</a:t>
+              <a:t>STRATEGIC PRODUCT MANAGER  ·  CASE STUDY 1  ·  10-MINUTE COMMERCIAL BRIEF</a:t>
             </a:r>
           </a:p>
         </p:txBody>
@@ -4255,7 +4250,7 @@
                 </a:solidFill>
                 <a:latin typeface="Calibri"/>
               </a:rPr>
-              <a:t>Grow topline. Protect EBIT. Reposition the offering.</a:t>
+              <a:t>Reposition an underperforming portfolio offering</a:t>
             </a:r>
           </a:p>
         </p:txBody>
@@ -4294,7 +4289,7 @@
                 </a:solidFill>
                 <a:latin typeface="Calibri"/>
               </a:rPr>
-              <a:t>Application Managed Services: strong delivery, but commercially stuck — flat net sales, gross margin 28% → 22–24%, Sales cannot sell value, regions discount without trading scope.</a:t>
+              <a:t>Application Managed Services: strong technical delivery, but commercially stuck — flat net sales, declining gross margin, Sales cannot articulate value, inconsistent regional pricing.</a:t>
             </a:r>
           </a:p>
         </p:txBody>
@@ -4307,8 +4302,8 @@
         </p:nvSpPr>
         <p:spPr>
           <a:xfrm>
-            <a:off x="502920" y="1737360"/>
-            <a:ext cx="3566160" cy="1234440"/>
+            <a:off x="502920" y="1783080"/>
+            <a:ext cx="3566160" cy="1325880"/>
           </a:xfrm>
           <a:prstGeom prst="roundRect">
             <a:avLst>
@@ -4352,8 +4347,8 @@
         </p:nvSpPr>
         <p:spPr>
           <a:xfrm>
-            <a:off x="640080" y="1847088"/>
-            <a:ext cx="3291840" cy="1051560"/>
+            <a:off x="640080" y="1892808"/>
+            <a:ext cx="3291840" cy="1143000"/>
           </a:xfrm>
           <a:prstGeom prst="rect">
             <a:avLst/>
@@ -4378,7 +4373,7 @@
                 </a:solidFill>
                 <a:latin typeface="Calibri"/>
               </a:rPr>
-              <a:t>SPM OWNS — NEW SALES</a:t>
+              <a:t>NET SALES (2 YEARS)</a:t>
             </a:r>
           </a:p>
           <a:p>
@@ -4390,11 +4385,11 @@
             <a:r>
               <a:rPr sz="2200" b="1">
                 <a:solidFill>
-                  <a:srgbClr val="58A6FF"/>
-                </a:solidFill>
-                <a:latin typeface="Calibri"/>
-              </a:rPr>
-              <a:t>Topline</a:t>
+                  <a:srgbClr val="8B9CB3"/>
+                </a:solidFill>
+                <a:latin typeface="Calibri"/>
+              </a:rPr>
+              <a:t>Flat</a:t>
             </a:r>
           </a:p>
           <a:p>
@@ -4410,7 +4405,7 @@
                 </a:solidFill>
                 <a:latin typeface="Calibri"/>
               </a:rPr>
-              <a:t>Net sales · attach · expansion</a:t>
+              <a:t>Weak conversion · little attach</a:t>
             </a:r>
           </a:p>
         </p:txBody>
@@ -4423,8 +4418,8 @@
         </p:nvSpPr>
         <p:spPr>
           <a:xfrm>
-            <a:off x="4297680" y="1737360"/>
-            <a:ext cx="3566160" cy="1234440"/>
+            <a:off x="4297680" y="1783080"/>
+            <a:ext cx="3566160" cy="1325880"/>
           </a:xfrm>
           <a:prstGeom prst="roundRect">
             <a:avLst>
@@ -4468,8 +4463,8 @@
         </p:nvSpPr>
         <p:spPr>
           <a:xfrm>
-            <a:off x="4434840" y="1847088"/>
-            <a:ext cx="3291840" cy="1051560"/>
+            <a:off x="4434840" y="1892808"/>
+            <a:ext cx="3291840" cy="1143000"/>
           </a:xfrm>
           <a:prstGeom prst="rect">
             <a:avLst/>
@@ -4494,7 +4489,7 @@
                 </a:solidFill>
                 <a:latin typeface="Calibri"/>
               </a:rPr>
-              <a:t>SPM OWNS — PROFITABILITY</a:t>
+              <a:t>GROSS MARGIN (ILLUSTRATIVE)</a:t>
             </a:r>
           </a:p>
           <a:p>
@@ -4506,11 +4501,11 @@
             <a:r>
               <a:rPr sz="2200" b="1">
                 <a:solidFill>
-                  <a:srgbClr val="D4A853"/>
-                </a:solidFill>
-                <a:latin typeface="Calibri"/>
-              </a:rPr>
-              <a:t>Margin / EBIT</a:t>
+                  <a:srgbClr val="F87171"/>
+                </a:solidFill>
+                <a:latin typeface="Calibri"/>
+              </a:rPr>
+              <a:t>28% → 22–24%</a:t>
             </a:r>
           </a:p>
           <a:p>
@@ -4526,7 +4521,7 @@
                 </a:solidFill>
                 <a:latin typeface="Calibri"/>
               </a:rPr>
-              <a:t>Gross margin · deal quality</a:t>
+              <a:t>−4 to −6 percentage points over 2 years</a:t>
             </a:r>
           </a:p>
         </p:txBody>
@@ -4539,8 +4534,8 @@
         </p:nvSpPr>
         <p:spPr>
           <a:xfrm>
-            <a:off x="8092440" y="1737360"/>
-            <a:ext cx="3566160" cy="1234440"/>
+            <a:off x="8092440" y="1783080"/>
+            <a:ext cx="3566160" cy="1325880"/>
           </a:xfrm>
           <a:prstGeom prst="roundRect">
             <a:avLst>
@@ -4584,8 +4579,8 @@
         </p:nvSpPr>
         <p:spPr>
           <a:xfrm>
-            <a:off x="8229600" y="1847088"/>
-            <a:ext cx="3291840" cy="1051560"/>
+            <a:off x="8229600" y="1892808"/>
+            <a:ext cx="3291840" cy="1143000"/>
           </a:xfrm>
           <a:prstGeom prst="rect">
             <a:avLst/>
@@ -4610,7 +4605,7 @@
                 </a:solidFill>
                 <a:latin typeface="Calibri"/>
               </a:rPr>
-              <a:t>TODAY’S PARADOX</a:t>
+              <a:t>DELIVERY SATISFACTION</a:t>
             </a:r>
           </a:p>
           <a:p>
@@ -4622,11 +4617,11 @@
             <a:r>
               <a:rPr sz="2200" b="1">
                 <a:solidFill>
-                  <a:srgbClr val="F87171"/>
-                </a:solidFill>
-                <a:latin typeface="Calibri"/>
-              </a:rPr>
-              <a:t>Strong NPS</a:t>
+                  <a:srgbClr val="3FB950"/>
+                </a:solidFill>
+                <a:latin typeface="Calibri"/>
+              </a:rPr>
+              <a:t>Strong</a:t>
             </a:r>
           </a:p>
           <a:p>
@@ -4642,7 +4637,7 @@
                 </a:solidFill>
                 <a:latin typeface="Calibri"/>
               </a:rPr>
-              <a:t>Flat sales · eroding GM</a:t>
+              <a:t>Execution is not the failure mode</a:t>
             </a:r>
           </a:p>
         </p:txBody>
@@ -4655,8 +4650,8 @@
         </p:nvSpPr>
         <p:spPr>
           <a:xfrm>
-            <a:off x="502920" y="3154680"/>
-            <a:ext cx="11155680" cy="1097280"/>
+            <a:off x="502920" y="3337560"/>
+            <a:ext cx="11155680" cy="1051560"/>
           </a:xfrm>
           <a:prstGeom prst="roundRect">
             <a:avLst>
@@ -4700,8 +4695,8 @@
         </p:nvSpPr>
         <p:spPr>
           <a:xfrm>
-            <a:off x="685800" y="3273552"/>
-            <a:ext cx="10789920" cy="868680"/>
+            <a:off x="685800" y="3474720"/>
+            <a:ext cx="10789920" cy="822960"/>
           </a:xfrm>
           <a:prstGeom prst="rect">
             <a:avLst/>
@@ -4726,7 +4721,7 @@
                 </a:solidFill>
                 <a:latin typeface="Calibri"/>
               </a:rPr>
-              <a:t>THE JOB IN THIS ROLE</a:t>
+              <a:t>EXECUTIVE FRAMING</a:t>
             </a:r>
           </a:p>
           <a:p>
@@ -4742,7 +4737,7 @@
                 </a:solidFill>
                 <a:latin typeface="Calibri"/>
               </a:rPr>
-              <a:t>Strategic Product Manager is accountable for both new revenue (new sales / topline) and profitability (gross margin / EBIT contribution). Discounts are a growth tool — used to sustain revenue only when traded for additional scope, term, or customer investment that increases total value — never free margin bleed.</a:t>
+              <a:t>Commercial / go-to-market problem — not a delivery turnaround. Sold as headcount; buyers purchase outcomes, cost predictability, and risk reduction. Plan must restore net sales and gross margin together — discounts only when traded for scope, term, or attach. Leadership asks: evolve, reposition, or sunset.</a:t>
             </a:r>
           </a:p>
         </p:txBody>
@@ -4755,8 +4750,8 @@
         </p:nvSpPr>
         <p:spPr>
           <a:xfrm>
-            <a:off x="502920" y="4434840"/>
-            <a:ext cx="11155680" cy="1600200"/>
+            <a:off x="502920" y="4617720"/>
+            <a:ext cx="11155680" cy="1417320"/>
           </a:xfrm>
           <a:prstGeom prst="rect">
             <a:avLst/>
@@ -4771,7 +4766,7 @@
           <a:p>
             <a:pPr algn="l">
               <a:spcAft>
-                <a:spcPts val="600"/>
+                <a:spcPts val="800"/>
               </a:spcAft>
             </a:pPr>
             <a:r>
@@ -4781,13 +4776,13 @@
                 </a:solidFill>
                 <a:latin typeface="Calibri"/>
               </a:rPr>
-              <a:t>WHAT LEADERSHIP GETS IN 10 MINUTES</a:t>
+              <a:t>STORYLINE  ·  ONE STAGE PER SLIDE  ·  10 MIN + 5 MIN QUESTIONS</a:t>
             </a:r>
           </a:p>
           <a:p>
             <a:pPr algn="l">
               <a:spcAft>
-                <a:spcPts val="400"/>
+                <a:spcPts val="300"/>
               </a:spcAft>
             </a:pPr>
             <a:r>
@@ -4797,13 +4792,13 @@
                 </a:solidFill>
                 <a:latin typeface="Calibri"/>
               </a:rPr>
-              <a:t>1  Diagnose  →  2  Findings  →  3  Reposition decision</a:t>
+              <a:t>1  Five-lens diagnosis</a:t>
             </a:r>
           </a:p>
           <a:p>
             <a:pPr algn="l">
               <a:spcAft>
-                <a:spcPts val="400"/>
+                <a:spcPts val="300"/>
               </a:spcAft>
             </a:pPr>
             <a:r>
@@ -4813,12 +4808,28 @@
                 </a:solidFill>
                 <a:latin typeface="Calibri"/>
               </a:rPr>
-              <a:t>4  Revised packaging &amp; value proposition   ·   5  Guardrails + investment ROI sequence</a:t>
+              <a:t>2  Illustrative findings (what the data would show)</a:t>
             </a:r>
           </a:p>
           <a:p>
             <a:pPr algn="l">
               <a:spcAft>
+                <a:spcPts val="300"/>
+              </a:spcAft>
+            </a:pPr>
+            <a:r>
+              <a:rPr sz="1400" b="1">
+                <a:solidFill>
+                  <a:srgbClr val="E6EDF3"/>
+                </a:solidFill>
+                <a:latin typeface="Calibri"/>
+              </a:rPr>
+              <a:t>3  Decision framework → Reposition</a:t>
+            </a:r>
+          </a:p>
+          <a:p>
+            <a:pPr algn="l">
+              <a:spcAft>
                 <a:spcPts val="0"/>
               </a:spcAft>
             </a:pPr>
@@ -4829,7 +4840,7 @@
                 </a:solidFill>
                 <a:latin typeface="Calibri"/>
               </a:rPr>
-              <a:t>6  Sales · Marketing · Finance · regional enablement + metrics feedback loop   ·   7  Asks</a:t>
+              <a:t>4  Package &amp; price   ·   5  Guardrails &amp; invest   ·   6  Align &amp; measure   ·   7  Ask</a:t>
             </a:r>
           </a:p>
         </p:txBody>
@@ -8586,7 +8597,7 @@
                 </a:solidFill>
                 <a:latin typeface="Calibri"/>
               </a:rPr>
-              <a:t>Decision → Reposition (grow sales + restore margin)</a:t>
+              <a:t>Decision framework → Reposition</a:t>
             </a:r>
           </a:p>
         </p:txBody>
@@ -8752,7 +8763,7 @@
                 </a:solidFill>
                 <a:latin typeface="Calibri"/>
               </a:rPr>
-              <a:t>Change what Sales sells and how Deal Desk prices — tooling alone will not fix either P&amp;L lever</a:t>
+              <a:t>Change what Sales sells and how Deal Desk prices — tooling alone will not fix conversion or margin</a:t>
             </a:r>
           </a:p>
         </p:txBody>
@@ -14211,7 +14222,7 @@
                 </a:solidFill>
                 <a:latin typeface="Calibri"/>
               </a:rPr>
-              <a:t>12-MONTH SCOREBOARD  ·  BOTH SPM LEVERS  ·  Quarterly Pricing Council</a:t>
+              <a:t>12-MONTH SCOREBOARD  ·  Quarterly Pricing Council</a:t>
             </a:r>
           </a:p>
           <a:p>
@@ -14227,7 +14238,7 @@
                 </a:solidFill>
                 <a:latin typeface="Calibri"/>
               </a:rPr>
-              <a:t>NEW REVENUE: Net sales Flat → +8–12%   ·   Tier adoption ≥80%   ·   Wins on value/TCO ≥40%   ·   Renewal step-up ≥25%</a:t>
+              <a:t>Net sales Flat → +8–12%   ·   Gross margin recover 3–4 pts (e.g. toward 25–27%)   ·   Tier adoption ≥80%</a:t>
             </a:r>
           </a:p>
           <a:p>
@@ -14243,7 +14254,7 @@
                 </a:solidFill>
                 <a:latin typeface="Calibri"/>
               </a:rPr>
-              <a:t>MARGIN / EBIT: Recover 3–4 GM pts (e.g. toward 25–27%)   ·   Price variance &lt;15%   ·   ≥70% discounts have documented scope/term trade</a:t>
+              <a:t>Price variance &lt;15%   ·   Wins on value/TCO ≥40%   ·   Renewal step-up ≥25%   ·   ≥70% discounts have a documented scope/term trade</a:t>
             </a:r>
           </a:p>
           <a:p>
@@ -15107,7 +15118,7 @@
                 </a:solidFill>
                 <a:latin typeface="Calibri"/>
               </a:rPr>
-              <a:t>Reposition. Win new revenue. Restore margin.</a:t>
+              <a:t>Reposition. Land with tiers. Expand when value is proven.</a:t>
             </a:r>
           </a:p>
         </p:txBody>
@@ -15334,7 +15345,7 @@
                 </a:solidFill>
                 <a:latin typeface="Calibri"/>
               </a:rPr>
-              <a:t>Reposition Application Managed Services as Outcome-Tiered Application Operations (Stabilize → Optimize → Transform). Do not sunset. Do not evolve tooling without fixing the sellable unit. Use discounts to sustain topline only when traded for scope, term, or investment. Fund Deal Desk guardrails in Q1; pilot in two regions; govern with a quarterly Pricing Council.</a:t>
+              <a:t>Reposition Application Managed Services as Outcome-Tiered Application Operations (Stabilize → Optimize → Transform). Do not sunset. Do not evolve tooling without fixing the sellable unit. Use discounts to sustain net sales only when traded for scope, term, or attach. Fund Deal Desk guardrails in Q1; pilot in two regions; govern with a quarterly Pricing Council.</a:t>
             </a:r>
           </a:p>
         </p:txBody>
@@ -15418,7 +15429,7 @@
                 </a:solidFill>
                 <a:latin typeface="Calibri"/>
               </a:rPr>
-              <a:t>CASE ASKS — COVERED</a:t>
+              <a:t>THOUGHT PROCESS THEY SHOULD HEAR</a:t>
             </a:r>
           </a:p>
           <a:p>
@@ -15434,7 +15445,7 @@
                 </a:solidFill>
                 <a:latin typeface="Calibri"/>
               </a:rPr>
-              <a:t>✓ Packaging · pricing · value proposition</a:t>
+              <a:t>1 Diagnose with five lenses</a:t>
             </a:r>
           </a:p>
           <a:p>
@@ -15450,7 +15461,7 @@
                 </a:solidFill>
                 <a:latin typeface="Calibri"/>
               </a:rPr>
-              <a:t>✓ Commercial / Deal Desk guardrails</a:t>
+              <a:t>2 Synthesize commercial root causes</a:t>
             </a:r>
           </a:p>
           <a:p>
@@ -15466,7 +15477,7 @@
                 </a:solidFill>
                 <a:latin typeface="Calibri"/>
               </a:rPr>
-              <a:t>✓ Invest sequence + what to stop</a:t>
+              <a:t>3 Decide with trade-offs → Reposition</a:t>
             </a:r>
           </a:p>
           <a:p>
@@ -15482,23 +15493,7 @@
                 </a:solidFill>
                 <a:latin typeface="Calibri"/>
               </a:rPr>
-              <a:t>✓ Sales · Marketing · Finance · regions</a:t>
-            </a:r>
-          </a:p>
-          <a:p>
-            <a:pPr algn="l">
-              <a:spcAft>
-                <a:spcPts val="500"/>
-              </a:spcAft>
-            </a:pPr>
-            <a:r>
-              <a:rPr sz="1300" b="0">
-                <a:solidFill>
-                  <a:srgbClr val="E6EDF3"/>
-                </a:solidFill>
-                <a:latin typeface="Calibri"/>
-              </a:rPr>
-              <a:t>✓ Metrics + Pricing Council feedback loop</a:t>
+              <a:t>4 Package / guardrail / enable / measure</a:t>
             </a:r>
           </a:p>
         </p:txBody>
@@ -15630,7 +15625,7 @@
                 </a:solidFill>
                 <a:latin typeface="Calibri"/>
               </a:rPr>
-              <a:t>▸  Authorize two regional pilots (new sales)</a:t>
+              <a:t>▸  Authorize two regional pilots</a:t>
             </a:r>
           </a:p>
           <a:p>
@@ -15646,7 +15641,7 @@
                 </a:solidFill>
                 <a:latin typeface="Calibri"/>
               </a:rPr>
-              <a:t>▸  Name Product owner + monthly steering on sales + GM</a:t>
+              <a:t>▸  Name Product owner + monthly steering</a:t>
             </a:r>
           </a:p>
         </p:txBody>

</xml_diff>

<commit_message>
Align case studies to Autonomize, one GM ladder, safer proof language
Reconcile CS1 HTML/PPTX on Stabilize→Optimize→Autonomize with a single
22/26/28% floor GM ladder; genericize named clients and precise $ / FTE in
case-study leave-behinds and CS2 decks; thread subscription, GenAI / AI Deal
Desk, and multivendor MS themes; mark HTML as Q&A depth only.

Co-authored-by: gauravch86 <gauravch86@users.noreply.github.com>
</commit_message>
<xml_diff>
--- a/case-study-1-reposition-executive.pptx
+++ b/case-study-1-reposition-executive.pptx
@@ -864,7 +864,7 @@
           </a:p>
           <a:p>
             <a:r>
-              <a:t>Ladder: Stabilize lands new logos → Optimize expands → Transform deepens.</a:t>
+              <a:t>Ladder: Stabilize lands new logos → Optimize expands → Autonomize deepens.</a:t>
             </a:r>
           </a:p>
           <a:p>
@@ -945,12 +945,12 @@
           <a:p/>
           <a:p>
             <a:r>
-              <a:t>This slide answers: commercial guardrails/pricing guidelines AND investment prioritization.</a:t>
-            </a:r>
-          </a:p>
-          <a:p>
-            <a:r>
-              <a:t>Discount rule to verbalize: discount protects topline only when negotiated for more scope, longer term, or attach — increasing total contracted value / investment, not giving margin away.</a:t>
+              <a:t>Hit only 2–3 numbers verbally (floor GM ladder; discount=trade; fund Q1 Deal Desk). Rest is backup.</a:t>
+            </a:r>
+          </a:p>
+          <a:p>
+            <a:r>
+              <a:t>Why not just cut price? One line on the slide. AI Deal Desk assist = commercializing AI intelligence without removing human approval.</a:t>
             </a:r>
           </a:p>
           <a:p>
@@ -1125,10 +1125,30 @@
               <a:t>Then four asks. Hand to questions.</a:t>
             </a:r>
           </a:p>
+          <a:p>
+            <a:r>
+              <a:t>Bridge: “This is the kind of trade-off conversation I’d bring to this role.”</a:t>
+            </a:r>
+          </a:p>
+          <a:p>
+            <a:r>
+              <a:t>HTML is leave-behind depth — not the live walkthrough.</a:t>
+            </a:r>
+          </a:p>
           <a:p/>
           <a:p>
             <a:r>
-              <a:t>Q&amp;A: discount-as-trade · sunset · deal size dip · Finance rev-rec · optional multi-vendor pack.</a:t>
+              <a:t>Q&amp;A:</a:t>
+            </a:r>
+          </a:p>
+          <a:p>
+            <a:r>
+              <a:t>• Why not just cut price? Free discount buys volume that destroys GM and trains the market — we trade discount for scope/term/attach.</a:t>
+            </a:r>
+          </a:p>
+          <a:p>
+            <a:r>
+              <a:t>• Sunset / deal size dip / Finance rev-rec / optional multi-vendor pack.</a:t>
             </a:r>
           </a:p>
         </p:txBody>
@@ -9220,7 +9240,7 @@
                 </a:solidFill>
                 <a:latin typeface="Calibri"/>
               </a:rPr>
-              <a:t>•  Stabilize → Optimize → Transform</a:t>
+              <a:t>•  Stabilize → Optimize → Autonomize</a:t>
             </a:r>
           </a:p>
           <a:p>
@@ -10593,7 +10613,7 @@
                 </a:solidFill>
                 <a:latin typeface="Calibri"/>
               </a:rPr>
-              <a:t>•  + Monitoring / automation packs</a:t>
+              <a:t>•  + Monitoring / GenAI SOP packs</a:t>
             </a:r>
           </a:p>
           <a:p>
@@ -10609,7 +10629,7 @@
                 </a:solidFill>
                 <a:latin typeface="Calibri"/>
               </a:rPr>
-              <a:t>•  Outcome-band vs service levels</a:t>
+              <a:t>•  Subscription / outcome-band pricing</a:t>
             </a:r>
           </a:p>
           <a:p>
@@ -10768,7 +10788,7 @@
                 </a:solidFill>
                 <a:latin typeface="Calibri"/>
               </a:rPr>
-              <a:t>TRANSFORM</a:t>
+              <a:t>AUTONOMIZE</a:t>
             </a:r>
           </a:p>
           <a:p>
@@ -10784,7 +10804,7 @@
                 </a:solidFill>
                 <a:latin typeface="Calibri"/>
               </a:rPr>
-              <a:t>Deepen — operating uplift</a:t>
+              <a:t>Deepen — closed-loop uplift</a:t>
             </a:r>
           </a:p>
           <a:p>
@@ -10800,7 +10820,7 @@
                 </a:solidFill>
                 <a:latin typeface="Calibri"/>
               </a:rPr>
-              <a:t>•  + Continuous improvement</a:t>
+              <a:t>•  + Continuous improvement / self-heal</a:t>
             </a:r>
           </a:p>
           <a:p>
@@ -10816,7 +10836,7 @@
                 </a:solidFill>
                 <a:latin typeface="Calibri"/>
               </a:rPr>
-              <a:t>•  Milestone elements (Finance OK)</a:t>
+              <a:t>•  Value-/subscription + milestones</a:t>
             </a:r>
           </a:p>
           <a:p>
@@ -10832,7 +10852,7 @@
                 </a:solidFill>
                 <a:latin typeface="Calibri"/>
               </a:rPr>
-              <a:t>•  Executive scorecard</a:t>
+              <a:t>•  Executive scorecard (Finance OK)</a:t>
             </a:r>
           </a:p>
           <a:p>
@@ -10948,7 +10968,7 @@
                 </a:solidFill>
                 <a:latin typeface="Calibri"/>
               </a:rPr>
-              <a:t>“Ericsson Application Operations — outcome-tiered managed applications that restore control, improve total cost of ownership where contracted, and give Sales a globally consistent story with Deal Desk pricing discipline that grows revenue without giving margin away.”</a:t>
+              <a:t>“Ericsson Application Operations — outcome-tiered managed applications that restore control, improve total cost of ownership where contracted, and give Sales a globally consistent story with value-/subscription-ready pricing and Deal Desk discipline that grows revenue without giving margin away.”</a:t>
             </a:r>
           </a:p>
         </p:txBody>
@@ -12039,7 +12059,7 @@
                 </a:solidFill>
                 <a:latin typeface="Calibri"/>
               </a:rPr>
-              <a:t>Stabilize ≥22% · Optimize ≥26% · Transform ≥28%</a:t>
+              <a:t>Stabilize ≥22% · Optimize ≥26% · Autonomize ≥28%</a:t>
             </a:r>
           </a:p>
           <a:p>
@@ -12055,7 +12075,7 @@
                 </a:solidFill>
                 <a:latin typeface="Calibri"/>
               </a:rPr>
-              <a:t>Discount = trade, not gift</a:t>
+              <a:t>Discount = trade (not price cut)</a:t>
             </a:r>
           </a:p>
           <a:p>
@@ -12071,7 +12091,7 @@
                 </a:solidFill>
                 <a:latin typeface="Calibri"/>
               </a:rPr>
-              <a:t>≤12% off list only if traded for scope, term ≥24 mo, or attach pack</a:t>
+              <a:t>≤12% only if traded for scope / term / attach — never free volume</a:t>
             </a:r>
           </a:p>
           <a:p>
@@ -12103,7 +12123,135 @@
                 </a:solidFill>
                 <a:latin typeface="Calibri"/>
               </a:rPr>
-              <a:t>If discount needed to keep/win revenue → must increase contracted value or commitment</a:t>
+              <a:t>Discount to win/keep revenue must raise contracted value</a:t>
+            </a:r>
+          </a:p>
+          <a:p>
+            <a:pPr algn="l">
+              <a:spcAft>
+                <a:spcPts val="100"/>
+              </a:spcAft>
+            </a:pPr>
+            <a:r>
+              <a:rPr sz="1100" b="1">
+                <a:solidFill>
+                  <a:srgbClr val="58A6FF"/>
+                </a:solidFill>
+                <a:latin typeface="Calibri"/>
+              </a:rPr>
+              <a:t>AI Deal Desk assist</a:t>
+            </a:r>
+          </a:p>
+          <a:p>
+            <a:pPr algn="l">
+              <a:spcAft>
+                <a:spcPts val="500"/>
+              </a:spcAft>
+            </a:pPr>
+            <a:r>
+              <a:rPr sz="1100" b="0">
+                <a:solidFill>
+                  <a:srgbClr val="E6EDF3"/>
+                </a:solidFill>
+                <a:latin typeface="Calibri"/>
+              </a:rPr>
+              <a:t>Comps + override flags · human approval mandatory</a:t>
+            </a:r>
+          </a:p>
+          <a:p>
+            <a:pPr algn="l">
+              <a:spcAft>
+                <a:spcPts val="100"/>
+              </a:spcAft>
+            </a:pPr>
+            <a:r>
+              <a:rPr sz="1100" b="1">
+                <a:solidFill>
+                  <a:srgbClr val="58A6FF"/>
+                </a:solidFill>
+                <a:latin typeface="Calibri"/>
+              </a:rPr>
+              <a:t>Transition pricing</a:t>
+            </a:r>
+          </a:p>
+          <a:p>
+            <a:pPr algn="l">
+              <a:spcAft>
+                <a:spcPts val="500"/>
+              </a:spcAft>
+            </a:pPr>
+            <a:r>
+              <a:rPr sz="1100" b="0">
+                <a:solidFill>
+                  <a:srgbClr val="E6EDF3"/>
+                </a:solidFill>
+                <a:latin typeface="Calibri"/>
+              </a:rPr>
+              <a:t>Knowledge-transfer mandatory · min 8% Year-1 contract value</a:t>
+            </a:r>
+          </a:p>
+          <a:p>
+            <a:pPr algn="l">
+              <a:spcAft>
+                <a:spcPts val="100"/>
+              </a:spcAft>
+            </a:pPr>
+            <a:r>
+              <a:rPr sz="1100" b="1">
+                <a:solidFill>
+                  <a:srgbClr val="58A6FF"/>
+                </a:solidFill>
+                <a:latin typeface="Calibri"/>
+              </a:rPr>
+              <a:t>Scope / regional</a:t>
+            </a:r>
+          </a:p>
+          <a:p>
+            <a:pPr algn="l">
+              <a:spcAft>
+                <a:spcPts val="500"/>
+              </a:spcAft>
+            </a:pPr>
+            <a:r>
+              <a:rPr sz="1100" b="0">
+                <a:solidFill>
+                  <a:srgbClr val="E6EDF3"/>
+                </a:solidFill>
+                <a:latin typeface="Calibri"/>
+              </a:rPr>
+              <a:t>Unpaid work ≤2% ACV · like-for-like within ±15% rate card</a:t>
+            </a:r>
+          </a:p>
+          <a:p>
+            <a:pPr algn="l">
+              <a:spcAft>
+                <a:spcPts val="100"/>
+              </a:spcAft>
+            </a:pPr>
+            <a:r>
+              <a:rPr sz="1100" b="1">
+                <a:solidFill>
+                  <a:srgbClr val="58A6FF"/>
+                </a:solidFill>
+                <a:latin typeface="Calibri"/>
+              </a:rPr>
+              <a:t>Credits / penalties</a:t>
+            </a:r>
+          </a:p>
+          <a:p>
+            <a:pPr algn="l">
+              <a:spcAft>
+                <a:spcPts val="500"/>
+              </a:spcAft>
+            </a:pPr>
+            <a:r>
+              <a:rPr sz="1100" b="0">
+                <a:solidFill>
+                  <a:srgbClr val="E6EDF3"/>
+                </a:solidFill>
+                <a:latin typeface="Calibri"/>
+              </a:rPr>
+              <a:t>Soft-ramp M1–6 · Finance revenue-recognition OK</a:t>
             </a:r>
           </a:p>
           <a:p>
@@ -15345,7 +15493,7 @@
                 </a:solidFill>
                 <a:latin typeface="Calibri"/>
               </a:rPr>
-              <a:t>Reposition Application Managed Services as Outcome-Tiered Application Operations (Stabilize → Optimize → Transform). Do not sunset. Do not evolve tooling without fixing the sellable unit. Use discounts to sustain net sales only when traded for scope, term, or attach. Fund Deal Desk guardrails in Q1; pilot in two regions; govern with a quarterly Pricing Council.</a:t>
+              <a:t>Reposition Application Managed Services as Outcome-Tiered Application Operations (Stabilize → Optimize → Autonomize). Do not sunset. Do not evolve tooling without fixing the sellable unit. Use discounts to sustain net sales only when traded for scope, term, or attach. Fund Deal Desk guardrails in Q1; pilot in two regions; govern with a quarterly Pricing Council.</a:t>
             </a:r>
           </a:p>
         </p:txBody>

</xml_diff>